<commit_message>
Refine first page resume layout
Co-authored-by: yanatimofeeva2511 <yanatimofeeva2511@users.noreply.github.com>
</commit_message>
<xml_diff>
--- a/resume_clevel_fintech_ru_editable.pptx
+++ b/resume_clevel_fintech_ru_editable.pptx
@@ -129,7 +129,7 @@
               <a:buNone/>
             </a:pPr>
             <a:r>
-              <a:rPr lang="ru-RU" sz="2000" b="1">
+              <a:rPr lang="ru-RU" sz="2050" b="1">
                 <a:solidFill>
                   <a:srgbClr val="0F2742"/>
                 </a:solidFill>
@@ -138,7 +138,7 @@
               </a:rPr>
               <a:t>Яна Тимофеева</a:t>
             </a:r>
-            <a:endParaRPr lang="ru-RU" sz="2000"/>
+            <a:endParaRPr lang="ru-RU" sz="2050"/>
           </a:p>
         </p:txBody>
       </p:sp>
@@ -247,7 +247,7 @@
               <a:buNone/>
             </a:pPr>
             <a:r>
-              <a:rPr lang="ru-RU" sz="1040" b="1">
+              <a:rPr lang="ru-RU" sz="1030" b="1">
                 <a:solidFill>
                   <a:srgbClr val="173A5E"/>
                 </a:solidFill>
@@ -256,7 +256,7 @@
               </a:rPr>
               <a:t>C-level лидер | розничный банкинг, финтех и платежная инфраструктура</a:t>
             </a:r>
-            <a:endParaRPr lang="ru-RU" sz="1040"/>
+            <a:endParaRPr lang="ru-RU" sz="1030"/>
           </a:p>
           <a:p>
             <a:pPr>
@@ -284,7 +284,7 @@
         </p:nvSpPr>
         <p:spPr>
           <a:xfrm>
-            <a:off x="396000" y="1548000"/>
+            <a:off x="396000" y="1584000"/>
             <a:ext cx="6768000" cy="216000"/>
           </a:xfrm>
           <a:prstGeom prst="rect">
@@ -324,7 +324,7 @@
         </p:nvSpPr>
         <p:spPr>
           <a:xfrm>
-            <a:off x="396000" y="1800000"/>
+            <a:off x="396000" y="1836000"/>
             <a:ext cx="6768000" cy="9000"/>
           </a:xfrm>
           <a:prstGeom prst="rect">
@@ -346,7 +346,7 @@
         </p:nvSpPr>
         <p:spPr>
           <a:xfrm>
-            <a:off x="396000" y="1908000"/>
+            <a:off x="396000" y="1944000"/>
             <a:ext cx="6768000" cy="972000"/>
           </a:xfrm>
           <a:prstGeom prst="rect">
@@ -396,14 +396,168 @@
       </p:sp>
       <p:sp>
         <p:nvSpPr>
-          <p:cNvPr id="20" name="tag"/>
-          <p:cNvSpPr txBox="1"/>
-          <p:nvPr/>
-        </p:nvSpPr>
-        <p:spPr>
-          <a:xfrm>
-            <a:off x="396000" y="2952000"/>
-            <a:ext cx="684000" cy="226800"/>
+          <p:cNvPr id="40" name="focus title"/>
+          <p:cNvSpPr txBox="1"/>
+          <p:nvPr/>
+        </p:nvSpPr>
+        <p:spPr>
+          <a:xfrm>
+            <a:off x="396000" y="3132000"/>
+            <a:ext cx="4464000" cy="216000"/>
+          </a:xfrm>
+          <a:prstGeom prst="rect">
+            <a:avLst/>
+          </a:prstGeom>
+          <a:noFill/>
+          <a:ln>
+            <a:noFill/>
+          </a:ln>
+        </p:spPr>
+        <p:txBody>
+          <a:bodyPr wrap="square" lIns="0" tIns="0" rIns="0" bIns="0"/>
+          <a:lstStyle/>
+          <a:p>
+            <a:pPr>
+              <a:buNone/>
+            </a:pPr>
+            <a:r>
+              <a:rPr lang="ru-RU" sz="820" b="1">
+                <a:solidFill>
+                  <a:srgbClr val="0F2742"/>
+                </a:solidFill>
+                <a:latin typeface="Arial"/>
+                <a:cs typeface="Arial"/>
+              </a:rPr>
+              <a:t>УПРАВЛЕНЧЕСКИЙ ФОКУС</a:t>
+            </a:r>
+            <a:endParaRPr lang="ru-RU" sz="820"/>
+          </a:p>
+        </p:txBody>
+      </p:sp>
+      <p:sp>
+        <p:nvSpPr>
+          <p:cNvPr id="41" name="fu"/>
+          <p:cNvSpPr/>
+          <p:nvPr/>
+        </p:nvSpPr>
+        <p:spPr>
+          <a:xfrm>
+            <a:off x="396000" y="3384000"/>
+            <a:ext cx="4464000" cy="9000"/>
+          </a:xfrm>
+          <a:prstGeom prst="rect">
+            <a:avLst/>
+          </a:prstGeom>
+          <a:solidFill>
+            <a:srgbClr val="D7DEE8"/>
+          </a:solidFill>
+          <a:ln>
+            <a:noFill/>
+          </a:ln>
+        </p:spPr>
+      </p:sp>
+      <p:sp>
+        <p:nvSpPr>
+          <p:cNvPr id="50" name="BUILD - запуск самостоятельных бизнес-направлений"/>
+          <p:cNvSpPr txBox="1"/>
+          <p:nvPr/>
+        </p:nvSpPr>
+        <p:spPr>
+          <a:xfrm>
+            <a:off x="396000" y="3528000"/>
+            <a:ext cx="4464000" cy="1764000"/>
+          </a:xfrm>
+          <a:prstGeom prst="roundRect">
+            <a:avLst/>
+          </a:prstGeom>
+          <a:solidFill>
+            <a:srgbClr val="F8FAFC"/>
+          </a:solidFill>
+          <a:ln w="6350">
+            <a:solidFill>
+              <a:srgbClr val="D7DEE8"/>
+            </a:solidFill>
+          </a:ln>
+        </p:spPr>
+        <p:txBody>
+          <a:bodyPr wrap="square" lIns="18500" tIns="18500" rIns="18500" bIns="18500"/>
+          <a:lstStyle/>
+          <a:p>
+            <a:pPr>
+              <a:buNone/>
+            </a:pPr>
+            <a:r>
+              <a:rPr lang="ru-RU" sz="740" b="1">
+                <a:solidFill>
+                  <a:srgbClr val="173A5E"/>
+                </a:solidFill>
+                <a:latin typeface="Arial"/>
+                <a:cs typeface="Arial"/>
+              </a:rPr>
+              <a:t>BUILD - запуск самостоятельных бизнес-направлений</a:t>
+            </a:r>
+            <a:endParaRPr lang="ru-RU" sz="740"/>
+          </a:p>
+          <a:p>
+            <a:pPr marL="155000" indent="-80000">
+              <a:buChar char="•"/>
+            </a:pPr>
+            <a:r>
+              <a:rPr lang="ru-RU" sz="590">
+                <a:solidFill>
+                  <a:srgbClr val="1F2933"/>
+                </a:solidFill>
+                <a:latin typeface="Arial"/>
+                <a:cs typeface="Arial"/>
+              </a:rPr>
+              <a:t>Определяю рынок, сегменты, бизнес-модель, стратегию, инвестиционную логику и окупаемость.</a:t>
+            </a:r>
+            <a:endParaRPr lang="ru-RU" sz="590"/>
+          </a:p>
+          <a:p>
+            <a:pPr marL="155000" indent="-80000">
+              <a:buChar char="•"/>
+            </a:pPr>
+            <a:r>
+              <a:rPr lang="ru-RU" sz="590">
+                <a:solidFill>
+                  <a:srgbClr val="1F2933"/>
+                </a:solidFill>
+                <a:latin typeface="Arial"/>
+                <a:cs typeface="Arial"/>
+              </a:rPr>
+              <a:t>Формирую продуктовый ряд и клиентское предложение; развиваю каналы продаж, партнерства и дистрибуцию.</a:t>
+            </a:r>
+            <a:endParaRPr lang="ru-RU" sz="590"/>
+          </a:p>
+          <a:p>
+            <a:pPr marL="155000" indent="-80000">
+              <a:buChar char="•"/>
+            </a:pPr>
+            <a:r>
+              <a:rPr lang="ru-RU" sz="590">
+                <a:solidFill>
+                  <a:srgbClr val="1F2933"/>
+                </a:solidFill>
+                <a:latin typeface="Arial"/>
+                <a:cs typeface="Arial"/>
+              </a:rPr>
+              <a:t>Собираю кросс-функциональную реализацию с бизнесом, продажами, маркетингом, продуктом, операциями и IT.</a:t>
+            </a:r>
+            <a:endParaRPr lang="ru-RU" sz="590"/>
+          </a:p>
+        </p:txBody>
+      </p:sp>
+      <p:sp>
+        <p:nvSpPr>
+          <p:cNvPr id="200" name="tag"/>
+          <p:cNvSpPr txBox="1"/>
+          <p:nvPr/>
+        </p:nvSpPr>
+        <p:spPr>
+          <a:xfrm>
+            <a:off x="504000" y="4752000"/>
+            <a:ext cx="936000" cy="205200"/>
           </a:xfrm>
           <a:prstGeom prst="roundRect">
             <a:avLst/>
@@ -418,36 +572,36 @@
           </a:ln>
         </p:spPr>
         <p:txBody>
-          <a:bodyPr wrap="square" lIns="18000" tIns="18000" rIns="18000" bIns="18000"/>
-          <a:lstStyle/>
-          <a:p>
-            <a:pPr>
-              <a:buNone/>
-            </a:pPr>
-            <a:r>
-              <a:rPr lang="ru-RU" sz="650" b="1">
+          <a:bodyPr wrap="square" lIns="14000" tIns="14000" rIns="14000" bIns="14000"/>
+          <a:lstStyle/>
+          <a:p>
+            <a:pPr>
+              <a:buNone/>
+            </a:pPr>
+            <a:r>
+              <a:rPr lang="ru-RU" sz="560" b="1">
                 <a:solidFill>
                   <a:srgbClr val="0F4778"/>
                 </a:solidFill>
                 <a:latin typeface="Arial"/>
                 <a:cs typeface="Arial"/>
               </a:rPr>
-              <a:t>20+ лет</a:t>
-            </a:r>
-            <a:endParaRPr lang="ru-RU" sz="650"/>
-          </a:p>
-        </p:txBody>
-      </p:sp>
-      <p:sp>
-        <p:nvSpPr>
-          <p:cNvPr id="21" name="tag"/>
-          <p:cNvSpPr txBox="1"/>
-          <p:nvPr/>
-        </p:nvSpPr>
-        <p:spPr>
-          <a:xfrm>
-            <a:off x="1152000" y="2952000"/>
-            <a:ext cx="1044000" cy="226800"/>
+              <a:t>АКБ +11% до 2,1 млн</a:t>
+            </a:r>
+            <a:endParaRPr lang="ru-RU" sz="560"/>
+          </a:p>
+        </p:txBody>
+      </p:sp>
+      <p:sp>
+        <p:nvSpPr>
+          <p:cNvPr id="201" name="tag"/>
+          <p:cNvSpPr txBox="1"/>
+          <p:nvPr/>
+        </p:nvSpPr>
+        <p:spPr>
+          <a:xfrm>
+            <a:off x="1512000" y="4752000"/>
+            <a:ext cx="720000" cy="205200"/>
           </a:xfrm>
           <a:prstGeom prst="roundRect">
             <a:avLst/>
@@ -462,36 +616,36 @@
           </a:ln>
         </p:spPr>
         <p:txBody>
-          <a:bodyPr wrap="square" lIns="18000" tIns="18000" rIns="18000" bIns="18000"/>
-          <a:lstStyle/>
-          <a:p>
-            <a:pPr>
-              <a:buNone/>
-            </a:pPr>
-            <a:r>
-              <a:rPr lang="ru-RU" sz="650" b="1">
+          <a:bodyPr wrap="square" lIns="14000" tIns="14000" rIns="14000" bIns="14000"/>
+          <a:lstStyle/>
+          <a:p>
+            <a:pPr>
+              <a:buNone/>
+            </a:pPr>
+            <a:r>
+              <a:rPr lang="ru-RU" sz="560" b="1">
                 <a:solidFill>
                   <a:srgbClr val="0F4778"/>
                 </a:solidFill>
                 <a:latin typeface="Arial"/>
                 <a:cs typeface="Arial"/>
               </a:rPr>
-              <a:t>25 млн клиентов</a:t>
-            </a:r>
-            <a:endParaRPr lang="ru-RU" sz="650"/>
-          </a:p>
-        </p:txBody>
-      </p:sp>
-      <p:sp>
-        <p:nvSpPr>
-          <p:cNvPr id="22" name="tag"/>
-          <p:cNvSpPr txBox="1"/>
-          <p:nvPr/>
-        </p:nvSpPr>
-        <p:spPr>
-          <a:xfrm>
-            <a:off x="2268000" y="2952000"/>
-            <a:ext cx="1224000" cy="226800"/>
+              <a:t>AUM +35%</a:t>
+            </a:r>
+            <a:endParaRPr lang="ru-RU" sz="560"/>
+          </a:p>
+        </p:txBody>
+      </p:sp>
+      <p:sp>
+        <p:nvSpPr>
+          <p:cNvPr id="202" name="tag"/>
+          <p:cNvSpPr txBox="1"/>
+          <p:nvPr/>
+        </p:nvSpPr>
+        <p:spPr>
+          <a:xfrm>
+            <a:off x="2304000" y="4752000"/>
+            <a:ext cx="792000" cy="205200"/>
           </a:xfrm>
           <a:prstGeom prst="roundRect">
             <a:avLst/>
@@ -506,36 +660,36 @@
           </a:ln>
         </p:spPr>
         <p:txBody>
-          <a:bodyPr wrap="square" lIns="18000" tIns="18000" rIns="18000" bIns="18000"/>
-          <a:lstStyle/>
-          <a:p>
-            <a:pPr>
-              <a:buNone/>
-            </a:pPr>
-            <a:r>
-              <a:rPr lang="ru-RU" sz="650" b="1">
+          <a:bodyPr wrap="square" lIns="14000" tIns="14000" rIns="14000" bIns="14000"/>
+          <a:lstStyle/>
+          <a:p>
+            <a:pPr>
+              <a:buNone/>
+            </a:pPr>
+            <a:r>
+              <a:rPr lang="ru-RU" sz="560" b="1">
                 <a:solidFill>
                   <a:srgbClr val="0F4778"/>
                 </a:solidFill>
                 <a:latin typeface="Arial"/>
                 <a:cs typeface="Arial"/>
               </a:rPr>
-              <a:t>20 млн без простоя</a:t>
-            </a:r>
-            <a:endParaRPr lang="ru-RU" sz="650"/>
-          </a:p>
-        </p:txBody>
-      </p:sp>
-      <p:sp>
-        <p:nvSpPr>
-          <p:cNvPr id="23" name="tag"/>
-          <p:cNvSpPr txBox="1"/>
-          <p:nvPr/>
-        </p:nvSpPr>
-        <p:spPr>
-          <a:xfrm>
-            <a:off x="3564000" y="2952000"/>
-            <a:ext cx="1368000" cy="226800"/>
+              <a:t>отток - в 3 раза</a:t>
+            </a:r>
+            <a:endParaRPr lang="ru-RU" sz="560"/>
+          </a:p>
+        </p:txBody>
+      </p:sp>
+      <p:sp>
+        <p:nvSpPr>
+          <p:cNvPr id="203" name="tag"/>
+          <p:cNvSpPr txBox="1"/>
+          <p:nvPr/>
+        </p:nvSpPr>
+        <p:spPr>
+          <a:xfrm>
+            <a:off x="3168000" y="4752000"/>
+            <a:ext cx="612000" cy="205200"/>
           </a:xfrm>
           <a:prstGeom prst="roundRect">
             <a:avLst/>
@@ -550,36 +704,36 @@
           </a:ln>
         </p:spPr>
         <p:txBody>
-          <a:bodyPr wrap="square" lIns="18000" tIns="18000" rIns="18000" bIns="18000"/>
-          <a:lstStyle/>
-          <a:p>
-            <a:pPr>
-              <a:buNone/>
-            </a:pPr>
-            <a:r>
-              <a:rPr lang="ru-RU" sz="650" b="1">
+          <a:bodyPr wrap="square" lIns="14000" tIns="14000" rIns="14000" bIns="14000"/>
+          <a:lstStyle/>
+          <a:p>
+            <a:pPr>
+              <a:buNone/>
+            </a:pPr>
+            <a:r>
+              <a:rPr lang="ru-RU" sz="560" b="1">
                 <a:solidFill>
                   <a:srgbClr val="0F4778"/>
                 </a:solidFill>
                 <a:latin typeface="Arial"/>
                 <a:cs typeface="Arial"/>
               </a:rPr>
-              <a:t>2 млн фед. проект</a:t>
-            </a:r>
-            <a:endParaRPr lang="ru-RU" sz="650"/>
-          </a:p>
-        </p:txBody>
-      </p:sp>
-      <p:sp>
-        <p:nvSpPr>
-          <p:cNvPr id="24" name="tag"/>
-          <p:cNvSpPr txBox="1"/>
-          <p:nvPr/>
-        </p:nvSpPr>
-        <p:spPr>
-          <a:xfrm>
-            <a:off x="5004000" y="2952000"/>
-            <a:ext cx="1188000" cy="226800"/>
+              <a:t>N5 +3 п.п.</a:t>
+            </a:r>
+            <a:endParaRPr lang="ru-RU" sz="560"/>
+          </a:p>
+        </p:txBody>
+      </p:sp>
+      <p:sp>
+        <p:nvSpPr>
+          <p:cNvPr id="204" name="tag"/>
+          <p:cNvSpPr txBox="1"/>
+          <p:nvPr/>
+        </p:nvSpPr>
+        <p:spPr>
+          <a:xfrm>
+            <a:off x="504000" y="4982400"/>
+            <a:ext cx="936000" cy="205200"/>
           </a:xfrm>
           <a:prstGeom prst="roundRect">
             <a:avLst/>
@@ -594,36 +748,36 @@
           </a:ln>
         </p:spPr>
         <p:txBody>
-          <a:bodyPr wrap="square" lIns="18000" tIns="18000" rIns="18000" bIns="18000"/>
-          <a:lstStyle/>
-          <a:p>
-            <a:pPr>
-              <a:buNone/>
-            </a:pPr>
-            <a:r>
-              <a:rPr lang="ru-RU" sz="650" b="1">
+          <a:bodyPr wrap="square" lIns="14000" tIns="14000" rIns="14000" bIns="14000"/>
+          <a:lstStyle/>
+          <a:p>
+            <a:pPr>
+              <a:buNone/>
+            </a:pPr>
+            <a:r>
+              <a:rPr lang="ru-RU" sz="560" b="1">
                 <a:solidFill>
                   <a:srgbClr val="0F4778"/>
                 </a:solidFill>
                 <a:latin typeface="Arial"/>
                 <a:cs typeface="Arial"/>
               </a:rPr>
-              <a:t>170 чел. / 12 команд</a:t>
-            </a:r>
-            <a:endParaRPr lang="ru-RU" sz="650"/>
-          </a:p>
-        </p:txBody>
-      </p:sp>
-      <p:sp>
-        <p:nvSpPr>
-          <p:cNvPr id="25" name="tag"/>
-          <p:cNvSpPr txBox="1"/>
-          <p:nvPr/>
-        </p:nvSpPr>
-        <p:spPr>
-          <a:xfrm>
-            <a:off x="396000" y="3240000"/>
-            <a:ext cx="1080000" cy="226800"/>
+              <a:t>N1 автокредиты</a:t>
+            </a:r>
+            <a:endParaRPr lang="ru-RU" sz="560"/>
+          </a:p>
+        </p:txBody>
+      </p:sp>
+      <p:sp>
+        <p:nvSpPr>
+          <p:cNvPr id="205" name="tag"/>
+          <p:cNvSpPr txBox="1"/>
+          <p:nvPr/>
+        </p:nvSpPr>
+        <p:spPr>
+          <a:xfrm>
+            <a:off x="1512000" y="4982400"/>
+            <a:ext cx="540000" cy="205200"/>
           </a:xfrm>
           <a:prstGeom prst="roundRect">
             <a:avLst/>
@@ -638,36 +792,128 @@
           </a:ln>
         </p:spPr>
         <p:txBody>
-          <a:bodyPr wrap="square" lIns="18000" tIns="18000" rIns="18000" bIns="18000"/>
-          <a:lstStyle/>
-          <a:p>
-            <a:pPr>
-              <a:buNone/>
-            </a:pPr>
-            <a:r>
-              <a:rPr lang="ru-RU" sz="650" b="1">
+          <a:bodyPr wrap="square" lIns="14000" tIns="14000" rIns="14000" bIns="14000"/>
+          <a:lstStyle/>
+          <a:p>
+            <a:pPr>
+              <a:buNone/>
+            </a:pPr>
+            <a:r>
+              <a:rPr lang="ru-RU" sz="560" b="1">
                 <a:solidFill>
                   <a:srgbClr val="0F4778"/>
                 </a:solidFill>
                 <a:latin typeface="Arial"/>
                 <a:cs typeface="Arial"/>
               </a:rPr>
-              <a:t>600+ точек продаж</a:t>
-            </a:r>
-            <a:endParaRPr lang="ru-RU" sz="650"/>
-          </a:p>
-        </p:txBody>
-      </p:sp>
-      <p:sp>
-        <p:nvSpPr>
-          <p:cNvPr id="26" name="tag"/>
-          <p:cNvSpPr txBox="1"/>
-          <p:nvPr/>
-        </p:nvSpPr>
-        <p:spPr>
-          <a:xfrm>
-            <a:off x="1548000" y="3240000"/>
-            <a:ext cx="900000" cy="226800"/>
+              <a:t>88% NTB</a:t>
+            </a:r>
+            <a:endParaRPr lang="ru-RU" sz="560"/>
+          </a:p>
+        </p:txBody>
+      </p:sp>
+      <p:sp>
+        <p:nvSpPr>
+          <p:cNvPr id="51" name="TRANSFORM - корректировка модели"/>
+          <p:cNvSpPr txBox="1"/>
+          <p:nvPr/>
+        </p:nvSpPr>
+        <p:spPr>
+          <a:xfrm>
+            <a:off x="396000" y="5472000"/>
+            <a:ext cx="4464000" cy="1764000"/>
+          </a:xfrm>
+          <a:prstGeom prst="roundRect">
+            <a:avLst/>
+          </a:prstGeom>
+          <a:solidFill>
+            <a:srgbClr val="F8FAFC"/>
+          </a:solidFill>
+          <a:ln w="6350">
+            <a:solidFill>
+              <a:srgbClr val="D7DEE8"/>
+            </a:solidFill>
+          </a:ln>
+        </p:spPr>
+        <p:txBody>
+          <a:bodyPr wrap="square" lIns="18500" tIns="18500" rIns="18500" bIns="18500"/>
+          <a:lstStyle/>
+          <a:p>
+            <a:pPr>
+              <a:buNone/>
+            </a:pPr>
+            <a:r>
+              <a:rPr lang="ru-RU" sz="740" b="1">
+                <a:solidFill>
+                  <a:srgbClr val="173A5E"/>
+                </a:solidFill>
+                <a:latin typeface="Arial"/>
+                <a:cs typeface="Arial"/>
+              </a:rPr>
+              <a:t>TRANSFORM - корректировка модели</a:t>
+            </a:r>
+            <a:endParaRPr lang="ru-RU" sz="740"/>
+          </a:p>
+          <a:p>
+            <a:pPr marL="155000" indent="-80000">
+              <a:buChar char="•"/>
+            </a:pPr>
+            <a:r>
+              <a:rPr lang="ru-RU" sz="590">
+                <a:solidFill>
+                  <a:srgbClr val="1F2933"/>
+                </a:solidFill>
+                <a:latin typeface="Arial"/>
+                <a:cs typeface="Arial"/>
+              </a:rPr>
+              <a:t>Диагностирую модель бизнеса и определяю изменения под новые цели роста и доходности.</a:t>
+            </a:r>
+            <a:endParaRPr lang="ru-RU" sz="590"/>
+          </a:p>
+          <a:p>
+            <a:pPr marL="155000" indent="-80000">
+              <a:buChar char="•"/>
+            </a:pPr>
+            <a:r>
+              <a:rPr lang="ru-RU" sz="590">
+                <a:solidFill>
+                  <a:srgbClr val="1F2933"/>
+                </a:solidFill>
+                <a:latin typeface="Arial"/>
+                <a:cs typeface="Arial"/>
+              </a:rPr>
+              <a:t>Пересобираю стратегию, экономику привлечения, источники финансирования, продуктовые приоритеты и операционную модель.</a:t>
+            </a:r>
+            <a:endParaRPr lang="ru-RU" sz="590"/>
+          </a:p>
+          <a:p>
+            <a:pPr marL="155000" indent="-80000">
+              <a:buChar char="•"/>
+            </a:pPr>
+            <a:r>
+              <a:rPr lang="ru-RU" sz="590">
+                <a:solidFill>
+                  <a:srgbClr val="1F2933"/>
+                </a:solidFill>
+                <a:latin typeface="Arial"/>
+                <a:cs typeface="Arial"/>
+              </a:rPr>
+              <a:t>Провожу изменения в работающем контуре банка: продукт, процессы, технологии, оргструктура и клиентский опыт.</a:t>
+            </a:r>
+            <a:endParaRPr lang="ru-RU" sz="590"/>
+          </a:p>
+        </p:txBody>
+      </p:sp>
+      <p:sp>
+        <p:nvSpPr>
+          <p:cNvPr id="206" name="tag"/>
+          <p:cNvSpPr txBox="1"/>
+          <p:nvPr/>
+        </p:nvSpPr>
+        <p:spPr>
+          <a:xfrm>
+            <a:off x="504000" y="6696000"/>
+            <a:ext cx="828000" cy="205200"/>
           </a:xfrm>
           <a:prstGeom prst="roundRect">
             <a:avLst/>
@@ -682,36 +928,36 @@
           </a:ln>
         </p:spPr>
         <p:txBody>
-          <a:bodyPr wrap="square" lIns="18000" tIns="18000" rIns="18000" bIns="18000"/>
-          <a:lstStyle/>
-          <a:p>
-            <a:pPr>
-              <a:buNone/>
-            </a:pPr>
-            <a:r>
-              <a:rPr lang="ru-RU" sz="650" b="1">
+          <a:bodyPr wrap="square" lIns="14000" tIns="14000" rIns="14000" bIns="14000"/>
+          <a:lstStyle/>
+          <a:p>
+            <a:pPr>
+              <a:buNone/>
+            </a:pPr>
+            <a:r>
+              <a:rPr lang="ru-RU" sz="560" b="1">
                 <a:solidFill>
                   <a:srgbClr val="0F4778"/>
                 </a:solidFill>
                 <a:latin typeface="Arial"/>
                 <a:cs typeface="Arial"/>
               </a:rPr>
-              <a:t>70 млрд руб.</a:t>
-            </a:r>
-            <a:endParaRPr lang="ru-RU" sz="650"/>
-          </a:p>
-        </p:txBody>
-      </p:sp>
-      <p:sp>
-        <p:nvSpPr>
-          <p:cNvPr id="27" name="tag"/>
-          <p:cNvSpPr txBox="1"/>
-          <p:nvPr/>
-        </p:nvSpPr>
-        <p:spPr>
-          <a:xfrm>
-            <a:off x="2520000" y="3240000"/>
-            <a:ext cx="720000" cy="226800"/>
+              <a:t>25 млн клиентов</a:t>
+            </a:r>
+            <a:endParaRPr lang="ru-RU" sz="560"/>
+          </a:p>
+        </p:txBody>
+      </p:sp>
+      <p:sp>
+        <p:nvSpPr>
+          <p:cNvPr id="207" name="tag"/>
+          <p:cNvSpPr txBox="1"/>
+          <p:nvPr/>
+        </p:nvSpPr>
+        <p:spPr>
+          <a:xfrm>
+            <a:off x="1404000" y="6696000"/>
+            <a:ext cx="756000" cy="205200"/>
           </a:xfrm>
           <a:prstGeom prst="roundRect">
             <a:avLst/>
@@ -726,36 +972,36 @@
           </a:ln>
         </p:spPr>
         <p:txBody>
-          <a:bodyPr wrap="square" lIns="18000" tIns="18000" rIns="18000" bIns="18000"/>
-          <a:lstStyle/>
-          <a:p>
-            <a:pPr>
-              <a:buNone/>
-            </a:pPr>
-            <a:r>
-              <a:rPr lang="ru-RU" sz="650" b="1">
+          <a:bodyPr wrap="square" lIns="14000" tIns="14000" rIns="14000" bIns="14000"/>
+          <a:lstStyle/>
+          <a:p>
+            <a:pPr>
+              <a:buNone/>
+            </a:pPr>
+            <a:r>
+              <a:rPr lang="ru-RU" sz="560" b="1">
                 <a:solidFill>
                   <a:srgbClr val="0F4778"/>
                 </a:solidFill>
                 <a:latin typeface="Arial"/>
                 <a:cs typeface="Arial"/>
               </a:rPr>
-              <a:t>AUM +35%</a:t>
-            </a:r>
-            <a:endParaRPr lang="ru-RU" sz="650"/>
-          </a:p>
-        </p:txBody>
-      </p:sp>
-      <p:sp>
-        <p:nvSpPr>
-          <p:cNvPr id="28" name="tag"/>
-          <p:cNvSpPr txBox="1"/>
-          <p:nvPr/>
-        </p:nvSpPr>
-        <p:spPr>
-          <a:xfrm>
-            <a:off x="3312000" y="3240000"/>
-            <a:ext cx="648000" cy="226800"/>
+              <a:t>+25% YoY</a:t>
+            </a:r>
+            <a:endParaRPr lang="ru-RU" sz="560"/>
+          </a:p>
+        </p:txBody>
+      </p:sp>
+      <p:sp>
+        <p:nvSpPr>
+          <p:cNvPr id="208" name="tag"/>
+          <p:cNvSpPr txBox="1"/>
+          <p:nvPr/>
+        </p:nvSpPr>
+        <p:spPr>
+          <a:xfrm>
+            <a:off x="2232000" y="6696000"/>
+            <a:ext cx="612000" cy="205200"/>
           </a:xfrm>
           <a:prstGeom prst="roundRect">
             <a:avLst/>
@@ -770,36 +1016,36 @@
           </a:ln>
         </p:spPr>
         <p:txBody>
-          <a:bodyPr wrap="square" lIns="18000" tIns="18000" rIns="18000" bIns="18000"/>
-          <a:lstStyle/>
-          <a:p>
-            <a:pPr>
-              <a:buNone/>
-            </a:pPr>
-            <a:r>
-              <a:rPr lang="ru-RU" sz="650" b="1">
+          <a:bodyPr wrap="square" lIns="14000" tIns="14000" rIns="14000" bIns="14000"/>
+          <a:lstStyle/>
+          <a:p>
+            <a:pPr>
+              <a:buNone/>
+            </a:pPr>
+            <a:r>
+              <a:rPr lang="ru-RU" sz="560" b="1">
                 <a:solidFill>
                   <a:srgbClr val="0F4778"/>
                 </a:solidFill>
                 <a:latin typeface="Arial"/>
                 <a:cs typeface="Arial"/>
               </a:rPr>
-              <a:t>88% NTB</a:t>
-            </a:r>
-            <a:endParaRPr lang="ru-RU" sz="650"/>
-          </a:p>
-        </p:txBody>
-      </p:sp>
-      <p:sp>
-        <p:nvSpPr>
-          <p:cNvPr id="29" name="tag"/>
-          <p:cNvSpPr txBox="1"/>
-          <p:nvPr/>
-        </p:nvSpPr>
-        <p:spPr>
-          <a:xfrm>
-            <a:off x="4032000" y="3240000"/>
-            <a:ext cx="828000" cy="226800"/>
+              <a:t>N2 по АКБ</a:t>
+            </a:r>
+            <a:endParaRPr lang="ru-RU" sz="560"/>
+          </a:p>
+        </p:txBody>
+      </p:sp>
+      <p:sp>
+        <p:nvSpPr>
+          <p:cNvPr id="209" name="tag"/>
+          <p:cNvSpPr txBox="1"/>
+          <p:nvPr/>
+        </p:nvSpPr>
+        <p:spPr>
+          <a:xfrm>
+            <a:off x="2916000" y="6696000"/>
+            <a:ext cx="1224000" cy="205200"/>
           </a:xfrm>
           <a:prstGeom prst="roundRect">
             <a:avLst/>
@@ -814,98 +1060,80 @@
           </a:ln>
         </p:spPr>
         <p:txBody>
-          <a:bodyPr wrap="square" lIns="18000" tIns="18000" rIns="18000" bIns="18000"/>
-          <a:lstStyle/>
-          <a:p>
-            <a:pPr>
-              <a:buNone/>
-            </a:pPr>
-            <a:r>
-              <a:rPr lang="ru-RU" sz="650" b="1">
+          <a:bodyPr wrap="square" lIns="14000" tIns="14000" rIns="14000" bIns="14000"/>
+          <a:lstStyle/>
+          <a:p>
+            <a:pPr>
+              <a:buNone/>
+            </a:pPr>
+            <a:r>
+              <a:rPr lang="ru-RU" sz="560" b="1">
                 <a:solidFill>
                   <a:srgbClr val="0F4778"/>
                 </a:solidFill>
                 <a:latin typeface="Arial"/>
                 <a:cs typeface="Arial"/>
               </a:rPr>
-              <a:t>английский C2</a:t>
-            </a:r>
-            <a:endParaRPr lang="ru-RU" sz="650"/>
-          </a:p>
-        </p:txBody>
-      </p:sp>
-      <p:sp>
-        <p:nvSpPr>
-          <p:cNvPr id="40" name="focus title"/>
-          <p:cNvSpPr txBox="1"/>
-          <p:nvPr/>
-        </p:nvSpPr>
-        <p:spPr>
-          <a:xfrm>
-            <a:off x="396000" y="3708000"/>
-            <a:ext cx="4428000" cy="216000"/>
-          </a:xfrm>
-          <a:prstGeom prst="rect">
-            <a:avLst/>
-          </a:prstGeom>
-          <a:noFill/>
-          <a:ln>
-            <a:noFill/>
-          </a:ln>
-        </p:spPr>
-        <p:txBody>
-          <a:bodyPr wrap="square" lIns="0" tIns="0" rIns="0" bIns="0"/>
-          <a:lstStyle/>
-          <a:p>
-            <a:pPr>
-              <a:buNone/>
-            </a:pPr>
-            <a:r>
-              <a:rPr lang="ru-RU" sz="820" b="1">
-                <a:solidFill>
-                  <a:srgbClr val="0F2742"/>
-                </a:solidFill>
-                <a:latin typeface="Arial"/>
-                <a:cs typeface="Arial"/>
-              </a:rPr>
-              <a:t>УПРАВЛЕНЧЕСКИЙ ФОКУС</a:t>
-            </a:r>
-            <a:endParaRPr lang="ru-RU" sz="820"/>
-          </a:p>
-        </p:txBody>
-      </p:sp>
-      <p:sp>
-        <p:nvSpPr>
-          <p:cNvPr id="41" name="fu"/>
-          <p:cNvSpPr/>
-          <p:nvPr/>
-        </p:nvSpPr>
-        <p:spPr>
-          <a:xfrm>
-            <a:off x="396000" y="3960000"/>
-            <a:ext cx="4428000" cy="9000"/>
-          </a:xfrm>
-          <a:prstGeom prst="rect">
-            <a:avLst/>
-          </a:prstGeom>
-          <a:solidFill>
-            <a:srgbClr val="D7DEE8"/>
-          </a:solidFill>
-          <a:ln>
-            <a:noFill/>
-          </a:ln>
-        </p:spPr>
-      </p:sp>
-      <p:sp>
-        <p:nvSpPr>
-          <p:cNvPr id="50" name="BUILD - запуск бизнес-направлений"/>
-          <p:cNvSpPr txBox="1"/>
-          <p:nvPr/>
-        </p:nvSpPr>
-        <p:spPr>
-          <a:xfrm>
-            <a:off x="396000" y="4104000"/>
-            <a:ext cx="4428000" cy="1440000"/>
+              <a:t>масштабная IT-трансформация</a:t>
+            </a:r>
+            <a:endParaRPr lang="ru-RU" sz="560"/>
+          </a:p>
+        </p:txBody>
+      </p:sp>
+      <p:sp>
+        <p:nvSpPr>
+          <p:cNvPr id="210" name="tag"/>
+          <p:cNvSpPr txBox="1"/>
+          <p:nvPr/>
+        </p:nvSpPr>
+        <p:spPr>
+          <a:xfrm>
+            <a:off x="504000" y="6926400"/>
+            <a:ext cx="1008000" cy="205200"/>
+          </a:xfrm>
+          <a:prstGeom prst="roundRect">
+            <a:avLst/>
+          </a:prstGeom>
+          <a:solidFill>
+            <a:srgbClr val="E8F1FB"/>
+          </a:solidFill>
+          <a:ln w="6350">
+            <a:solidFill>
+              <a:srgbClr val="E8F1FB"/>
+            </a:solidFill>
+          </a:ln>
+        </p:spPr>
+        <p:txBody>
+          <a:bodyPr wrap="square" lIns="14000" tIns="14000" rIns="14000" bIns="14000"/>
+          <a:lstStyle/>
+          <a:p>
+            <a:pPr>
+              <a:buNone/>
+            </a:pPr>
+            <a:r>
+              <a:rPr lang="ru-RU" sz="560" b="1">
+                <a:solidFill>
+                  <a:srgbClr val="0F4778"/>
+                </a:solidFill>
+                <a:latin typeface="Arial"/>
+                <a:cs typeface="Arial"/>
+              </a:rPr>
+              <a:t>P&amp;L / CIR / pNPS</a:t>
+            </a:r>
+            <a:endParaRPr lang="ru-RU" sz="560"/>
+          </a:p>
+        </p:txBody>
+      </p:sp>
+      <p:sp>
+        <p:nvSpPr>
+          <p:cNvPr id="52" name="LEAD - сложные программы"/>
+          <p:cNvSpPr txBox="1"/>
+          <p:nvPr/>
+        </p:nvSpPr>
+        <p:spPr>
+          <a:xfrm>
+            <a:off x="396000" y="7416000"/>
+            <a:ext cx="4464000" cy="1764000"/>
           </a:xfrm>
           <a:prstGeom prst="roundRect">
             <a:avLst/>
@@ -920,255 +1148,291 @@
           </a:ln>
         </p:spPr>
         <p:txBody>
-          <a:bodyPr wrap="square" lIns="21000" tIns="21000" rIns="21000" bIns="21000"/>
-          <a:lstStyle/>
-          <a:p>
-            <a:pPr>
-              <a:buNone/>
-            </a:pPr>
-            <a:r>
-              <a:rPr lang="ru-RU" sz="750" b="1">
+          <a:bodyPr wrap="square" lIns="18500" tIns="18500" rIns="18500" bIns="18500"/>
+          <a:lstStyle/>
+          <a:p>
+            <a:pPr>
+              <a:buNone/>
+            </a:pPr>
+            <a:r>
+              <a:rPr lang="ru-RU" sz="740" b="1">
                 <a:solidFill>
                   <a:srgbClr val="173A5E"/>
                 </a:solidFill>
                 <a:latin typeface="Arial"/>
                 <a:cs typeface="Arial"/>
               </a:rPr>
-              <a:t>BUILD - запуск бизнес-направлений</a:t>
-            </a:r>
-            <a:endParaRPr lang="ru-RU" sz="750"/>
-          </a:p>
-          <a:p>
-            <a:pPr marL="165000" indent="-85000">
+              <a:t>LEAD - сложные программы</a:t>
+            </a:r>
+            <a:endParaRPr lang="ru-RU" sz="740"/>
+          </a:p>
+          <a:p>
+            <a:pPr marL="155000" indent="-80000">
               <a:buChar char="•"/>
             </a:pPr>
             <a:r>
-              <a:rPr lang="ru-RU" sz="620">
+              <a:rPr lang="ru-RU" sz="590">
                 <a:solidFill>
                   <a:srgbClr val="1F2933"/>
                 </a:solidFill>
                 <a:latin typeface="Arial"/>
                 <a:cs typeface="Arial"/>
               </a:rPr>
-              <a:t>Определяю рынок, сегменты, бизнес-модель, стратегию, инвестиционную логику и окупаемость.</a:t>
-            </a:r>
-            <a:endParaRPr lang="ru-RU" sz="620"/>
-          </a:p>
-          <a:p>
-            <a:pPr marL="165000" indent="-85000">
+              <a:t>Формирую концепт, систему принятия решений и общие цели для бизнеса, IT, операций, продаж, маркетинга, регулятора и партнеров.</a:t>
+            </a:r>
+            <a:endParaRPr lang="ru-RU" sz="590"/>
+          </a:p>
+          <a:p>
+            <a:pPr marL="155000" indent="-80000">
               <a:buChar char="•"/>
             </a:pPr>
             <a:r>
-              <a:rPr lang="ru-RU" sz="620">
+              <a:rPr lang="ru-RU" sz="590">
                 <a:solidFill>
                   <a:srgbClr val="1F2933"/>
                 </a:solidFill>
                 <a:latin typeface="Arial"/>
                 <a:cs typeface="Arial"/>
               </a:rPr>
-              <a:t>Формирую продуктовый ряд и клиентское предложение; развиваю каналы продаж, партнерства и дистрибуцию.</a:t>
-            </a:r>
-            <a:endParaRPr lang="ru-RU" sz="620"/>
-          </a:p>
-          <a:p>
-            <a:pPr marL="165000" indent="-85000">
+              <a:t>Организую Agile-команды и крупные delivery-программы; удерживаю результат в условиях высокой сложности.</a:t>
+            </a:r>
+            <a:endParaRPr lang="ru-RU" sz="590"/>
+          </a:p>
+          <a:p>
+            <a:pPr marL="155000" indent="-80000">
               <a:buChar char="•"/>
             </a:pPr>
             <a:r>
-              <a:rPr lang="ru-RU" sz="620">
+              <a:rPr lang="ru-RU" sz="590">
                 <a:solidFill>
                   <a:srgbClr val="1F2933"/>
                 </a:solidFill>
                 <a:latin typeface="Arial"/>
                 <a:cs typeface="Arial"/>
               </a:rPr>
-              <a:t>Собираю кросс-функциональную реализацию с бизнесом, продажами, маркетингом, продуктом, операциями и IT.</a:t>
-            </a:r>
-            <a:endParaRPr lang="ru-RU" sz="620"/>
-          </a:p>
-        </p:txBody>
-      </p:sp>
-      <p:sp>
-        <p:nvSpPr>
-          <p:cNvPr id="51" name="TRANSFORM - корректировка модели"/>
-          <p:cNvSpPr txBox="1"/>
-          <p:nvPr/>
-        </p:nvSpPr>
-        <p:spPr>
-          <a:xfrm>
-            <a:off x="396000" y="5688000"/>
-            <a:ext cx="4428000" cy="1440000"/>
+              <a:t>Обеспечиваю бесшовность критичных изменений для клиентов и операционного контура.</a:t>
+            </a:r>
+            <a:endParaRPr lang="ru-RU" sz="590"/>
+          </a:p>
+        </p:txBody>
+      </p:sp>
+      <p:sp>
+        <p:nvSpPr>
+          <p:cNvPr id="211" name="tag"/>
+          <p:cNvSpPr txBox="1"/>
+          <p:nvPr/>
+        </p:nvSpPr>
+        <p:spPr>
+          <a:xfrm>
+            <a:off x="504000" y="8640000"/>
+            <a:ext cx="1296000" cy="205200"/>
           </a:xfrm>
           <a:prstGeom prst="roundRect">
             <a:avLst/>
           </a:prstGeom>
           <a:solidFill>
-            <a:srgbClr val="F8FAFC"/>
+            <a:srgbClr val="E8F1FB"/>
           </a:solidFill>
           <a:ln w="6350">
             <a:solidFill>
-              <a:srgbClr val="D7DEE8"/>
+              <a:srgbClr val="E8F1FB"/>
             </a:solidFill>
           </a:ln>
         </p:spPr>
         <p:txBody>
-          <a:bodyPr wrap="square" lIns="21000" tIns="21000" rIns="21000" bIns="21000"/>
-          <a:lstStyle/>
-          <a:p>
-            <a:pPr>
-              <a:buNone/>
-            </a:pPr>
-            <a:r>
-              <a:rPr lang="ru-RU" sz="750" b="1">
-                <a:solidFill>
-                  <a:srgbClr val="173A5E"/>
-                </a:solidFill>
-                <a:latin typeface="Arial"/>
-                <a:cs typeface="Arial"/>
-              </a:rPr>
-              <a:t>TRANSFORM - корректировка модели</a:t>
-            </a:r>
-            <a:endParaRPr lang="ru-RU" sz="750"/>
-          </a:p>
-          <a:p>
-            <a:pPr marL="165000" indent="-85000">
-              <a:buChar char="•"/>
-            </a:pPr>
-            <a:r>
-              <a:rPr lang="ru-RU" sz="620">
-                <a:solidFill>
-                  <a:srgbClr val="1F2933"/>
-                </a:solidFill>
-                <a:latin typeface="Arial"/>
-                <a:cs typeface="Arial"/>
-              </a:rPr>
-              <a:t>Диагностирую модель бизнеса и определяю изменения под новые цели роста и доходности.</a:t>
-            </a:r>
-            <a:endParaRPr lang="ru-RU" sz="620"/>
-          </a:p>
-          <a:p>
-            <a:pPr marL="165000" indent="-85000">
-              <a:buChar char="•"/>
-            </a:pPr>
-            <a:r>
-              <a:rPr lang="ru-RU" sz="620">
-                <a:solidFill>
-                  <a:srgbClr val="1F2933"/>
-                </a:solidFill>
-                <a:latin typeface="Arial"/>
-                <a:cs typeface="Arial"/>
-              </a:rPr>
-              <a:t>Пересобираю стратегию, экономику привлечения, источники финансирования, продуктовые приоритеты и операционную модель.</a:t>
-            </a:r>
-            <a:endParaRPr lang="ru-RU" sz="620"/>
-          </a:p>
-          <a:p>
-            <a:pPr marL="165000" indent="-85000">
-              <a:buChar char="•"/>
-            </a:pPr>
-            <a:r>
-              <a:rPr lang="ru-RU" sz="620">
-                <a:solidFill>
-                  <a:srgbClr val="1F2933"/>
-                </a:solidFill>
-                <a:latin typeface="Arial"/>
-                <a:cs typeface="Arial"/>
-              </a:rPr>
-              <a:t>Провожу изменения в работающем контуре банка: продукт, процессы, технологии, оргструктура и клиентский опыт.</a:t>
-            </a:r>
-            <a:endParaRPr lang="ru-RU" sz="620"/>
-          </a:p>
-        </p:txBody>
-      </p:sp>
-      <p:sp>
-        <p:nvSpPr>
-          <p:cNvPr id="52" name="LEAD - сложные программы"/>
-          <p:cNvSpPr txBox="1"/>
-          <p:nvPr/>
-        </p:nvSpPr>
-        <p:spPr>
-          <a:xfrm>
-            <a:off x="396000" y="7272000"/>
-            <a:ext cx="4428000" cy="1440000"/>
+          <a:bodyPr wrap="square" lIns="14000" tIns="14000" rIns="14000" bIns="14000"/>
+          <a:lstStyle/>
+          <a:p>
+            <a:pPr>
+              <a:buNone/>
+            </a:pPr>
+            <a:r>
+              <a:rPr lang="ru-RU" sz="560" b="1">
+                <a:solidFill>
+                  <a:srgbClr val="0F4778"/>
+                </a:solidFill>
+                <a:latin typeface="Arial"/>
+                <a:cs typeface="Arial"/>
+              </a:rPr>
+              <a:t>1,5 млн / 8 процессингов</a:t>
+            </a:r>
+            <a:endParaRPr lang="ru-RU" sz="560"/>
+          </a:p>
+        </p:txBody>
+      </p:sp>
+      <p:sp>
+        <p:nvSpPr>
+          <p:cNvPr id="212" name="tag"/>
+          <p:cNvSpPr txBox="1"/>
+          <p:nvPr/>
+        </p:nvSpPr>
+        <p:spPr>
+          <a:xfrm>
+            <a:off x="1872000" y="8640000"/>
+            <a:ext cx="900000" cy="205200"/>
           </a:xfrm>
           <a:prstGeom prst="roundRect">
             <a:avLst/>
           </a:prstGeom>
           <a:solidFill>
-            <a:srgbClr val="F8FAFC"/>
+            <a:srgbClr val="E8F1FB"/>
           </a:solidFill>
           <a:ln w="6350">
             <a:solidFill>
-              <a:srgbClr val="D7DEE8"/>
+              <a:srgbClr val="E8F1FB"/>
             </a:solidFill>
           </a:ln>
         </p:spPr>
         <p:txBody>
-          <a:bodyPr wrap="square" lIns="21000" tIns="21000" rIns="21000" bIns="21000"/>
-          <a:lstStyle/>
-          <a:p>
-            <a:pPr>
-              <a:buNone/>
-            </a:pPr>
-            <a:r>
-              <a:rPr lang="ru-RU" sz="750" b="1">
-                <a:solidFill>
-                  <a:srgbClr val="173A5E"/>
-                </a:solidFill>
-                <a:latin typeface="Arial"/>
-                <a:cs typeface="Arial"/>
-              </a:rPr>
-              <a:t>LEAD - сложные программы</a:t>
-            </a:r>
-            <a:endParaRPr lang="ru-RU" sz="750"/>
-          </a:p>
-          <a:p>
-            <a:pPr marL="165000" indent="-85000">
-              <a:buChar char="•"/>
-            </a:pPr>
-            <a:r>
-              <a:rPr lang="ru-RU" sz="620">
-                <a:solidFill>
-                  <a:srgbClr val="1F2933"/>
-                </a:solidFill>
-                <a:latin typeface="Arial"/>
-                <a:cs typeface="Arial"/>
-              </a:rPr>
-              <a:t>Формирую концепт, систему принятия решений и общие цели для бизнеса, IT, операций, продаж, маркетинга, регулятора и партнеров.</a:t>
-            </a:r>
-            <a:endParaRPr lang="ru-RU" sz="620"/>
-          </a:p>
-          <a:p>
-            <a:pPr marL="165000" indent="-85000">
-              <a:buChar char="•"/>
-            </a:pPr>
-            <a:r>
-              <a:rPr lang="ru-RU" sz="620">
-                <a:solidFill>
-                  <a:srgbClr val="1F2933"/>
-                </a:solidFill>
-                <a:latin typeface="Arial"/>
-                <a:cs typeface="Arial"/>
-              </a:rPr>
-              <a:t>Организую Agile-команды и крупные delivery-программы; удерживаю результат в условиях высокой сложности.</a:t>
-            </a:r>
-            <a:endParaRPr lang="ru-RU" sz="620"/>
-          </a:p>
-          <a:p>
-            <a:pPr marL="165000" indent="-85000">
-              <a:buChar char="•"/>
-            </a:pPr>
-            <a:r>
-              <a:rPr lang="ru-RU" sz="620">
-                <a:solidFill>
-                  <a:srgbClr val="1F2933"/>
-                </a:solidFill>
-                <a:latin typeface="Arial"/>
-                <a:cs typeface="Arial"/>
-              </a:rPr>
-              <a:t>Обеспечиваю бесшовность критичных изменений для клиентов и операционного контура.</a:t>
-            </a:r>
-            <a:endParaRPr lang="ru-RU" sz="620"/>
+          <a:bodyPr wrap="square" lIns="14000" tIns="14000" rIns="14000" bIns="14000"/>
+          <a:lstStyle/>
+          <a:p>
+            <a:pPr>
+              <a:buNone/>
+            </a:pPr>
+            <a:r>
+              <a:rPr lang="ru-RU" sz="560" b="1">
+                <a:solidFill>
+                  <a:srgbClr val="0F4778"/>
+                </a:solidFill>
+                <a:latin typeface="Arial"/>
+                <a:cs typeface="Arial"/>
+              </a:rPr>
+              <a:t>20 млн без простоя</a:t>
+            </a:r>
+            <a:endParaRPr lang="ru-RU" sz="560"/>
+          </a:p>
+        </p:txBody>
+      </p:sp>
+      <p:sp>
+        <p:nvSpPr>
+          <p:cNvPr id="213" name="tag"/>
+          <p:cNvSpPr txBox="1"/>
+          <p:nvPr/>
+        </p:nvSpPr>
+        <p:spPr>
+          <a:xfrm>
+            <a:off x="2844000" y="8640000"/>
+            <a:ext cx="1044000" cy="205200"/>
+          </a:xfrm>
+          <a:prstGeom prst="roundRect">
+            <a:avLst/>
+          </a:prstGeom>
+          <a:solidFill>
+            <a:srgbClr val="E8F1FB"/>
+          </a:solidFill>
+          <a:ln w="6350">
+            <a:solidFill>
+              <a:srgbClr val="E8F1FB"/>
+            </a:solidFill>
+          </a:ln>
+        </p:spPr>
+        <p:txBody>
+          <a:bodyPr wrap="square" lIns="14000" tIns="14000" rIns="14000" bIns="14000"/>
+          <a:lstStyle/>
+          <a:p>
+            <a:pPr>
+              <a:buNone/>
+            </a:pPr>
+            <a:r>
+              <a:rPr lang="ru-RU" sz="560" b="1">
+                <a:solidFill>
+                  <a:srgbClr val="0F4778"/>
+                </a:solidFill>
+                <a:latin typeface="Arial"/>
+                <a:cs typeface="Arial"/>
+              </a:rPr>
+              <a:t>2 млн детей / 8 мес.</a:t>
+            </a:r>
+            <a:endParaRPr lang="ru-RU" sz="560"/>
+          </a:p>
+        </p:txBody>
+      </p:sp>
+      <p:sp>
+        <p:nvSpPr>
+          <p:cNvPr id="214" name="tag"/>
+          <p:cNvSpPr txBox="1"/>
+          <p:nvPr/>
+        </p:nvSpPr>
+        <p:spPr>
+          <a:xfrm>
+            <a:off x="504000" y="8870400"/>
+            <a:ext cx="1008000" cy="205200"/>
+          </a:xfrm>
+          <a:prstGeom prst="roundRect">
+            <a:avLst/>
+          </a:prstGeom>
+          <a:solidFill>
+            <a:srgbClr val="E8F1FB"/>
+          </a:solidFill>
+          <a:ln w="6350">
+            <a:solidFill>
+              <a:srgbClr val="E8F1FB"/>
+            </a:solidFill>
+          </a:ln>
+        </p:spPr>
+        <p:txBody>
+          <a:bodyPr wrap="square" lIns="14000" tIns="14000" rIns="14000" bIns="14000"/>
+          <a:lstStyle/>
+          <a:p>
+            <a:pPr>
+              <a:buNone/>
+            </a:pPr>
+            <a:r>
+              <a:rPr lang="ru-RU" sz="560" b="1">
+                <a:solidFill>
+                  <a:srgbClr val="0F4778"/>
+                </a:solidFill>
+                <a:latin typeface="Arial"/>
+                <a:cs typeface="Arial"/>
+              </a:rPr>
+              <a:t>170 чел. / 12 команд</a:t>
+            </a:r>
+            <a:endParaRPr lang="ru-RU" sz="560"/>
+          </a:p>
+        </p:txBody>
+      </p:sp>
+      <p:sp>
+        <p:nvSpPr>
+          <p:cNvPr id="215" name="tag"/>
+          <p:cNvSpPr txBox="1"/>
+          <p:nvPr/>
+        </p:nvSpPr>
+        <p:spPr>
+          <a:xfrm>
+            <a:off x="1584000" y="8870400"/>
+            <a:ext cx="648000" cy="205200"/>
+          </a:xfrm>
+          <a:prstGeom prst="roundRect">
+            <a:avLst/>
+          </a:prstGeom>
+          <a:solidFill>
+            <a:srgbClr val="E8F1FB"/>
+          </a:solidFill>
+          <a:ln w="6350">
+            <a:solidFill>
+              <a:srgbClr val="E8F1FB"/>
+            </a:solidFill>
+          </a:ln>
+        </p:spPr>
+        <p:txBody>
+          <a:bodyPr wrap="square" lIns="14000" tIns="14000" rIns="14000" bIns="14000"/>
+          <a:lstStyle/>
+          <a:p>
+            <a:pPr>
+              <a:buNone/>
+            </a:pPr>
+            <a:r>
+              <a:rPr lang="ru-RU" sz="560" b="1">
+                <a:solidFill>
+                  <a:srgbClr val="0F4778"/>
+                </a:solidFill>
+                <a:latin typeface="Arial"/>
+                <a:cs typeface="Arial"/>
+              </a:rPr>
+              <a:t>SDN-контур</a:t>
+            </a:r>
+            <a:endParaRPr lang="ru-RU" sz="560"/>
           </a:p>
         </p:txBody>
       </p:sp>
@@ -1180,8 +1444,8 @@
         </p:nvSpPr>
         <p:spPr>
           <a:xfrm>
-            <a:off x="5076000" y="3708000"/>
-            <a:ext cx="2088000" cy="216000"/>
+            <a:off x="5112000" y="3132000"/>
+            <a:ext cx="2052000" cy="216000"/>
           </a:xfrm>
           <a:prstGeom prst="rect">
             <a:avLst/>
@@ -1220,8 +1484,8 @@
         </p:nvSpPr>
         <p:spPr>
           <a:xfrm>
-            <a:off x="5076000" y="3960000"/>
-            <a:ext cx="2088000" cy="9000"/>
+            <a:off x="5112000" y="3384000"/>
+            <a:ext cx="2052000" cy="9000"/>
           </a:xfrm>
           <a:prstGeom prst="rect">
             <a:avLst/>
@@ -1242,8 +1506,8 @@
         </p:nvSpPr>
         <p:spPr>
           <a:xfrm>
-            <a:off x="5076000" y="4104000"/>
-            <a:ext cx="2088000" cy="1260000"/>
+            <a:off x="5112000" y="3528000"/>
+            <a:ext cx="2052000" cy="1440000"/>
           </a:xfrm>
           <a:prstGeom prst="rect">
             <a:avLst/>
@@ -1261,7 +1525,7 @@
               <a:buNone/>
             </a:pPr>
             <a:r>
-              <a:rPr lang="ru-RU" sz="640">
+              <a:rPr lang="ru-RU" sz="630">
                 <a:solidFill>
                   <a:srgbClr val="1F2933"/>
                 </a:solidFill>
@@ -1270,20 +1534,20 @@
               </a:rPr>
               <a:t>Chief Business Officer / Chief Product Officer / Chief Operating Officer / Head of Retail Banking / Managing Director по розничному бизнесу, продуктам, платежам, клиентским платформам или трансформации финансового бизнеса.</a:t>
             </a:r>
-            <a:endParaRPr lang="ru-RU" sz="640"/>
-          </a:p>
-        </p:txBody>
-      </p:sp>
-      <p:sp>
-        <p:nvSpPr>
-          <p:cNvPr id="73" name="expertise"/>
-          <p:cNvSpPr txBox="1"/>
-          <p:nvPr/>
-        </p:nvSpPr>
-        <p:spPr>
-          <a:xfrm>
-            <a:off x="5076000" y="5508000"/>
-            <a:ext cx="2088000" cy="4284000"/>
+            <a:endParaRPr lang="ru-RU" sz="630"/>
+          </a:p>
+        </p:txBody>
+      </p:sp>
+      <p:sp>
+        <p:nvSpPr>
+          <p:cNvPr id="73" name="expert title"/>
+          <p:cNvSpPr txBox="1"/>
+          <p:nvPr/>
+        </p:nvSpPr>
+        <p:spPr>
+          <a:xfrm>
+            <a:off x="5112000" y="5148000"/>
+            <a:ext cx="2052000" cy="216000"/>
           </a:xfrm>
           <a:prstGeom prst="rect">
             <a:avLst/>
@@ -1312,6 +1576,578 @@
             </a:r>
             <a:endParaRPr lang="ru-RU" sz="820"/>
           </a:p>
+        </p:txBody>
+      </p:sp>
+      <p:sp>
+        <p:nvSpPr>
+          <p:cNvPr id="74" name="eu"/>
+          <p:cNvSpPr/>
+          <p:nvPr/>
+        </p:nvSpPr>
+        <p:spPr>
+          <a:xfrm>
+            <a:off x="5112000" y="5400000"/>
+            <a:ext cx="2052000" cy="9000"/>
+          </a:xfrm>
+          <a:prstGeom prst="rect">
+            <a:avLst/>
+          </a:prstGeom>
+          <a:solidFill>
+            <a:srgbClr val="D7DEE8"/>
+          </a:solidFill>
+          <a:ln>
+            <a:noFill/>
+          </a:ln>
+        </p:spPr>
+      </p:sp>
+      <p:sp>
+        <p:nvSpPr>
+          <p:cNvPr id="75" name="expert note"/>
+          <p:cNvSpPr txBox="1"/>
+          <p:nvPr/>
+        </p:nvSpPr>
+        <p:spPr>
+          <a:xfrm>
+            <a:off x="5112000" y="5508000"/>
+            <a:ext cx="2052000" cy="504000"/>
+          </a:xfrm>
+          <a:prstGeom prst="rect">
+            <a:avLst/>
+          </a:prstGeom>
+          <a:noFill/>
+          <a:ln>
+            <a:noFill/>
+          </a:ln>
+        </p:spPr>
+        <p:txBody>
+          <a:bodyPr wrap="square" lIns="0" tIns="0" rIns="0" bIns="0"/>
+          <a:lstStyle/>
+          <a:p>
+            <a:pPr>
+              <a:buNone/>
+            </a:pPr>
+            <a:r>
+              <a:rPr lang="ru-RU" sz="580">
+                <a:solidFill>
+                  <a:srgbClr val="667085"/>
+                </a:solidFill>
+                <a:latin typeface="Arial"/>
+                <a:cs typeface="Arial"/>
+              </a:rPr>
+              <a:t>Уровень вовлеченности в областях с hands-on управленческим опытом.</a:t>
+            </a:r>
+            <a:endParaRPr lang="ru-RU" sz="580"/>
+          </a:p>
+        </p:txBody>
+      </p:sp>
+      <p:sp>
+        <p:nvSpPr>
+          <p:cNvPr id="80" name="bar label"/>
+          <p:cNvSpPr txBox="1"/>
+          <p:nvPr/>
+        </p:nvSpPr>
+        <p:spPr>
+          <a:xfrm>
+            <a:off x="5112000" y="6048000"/>
+            <a:ext cx="2052000" cy="180000"/>
+          </a:xfrm>
+          <a:prstGeom prst="rect">
+            <a:avLst/>
+          </a:prstGeom>
+          <a:noFill/>
+          <a:ln>
+            <a:noFill/>
+          </a:ln>
+        </p:spPr>
+        <p:txBody>
+          <a:bodyPr wrap="square" lIns="0" tIns="0" rIns="0" bIns="0"/>
+          <a:lstStyle/>
+          <a:p>
+            <a:pPr>
+              <a:buNone/>
+            </a:pPr>
+            <a:r>
+              <a:rPr lang="ru-RU" sz="610" b="1">
+                <a:solidFill>
+                  <a:srgbClr val="173A5E"/>
+                </a:solidFill>
+                <a:latin typeface="Arial"/>
+                <a:cs typeface="Arial"/>
+              </a:rPr>
+              <a:t>Retail business and P&amp;L</a:t>
+            </a:r>
+            <a:r>
+              <a:rPr lang="ru-RU" sz="610" b="1">
+                <a:solidFill>
+                  <a:srgbClr val="173A5E"/>
+                </a:solidFill>
+                <a:latin typeface="Arial"/>
+                <a:cs typeface="Arial"/>
+              </a:rPr>
+              <a:t> 100%</a:t>
+            </a:r>
+            <a:endParaRPr lang="ru-RU" sz="610"/>
+          </a:p>
+        </p:txBody>
+      </p:sp>
+      <p:sp>
+        <p:nvSpPr>
+          <p:cNvPr id="81" name="bar bg"/>
+          <p:cNvSpPr/>
+          <p:nvPr/>
+        </p:nvSpPr>
+        <p:spPr>
+          <a:xfrm>
+            <a:off x="5112000" y="6238800"/>
+            <a:ext cx="2052000" cy="97200"/>
+          </a:xfrm>
+          <a:prstGeom prst="rect">
+            <a:avLst/>
+          </a:prstGeom>
+          <a:solidFill>
+            <a:srgbClr val="EDF2F7"/>
+          </a:solidFill>
+          <a:ln>
+            <a:noFill/>
+          </a:ln>
+        </p:spPr>
+      </p:sp>
+      <p:sp>
+        <p:nvSpPr>
+          <p:cNvPr id="82" name="bar fill"/>
+          <p:cNvSpPr/>
+          <p:nvPr/>
+        </p:nvSpPr>
+        <p:spPr>
+          <a:xfrm>
+            <a:off x="5112000" y="6238800"/>
+            <a:ext cx="2052000" cy="97200"/>
+          </a:xfrm>
+          <a:prstGeom prst="rect">
+            <a:avLst/>
+          </a:prstGeom>
+          <a:solidFill>
+            <a:srgbClr val="0F4778"/>
+          </a:solidFill>
+          <a:ln>
+            <a:noFill/>
+          </a:ln>
+        </p:spPr>
+      </p:sp>
+      <p:sp>
+        <p:nvSpPr>
+          <p:cNvPr id="83" name="bar label"/>
+          <p:cNvSpPr txBox="1"/>
+          <p:nvPr/>
+        </p:nvSpPr>
+        <p:spPr>
+          <a:xfrm>
+            <a:off x="5112000" y="6588000"/>
+            <a:ext cx="2052000" cy="180000"/>
+          </a:xfrm>
+          <a:prstGeom prst="rect">
+            <a:avLst/>
+          </a:prstGeom>
+          <a:noFill/>
+          <a:ln>
+            <a:noFill/>
+          </a:ln>
+        </p:spPr>
+        <p:txBody>
+          <a:bodyPr wrap="square" lIns="0" tIns="0" rIns="0" bIns="0"/>
+          <a:lstStyle/>
+          <a:p>
+            <a:pPr>
+              <a:buNone/>
+            </a:pPr>
+            <a:r>
+              <a:rPr lang="ru-RU" sz="610" b="1">
+                <a:solidFill>
+                  <a:srgbClr val="173A5E"/>
+                </a:solidFill>
+                <a:latin typeface="Arial"/>
+                <a:cs typeface="Arial"/>
+              </a:rPr>
+              <a:t>Products and growth</a:t>
+            </a:r>
+            <a:r>
+              <a:rPr lang="ru-RU" sz="610" b="1">
+                <a:solidFill>
+                  <a:srgbClr val="173A5E"/>
+                </a:solidFill>
+                <a:latin typeface="Arial"/>
+                <a:cs typeface="Arial"/>
+              </a:rPr>
+              <a:t> 100%</a:t>
+            </a:r>
+            <a:endParaRPr lang="ru-RU" sz="610"/>
+          </a:p>
+        </p:txBody>
+      </p:sp>
+      <p:sp>
+        <p:nvSpPr>
+          <p:cNvPr id="84" name="bar bg"/>
+          <p:cNvSpPr/>
+          <p:nvPr/>
+        </p:nvSpPr>
+        <p:spPr>
+          <a:xfrm>
+            <a:off x="5112000" y="6778800"/>
+            <a:ext cx="2052000" cy="97200"/>
+          </a:xfrm>
+          <a:prstGeom prst="rect">
+            <a:avLst/>
+          </a:prstGeom>
+          <a:solidFill>
+            <a:srgbClr val="EDF2F7"/>
+          </a:solidFill>
+          <a:ln>
+            <a:noFill/>
+          </a:ln>
+        </p:spPr>
+      </p:sp>
+      <p:sp>
+        <p:nvSpPr>
+          <p:cNvPr id="85" name="bar fill"/>
+          <p:cNvSpPr/>
+          <p:nvPr/>
+        </p:nvSpPr>
+        <p:spPr>
+          <a:xfrm>
+            <a:off x="5112000" y="6778800"/>
+            <a:ext cx="2052000" cy="97200"/>
+          </a:xfrm>
+          <a:prstGeom prst="rect">
+            <a:avLst/>
+          </a:prstGeom>
+          <a:solidFill>
+            <a:srgbClr val="0F4778"/>
+          </a:solidFill>
+          <a:ln>
+            <a:noFill/>
+          </a:ln>
+        </p:spPr>
+      </p:sp>
+      <p:sp>
+        <p:nvSpPr>
+          <p:cNvPr id="86" name="bar label"/>
+          <p:cNvSpPr txBox="1"/>
+          <p:nvPr/>
+        </p:nvSpPr>
+        <p:spPr>
+          <a:xfrm>
+            <a:off x="5112000" y="7128000"/>
+            <a:ext cx="2052000" cy="180000"/>
+          </a:xfrm>
+          <a:prstGeom prst="rect">
+            <a:avLst/>
+          </a:prstGeom>
+          <a:noFill/>
+          <a:ln>
+            <a:noFill/>
+          </a:ln>
+        </p:spPr>
+        <p:txBody>
+          <a:bodyPr wrap="square" lIns="0" tIns="0" rIns="0" bIns="0"/>
+          <a:lstStyle/>
+          <a:p>
+            <a:pPr>
+              <a:buNone/>
+            </a:pPr>
+            <a:r>
+              <a:rPr lang="ru-RU" sz="610" b="1">
+                <a:solidFill>
+                  <a:srgbClr val="173A5E"/>
+                </a:solidFill>
+                <a:latin typeface="Arial"/>
+                <a:cs typeface="Arial"/>
+              </a:rPr>
+              <a:t>Channels and partnerships</a:t>
+            </a:r>
+            <a:r>
+              <a:rPr lang="ru-RU" sz="610" b="1">
+                <a:solidFill>
+                  <a:srgbClr val="173A5E"/>
+                </a:solidFill>
+                <a:latin typeface="Arial"/>
+                <a:cs typeface="Arial"/>
+              </a:rPr>
+              <a:t> 100%</a:t>
+            </a:r>
+            <a:endParaRPr lang="ru-RU" sz="610"/>
+          </a:p>
+        </p:txBody>
+      </p:sp>
+      <p:sp>
+        <p:nvSpPr>
+          <p:cNvPr id="87" name="bar bg"/>
+          <p:cNvSpPr/>
+          <p:nvPr/>
+        </p:nvSpPr>
+        <p:spPr>
+          <a:xfrm>
+            <a:off x="5112000" y="7318800"/>
+            <a:ext cx="2052000" cy="97200"/>
+          </a:xfrm>
+          <a:prstGeom prst="rect">
+            <a:avLst/>
+          </a:prstGeom>
+          <a:solidFill>
+            <a:srgbClr val="EDF2F7"/>
+          </a:solidFill>
+          <a:ln>
+            <a:noFill/>
+          </a:ln>
+        </p:spPr>
+      </p:sp>
+      <p:sp>
+        <p:nvSpPr>
+          <p:cNvPr id="88" name="bar fill"/>
+          <p:cNvSpPr/>
+          <p:nvPr/>
+        </p:nvSpPr>
+        <p:spPr>
+          <a:xfrm>
+            <a:off x="5112000" y="7318800"/>
+            <a:ext cx="2052000" cy="97200"/>
+          </a:xfrm>
+          <a:prstGeom prst="rect">
+            <a:avLst/>
+          </a:prstGeom>
+          <a:solidFill>
+            <a:srgbClr val="0F4778"/>
+          </a:solidFill>
+          <a:ln>
+            <a:noFill/>
+          </a:ln>
+        </p:spPr>
+      </p:sp>
+      <p:sp>
+        <p:nvSpPr>
+          <p:cNvPr id="89" name="bar label"/>
+          <p:cNvSpPr txBox="1"/>
+          <p:nvPr/>
+        </p:nvSpPr>
+        <p:spPr>
+          <a:xfrm>
+            <a:off x="5112000" y="7668000"/>
+            <a:ext cx="2052000" cy="180000"/>
+          </a:xfrm>
+          <a:prstGeom prst="rect">
+            <a:avLst/>
+          </a:prstGeom>
+          <a:noFill/>
+          <a:ln>
+            <a:noFill/>
+          </a:ln>
+        </p:spPr>
+        <p:txBody>
+          <a:bodyPr wrap="square" lIns="0" tIns="0" rIns="0" bIns="0"/>
+          <a:lstStyle/>
+          <a:p>
+            <a:pPr>
+              <a:buNone/>
+            </a:pPr>
+            <a:r>
+              <a:rPr lang="ru-RU" sz="610" b="1">
+                <a:solidFill>
+                  <a:srgbClr val="173A5E"/>
+                </a:solidFill>
+                <a:latin typeface="Arial"/>
+                <a:cs typeface="Arial"/>
+              </a:rPr>
+              <a:t>Technology and delivery</a:t>
+            </a:r>
+            <a:r>
+              <a:rPr lang="ru-RU" sz="610" b="1">
+                <a:solidFill>
+                  <a:srgbClr val="173A5E"/>
+                </a:solidFill>
+                <a:latin typeface="Arial"/>
+                <a:cs typeface="Arial"/>
+              </a:rPr>
+              <a:t> 80%</a:t>
+            </a:r>
+            <a:endParaRPr lang="ru-RU" sz="610"/>
+          </a:p>
+        </p:txBody>
+      </p:sp>
+      <p:sp>
+        <p:nvSpPr>
+          <p:cNvPr id="90" name="bar bg"/>
+          <p:cNvSpPr/>
+          <p:nvPr/>
+        </p:nvSpPr>
+        <p:spPr>
+          <a:xfrm>
+            <a:off x="5112000" y="7858800"/>
+            <a:ext cx="2052000" cy="97200"/>
+          </a:xfrm>
+          <a:prstGeom prst="rect">
+            <a:avLst/>
+          </a:prstGeom>
+          <a:solidFill>
+            <a:srgbClr val="EDF2F7"/>
+          </a:solidFill>
+          <a:ln>
+            <a:noFill/>
+          </a:ln>
+        </p:spPr>
+      </p:sp>
+      <p:sp>
+        <p:nvSpPr>
+          <p:cNvPr id="91" name="bar fill"/>
+          <p:cNvSpPr/>
+          <p:nvPr/>
+        </p:nvSpPr>
+        <p:spPr>
+          <a:xfrm>
+            <a:off x="5112000" y="7858800"/>
+            <a:ext cx="1641600" cy="97200"/>
+          </a:xfrm>
+          <a:prstGeom prst="rect">
+            <a:avLst/>
+          </a:prstGeom>
+          <a:solidFill>
+            <a:srgbClr val="0F4778"/>
+          </a:solidFill>
+          <a:ln>
+            <a:noFill/>
+          </a:ln>
+        </p:spPr>
+      </p:sp>
+      <p:sp>
+        <p:nvSpPr>
+          <p:cNvPr id="92" name="bar label"/>
+          <p:cNvSpPr txBox="1"/>
+          <p:nvPr/>
+        </p:nvSpPr>
+        <p:spPr>
+          <a:xfrm>
+            <a:off x="5112000" y="8208000"/>
+            <a:ext cx="2052000" cy="180000"/>
+          </a:xfrm>
+          <a:prstGeom prst="rect">
+            <a:avLst/>
+          </a:prstGeom>
+          <a:noFill/>
+          <a:ln>
+            <a:noFill/>
+          </a:ln>
+        </p:spPr>
+        <p:txBody>
+          <a:bodyPr wrap="square" lIns="0" tIns="0" rIns="0" bIns="0"/>
+          <a:lstStyle/>
+          <a:p>
+            <a:pPr>
+              <a:buNone/>
+            </a:pPr>
+            <a:r>
+              <a:rPr lang="ru-RU" sz="610" b="1">
+                <a:solidFill>
+                  <a:srgbClr val="173A5E"/>
+                </a:solidFill>
+                <a:latin typeface="Arial"/>
+                <a:cs typeface="Arial"/>
+              </a:rPr>
+              <a:t>Regulatory</a:t>
+            </a:r>
+            <a:r>
+              <a:rPr lang="ru-RU" sz="610" b="1">
+                <a:solidFill>
+                  <a:srgbClr val="173A5E"/>
+                </a:solidFill>
+                <a:latin typeface="Arial"/>
+                <a:cs typeface="Arial"/>
+              </a:rPr>
+              <a:t> 70%</a:t>
+            </a:r>
+            <a:endParaRPr lang="ru-RU" sz="610"/>
+          </a:p>
+        </p:txBody>
+      </p:sp>
+      <p:sp>
+        <p:nvSpPr>
+          <p:cNvPr id="93" name="bar bg"/>
+          <p:cNvSpPr/>
+          <p:nvPr/>
+        </p:nvSpPr>
+        <p:spPr>
+          <a:xfrm>
+            <a:off x="5112000" y="8398800"/>
+            <a:ext cx="2052000" cy="97200"/>
+          </a:xfrm>
+          <a:prstGeom prst="rect">
+            <a:avLst/>
+          </a:prstGeom>
+          <a:solidFill>
+            <a:srgbClr val="EDF2F7"/>
+          </a:solidFill>
+          <a:ln>
+            <a:noFill/>
+          </a:ln>
+        </p:spPr>
+      </p:sp>
+      <p:sp>
+        <p:nvSpPr>
+          <p:cNvPr id="94" name="bar fill"/>
+          <p:cNvSpPr/>
+          <p:nvPr/>
+        </p:nvSpPr>
+        <p:spPr>
+          <a:xfrm>
+            <a:off x="5112000" y="8398800"/>
+            <a:ext cx="1436400" cy="97200"/>
+          </a:xfrm>
+          <a:prstGeom prst="rect">
+            <a:avLst/>
+          </a:prstGeom>
+          <a:solidFill>
+            <a:srgbClr val="0F4778"/>
+          </a:solidFill>
+          <a:ln>
+            <a:noFill/>
+          </a:ln>
+        </p:spPr>
+      </p:sp>
+      <p:sp>
+        <p:nvSpPr>
+          <p:cNvPr id="100" name="edu"/>
+          <p:cNvSpPr txBox="1"/>
+          <p:nvPr/>
+        </p:nvSpPr>
+        <p:spPr>
+          <a:xfrm>
+            <a:off x="5112000" y="8892000"/>
+            <a:ext cx="2052000" cy="972000"/>
+          </a:xfrm>
+          <a:prstGeom prst="rect">
+            <a:avLst/>
+          </a:prstGeom>
+          <a:noFill/>
+          <a:ln>
+            <a:noFill/>
+          </a:ln>
+        </p:spPr>
+        <p:txBody>
+          <a:bodyPr wrap="square" lIns="0" tIns="0" rIns="0" bIns="0"/>
+          <a:lstStyle/>
+          <a:p>
+            <a:pPr>
+              <a:buNone/>
+            </a:pPr>
+            <a:r>
+              <a:rPr lang="ru-RU" sz="780" b="1">
+                <a:solidFill>
+                  <a:srgbClr val="0F2742"/>
+                </a:solidFill>
+                <a:latin typeface="Arial"/>
+                <a:cs typeface="Arial"/>
+              </a:rPr>
+              <a:t>ОБРАЗОВАНИЕ И ЯЗЫКИ</a:t>
+            </a:r>
+            <a:endParaRPr lang="ru-RU" sz="780"/>
+          </a:p>
           <a:p>
             <a:pPr>
               <a:buNone/>
@@ -1319,177 +2155,17 @@
             <a:r>
               <a:rPr lang="ru-RU" sz="600">
                 <a:solidFill>
-                  <a:srgbClr val="667085"/>
-                </a:solidFill>
-                <a:latin typeface="Arial"/>
-                <a:cs typeface="Arial"/>
-              </a:rPr>
-              <a:t>Области с hands-on управленческим опытом и подтвержденными результатами.</a:t>
+                  <a:srgbClr val="1F2933"/>
+                </a:solidFill>
+                <a:latin typeface="Arial"/>
+                <a:cs typeface="Arial"/>
+              </a:rPr>
+              <a:t>МГОУ, Москва, 1998
+Менеджмент и экономическая политика
+Русский - родной · Английский - C2
+Испанский - базовый</a:t>
             </a:r>
             <a:endParaRPr lang="ru-RU" sz="600"/>
-          </a:p>
-          <a:p>
-            <a:pPr>
-              <a:buNone/>
-            </a:pPr>
-            <a:r>
-              <a:rPr lang="ru-RU" sz="610" b="1">
-                <a:solidFill>
-                  <a:srgbClr val="1F2933"/>
-                </a:solidFill>
-                <a:latin typeface="Arial"/>
-                <a:cs typeface="Arial"/>
-              </a:rPr>
-              <a:t>Розничный бизнес и P&amp;L:</a:t>
-            </a:r>
-            <a:r>
-              <a:rPr lang="ru-RU" sz="610">
-                <a:solidFill>
-                  <a:srgbClr val="1F2933"/>
-                </a:solidFill>
-                <a:latin typeface="Arial"/>
-                <a:cs typeface="Arial"/>
-              </a:rPr>
-              <a:t> стратегия, экономика привлечения, окупаемость, P&amp;L, CIR, KPI.</a:t>
-            </a:r>
-            <a:endParaRPr lang="ru-RU" sz="610"/>
-          </a:p>
-          <a:p>
-            <a:pPr>
-              <a:buNone/>
-            </a:pPr>
-            <a:r>
-              <a:rPr lang="ru-RU" sz="610" b="1">
-                <a:solidFill>
-                  <a:srgbClr val="1F2933"/>
-                </a:solidFill>
-                <a:latin typeface="Arial"/>
-                <a:cs typeface="Arial"/>
-              </a:rPr>
-              <a:t>Продукты и рост:</a:t>
-            </a:r>
-            <a:r>
-              <a:rPr lang="ru-RU" sz="610">
-                <a:solidFill>
-                  <a:srgbClr val="1F2933"/>
-                </a:solidFill>
-                <a:latin typeface="Arial"/>
-                <a:cs typeface="Arial"/>
-              </a:rPr>
-              <a:t> карты, депозиты, накопительные счета, инвестиционные и страховые продукты, платежи, РКО, AUM, NTB, MAU/DAU, pNPS.</a:t>
-            </a:r>
-            <a:endParaRPr lang="ru-RU" sz="610"/>
-          </a:p>
-          <a:p>
-            <a:pPr>
-              <a:buNone/>
-            </a:pPr>
-            <a:r>
-              <a:rPr lang="ru-RU" sz="610" b="1">
-                <a:solidFill>
-                  <a:srgbClr val="1F2933"/>
-                </a:solidFill>
-                <a:latin typeface="Arial"/>
-                <a:cs typeface="Arial"/>
-              </a:rPr>
-              <a:t>Каналы:</a:t>
-            </a:r>
-            <a:r>
-              <a:rPr lang="ru-RU" sz="610">
-                <a:solidFill>
-                  <a:srgbClr val="1F2933"/>
-                </a:solidFill>
-                <a:latin typeface="Arial"/>
-                <a:cs typeface="Arial"/>
-              </a:rPr>
-              <a:t> региональная сеть, партнерская дистрибуция, модели продаж, мотивация, CRM.</a:t>
-            </a:r>
-            <a:endParaRPr lang="ru-RU" sz="610"/>
-          </a:p>
-          <a:p>
-            <a:pPr>
-              <a:buNone/>
-            </a:pPr>
-            <a:r>
-              <a:rPr lang="ru-RU" sz="610" b="1">
-                <a:solidFill>
-                  <a:srgbClr val="1F2933"/>
-                </a:solidFill>
-                <a:latin typeface="Arial"/>
-                <a:cs typeface="Arial"/>
-              </a:rPr>
-              <a:t>Технологии:</a:t>
-            </a:r>
-            <a:r>
-              <a:rPr lang="ru-RU" sz="610">
-                <a:solidFill>
-                  <a:srgbClr val="1F2933"/>
-                </a:solidFill>
-                <a:latin typeface="Arial"/>
-                <a:cs typeface="Arial"/>
-              </a:rPr>
-              <a:t> процессинг, миграции, Agile, трайбы, IT-трансформация.</a:t>
-            </a:r>
-            <a:endParaRPr lang="ru-RU" sz="610"/>
-          </a:p>
-          <a:p>
-            <a:pPr>
-              <a:buNone/>
-            </a:pPr>
-            <a:r>
-              <a:rPr lang="ru-RU" sz="610" b="1">
-                <a:solidFill>
-                  <a:srgbClr val="1F2933"/>
-                </a:solidFill>
-                <a:latin typeface="Arial"/>
-                <a:cs typeface="Arial"/>
-              </a:rPr>
-              <a:t>Регуляторика:</a:t>
-            </a:r>
-            <a:r>
-              <a:rPr lang="ru-RU" sz="610">
-                <a:solidFill>
-                  <a:srgbClr val="1F2933"/>
-                </a:solidFill>
-                <a:latin typeface="Arial"/>
-                <a:cs typeface="Arial"/>
-              </a:rPr>
-              <a:t> федеральные проекты, регулятор, платежные системы, SDN.</a:t>
-            </a:r>
-            <a:endParaRPr lang="ru-RU" sz="610"/>
-          </a:p>
-          <a:p>
-            <a:pPr>
-              <a:buNone/>
-            </a:pPr>
-            <a:r>
-              <a:rPr lang="ru-RU" sz="750" b="1">
-                <a:solidFill>
-                  <a:srgbClr val="0F2742"/>
-                </a:solidFill>
-                <a:latin typeface="Arial"/>
-                <a:cs typeface="Arial"/>
-              </a:rPr>
-              <a:t>ОБРАЗОВАНИЕ И ЯЗЫКИ</a:t>
-            </a:r>
-            <a:endParaRPr lang="ru-RU" sz="750"/>
-          </a:p>
-          <a:p>
-            <a:pPr>
-              <a:buNone/>
-            </a:pPr>
-            <a:r>
-              <a:rPr lang="ru-RU" sz="610">
-                <a:solidFill>
-                  <a:srgbClr val="1F2933"/>
-                </a:solidFill>
-                <a:latin typeface="Arial"/>
-                <a:cs typeface="Arial"/>
-              </a:rPr>
-              <a:t>МГОУ, Москва, 1998 · Менеджмент и экономическая политика
-Русский - родной · Английский - C2</a:t>
-            </a:r>
-            <a:endParaRPr lang="ru-RU" sz="610"/>
           </a:p>
         </p:txBody>
       </p:sp>
@@ -1643,7 +2319,7 @@
             <a:endParaRPr lang="ru-RU" sz="640"/>
           </a:p>
           <a:p>
-            <a:pPr marL="165000" indent="-85000">
+            <a:pPr marL="155000" indent="-80000">
               <a:buChar char="•"/>
             </a:pPr>
             <a:r>
@@ -1659,7 +2335,7 @@
             <a:endParaRPr lang="ru-RU" sz="590"/>
           </a:p>
           <a:p>
-            <a:pPr marL="165000" indent="-85000">
+            <a:pPr marL="155000" indent="-80000">
               <a:buChar char="•"/>
             </a:pPr>
             <a:r>
@@ -1675,7 +2351,7 @@
             <a:endParaRPr lang="ru-RU" sz="590"/>
           </a:p>
           <a:p>
-            <a:pPr marL="165000" indent="-85000">
+            <a:pPr marL="155000" indent="-80000">
               <a:buChar char="•"/>
             </a:pPr>
             <a:r>
@@ -1691,7 +2367,7 @@
             <a:endParaRPr lang="ru-RU" sz="590"/>
           </a:p>
           <a:p>
-            <a:pPr marL="165000" indent="-85000">
+            <a:pPr marL="155000" indent="-80000">
               <a:buChar char="•"/>
             </a:pPr>
             <a:r>
@@ -1707,7 +2383,7 @@
             <a:endParaRPr lang="ru-RU" sz="590"/>
           </a:p>
           <a:p>
-            <a:pPr marL="165000" indent="-85000">
+            <a:pPr marL="155000" indent="-80000">
               <a:buChar char="•"/>
             </a:pPr>
             <a:r>
@@ -1779,7 +2455,7 @@
             <a:endParaRPr lang="ru-RU" sz="640"/>
           </a:p>
           <a:p>
-            <a:pPr marL="165000" indent="-85000">
+            <a:pPr marL="155000" indent="-80000">
               <a:buChar char="•"/>
             </a:pPr>
             <a:r>
@@ -1795,7 +2471,7 @@
             <a:endParaRPr lang="ru-RU" sz="590"/>
           </a:p>
           <a:p>
-            <a:pPr marL="165000" indent="-85000">
+            <a:pPr marL="155000" indent="-80000">
               <a:buChar char="•"/>
             </a:pPr>
             <a:r>
@@ -1811,7 +2487,7 @@
             <a:endParaRPr lang="ru-RU" sz="590"/>
           </a:p>
           <a:p>
-            <a:pPr marL="165000" indent="-85000">
+            <a:pPr marL="155000" indent="-80000">
               <a:buChar char="•"/>
             </a:pPr>
             <a:r>
@@ -1827,7 +2503,7 @@
             <a:endParaRPr lang="ru-RU" sz="590"/>
           </a:p>
           <a:p>
-            <a:pPr marL="165000" indent="-85000">
+            <a:pPr marL="155000" indent="-80000">
               <a:buChar char="•"/>
             </a:pPr>
             <a:r>
@@ -1843,7 +2519,7 @@
             <a:endParaRPr lang="ru-RU" sz="590"/>
           </a:p>
           <a:p>
-            <a:pPr marL="165000" indent="-85000">
+            <a:pPr marL="155000" indent="-80000">
               <a:buChar char="•"/>
             </a:pPr>
             <a:r>
@@ -1859,7 +2535,7 @@
             <a:endParaRPr lang="ru-RU" sz="590"/>
           </a:p>
           <a:p>
-            <a:pPr marL="165000" indent="-85000">
+            <a:pPr marL="155000" indent="-80000">
               <a:buChar char="•"/>
             </a:pPr>
             <a:r>
@@ -1931,7 +2607,7 @@
             <a:endParaRPr lang="ru-RU" sz="640"/>
           </a:p>
           <a:p>
-            <a:pPr marL="165000" indent="-85000">
+            <a:pPr marL="155000" indent="-80000">
               <a:buChar char="•"/>
             </a:pPr>
             <a:r>
@@ -1947,7 +2623,7 @@
             <a:endParaRPr lang="ru-RU" sz="590"/>
           </a:p>
           <a:p>
-            <a:pPr marL="165000" indent="-85000">
+            <a:pPr marL="155000" indent="-80000">
               <a:buChar char="•"/>
             </a:pPr>
             <a:r>
@@ -1963,7 +2639,7 @@
             <a:endParaRPr lang="ru-RU" sz="590"/>
           </a:p>
           <a:p>
-            <a:pPr marL="165000" indent="-85000">
+            <a:pPr marL="155000" indent="-80000">
               <a:buChar char="•"/>
             </a:pPr>
             <a:r>
@@ -1979,7 +2655,7 @@
             <a:endParaRPr lang="ru-RU" sz="590"/>
           </a:p>
           <a:p>
-            <a:pPr marL="165000" indent="-85000">
+            <a:pPr marL="155000" indent="-80000">
               <a:buChar char="•"/>
             </a:pPr>
             <a:r>
@@ -1995,7 +2671,7 @@
             <a:endParaRPr lang="ru-RU" sz="590"/>
           </a:p>
           <a:p>
-            <a:pPr marL="165000" indent="-85000">
+            <a:pPr marL="155000" indent="-80000">
               <a:buChar char="•"/>
             </a:pPr>
             <a:r>

</xml_diff>

<commit_message>
Expand metric proof blocks
Co-authored-by: yanatimofeeva2511 <yanatimofeeva2511@users.noreply.github.com>
</commit_message>
<xml_diff>
--- a/resume_clevel_fintech_ru_editable.pptx
+++ b/resume_clevel_fintech_ru_editable.pptx
@@ -129,7 +129,7 @@
               <a:buNone/>
             </a:pPr>
             <a:r>
-              <a:rPr lang="ru-RU" sz="2050" b="1">
+              <a:rPr lang="ru-RU" sz="2000" b="1">
                 <a:solidFill>
                   <a:srgbClr val="0F2742"/>
                 </a:solidFill>
@@ -138,7 +138,7 @@
               </a:rPr>
               <a:t>Яна Тимофеева</a:t>
             </a:r>
-            <a:endParaRPr lang="ru-RU" sz="2050"/>
+            <a:endParaRPr lang="ru-RU" sz="2000"/>
           </a:p>
         </p:txBody>
       </p:sp>
@@ -169,7 +169,7 @@
               <a:buNone/>
             </a:pPr>
             <a:r>
-              <a:rPr lang="ru-RU" sz="720">
+              <a:rPr lang="ru-RU" sz="700">
                 <a:solidFill>
                   <a:srgbClr val="4B5563"/>
                 </a:solidFill>
@@ -178,14 +178,14 @@
               </a:rPr>
               <a:t>Москва · +7 (903) 725-82-18</a:t>
             </a:r>
-            <a:endParaRPr lang="ru-RU" sz="720"/>
-          </a:p>
-          <a:p>
-            <a:pPr>
-              <a:buNone/>
-            </a:pPr>
-            <a:r>
-              <a:rPr lang="ru-RU" sz="720">
+            <a:endParaRPr lang="ru-RU" sz="700"/>
+          </a:p>
+          <a:p>
+            <a:pPr>
+              <a:buNone/>
+            </a:pPr>
+            <a:r>
+              <a:rPr lang="ru-RU" sz="700">
                 <a:solidFill>
                   <a:srgbClr val="4B5563"/>
                 </a:solidFill>
@@ -194,7 +194,7 @@
               </a:rPr>
               <a:t>ia.timofeeva@yandex.ru</a:t>
             </a:r>
-            <a:endParaRPr lang="ru-RU" sz="720"/>
+            <a:endParaRPr lang="ru-RU" sz="700"/>
           </a:p>
         </p:txBody>
       </p:sp>
@@ -229,7 +229,7 @@
         <p:spPr>
           <a:xfrm>
             <a:off x="396000" y="900000"/>
-            <a:ext cx="6768000" cy="540000"/>
+            <a:ext cx="6768000" cy="504000"/>
           </a:xfrm>
           <a:prstGeom prst="rect">
             <a:avLst/>
@@ -247,7 +247,7 @@
               <a:buNone/>
             </a:pPr>
             <a:r>
-              <a:rPr lang="ru-RU" sz="1030" b="1">
+              <a:rPr lang="ru-RU" sz="980" b="1">
                 <a:solidFill>
                   <a:srgbClr val="173A5E"/>
                 </a:solidFill>
@@ -256,14 +256,14 @@
               </a:rPr>
               <a:t>C-level лидер | розничный банкинг, финтех и платежная инфраструктура</a:t>
             </a:r>
-            <a:endParaRPr lang="ru-RU" sz="1030"/>
-          </a:p>
-          <a:p>
-            <a:pPr>
-              <a:buNone/>
-            </a:pPr>
-            <a:r>
-              <a:rPr lang="ru-RU" sz="760">
+            <a:endParaRPr lang="ru-RU" sz="980"/>
+          </a:p>
+          <a:p>
+            <a:pPr>
+              <a:buNone/>
+            </a:pPr>
+            <a:r>
+              <a:rPr lang="ru-RU" sz="720">
                 <a:solidFill>
                   <a:srgbClr val="4B5563"/>
                 </a:solidFill>
@@ -272,7 +272,7 @@
               </a:rPr>
               <a:t>BUILD / TRANSFORM / LEAD: запуск бизнес-направлений, трансформация продуктовых моделей, управление крупными программами изменений</a:t>
             </a:r>
-            <a:endParaRPr lang="ru-RU" sz="760"/>
+            <a:endParaRPr lang="ru-RU" sz="720"/>
           </a:p>
         </p:txBody>
       </p:sp>
@@ -284,7 +284,7 @@
         </p:nvSpPr>
         <p:spPr>
           <a:xfrm>
-            <a:off x="396000" y="1584000"/>
+            <a:off x="396000" y="1512000"/>
             <a:ext cx="6768000" cy="216000"/>
           </a:xfrm>
           <a:prstGeom prst="rect">
@@ -303,7 +303,7 @@
               <a:buNone/>
             </a:pPr>
             <a:r>
-              <a:rPr lang="ru-RU" sz="820" b="1">
+              <a:rPr lang="ru-RU" sz="800" b="1">
                 <a:solidFill>
                   <a:srgbClr val="0F2742"/>
                 </a:solidFill>
@@ -312,7 +312,7 @@
               </a:rPr>
               <a:t>ПРОФИЛЬ</a:t>
             </a:r>
-            <a:endParaRPr lang="ru-RU" sz="820"/>
+            <a:endParaRPr lang="ru-RU" sz="800"/>
           </a:p>
         </p:txBody>
       </p:sp>
@@ -324,7 +324,7 @@
         </p:nvSpPr>
         <p:spPr>
           <a:xfrm>
-            <a:off x="396000" y="1836000"/>
+            <a:off x="396000" y="1764000"/>
             <a:ext cx="6768000" cy="9000"/>
           </a:xfrm>
           <a:prstGeom prst="rect">
@@ -346,8 +346,8 @@
         </p:nvSpPr>
         <p:spPr>
           <a:xfrm>
-            <a:off x="396000" y="1944000"/>
-            <a:ext cx="6768000" cy="972000"/>
+            <a:off x="396000" y="1872000"/>
+            <a:ext cx="6768000" cy="900000"/>
           </a:xfrm>
           <a:prstGeom prst="rect">
             <a:avLst/>
@@ -365,7 +365,7 @@
               <a:buNone/>
             </a:pPr>
             <a:r>
-              <a:rPr lang="ru-RU" sz="720">
+              <a:rPr lang="ru-RU" sz="670">
                 <a:solidFill>
                   <a:srgbClr val="1F2933"/>
                 </a:solidFill>
@@ -374,14 +374,14 @@
               </a:rPr>
               <a:t>Бизнес-лидер с 20+ годами опыта в крупнейших финансовых организациях России. Отвечаю за розничные направления, запуск новых продуктов, клиентский рост, партнерскую дистрибуцию, технологические миграции и федеральные проекты на стыке бизнеса, IT, операций, маркетинга, продаж и регуляторного контура.</a:t>
             </a:r>
-            <a:endParaRPr lang="ru-RU" sz="720"/>
-          </a:p>
-          <a:p>
-            <a:pPr>
-              <a:buNone/>
-            </a:pPr>
-            <a:r>
-              <a:rPr lang="ru-RU" sz="720">
+            <a:endParaRPr lang="ru-RU" sz="670"/>
+          </a:p>
+          <a:p>
+            <a:pPr>
+              <a:buNone/>
+            </a:pPr>
+            <a:r>
+              <a:rPr lang="ru-RU" sz="670">
                 <a:solidFill>
                   <a:srgbClr val="1F2933"/>
                 </a:solidFill>
@@ -390,7 +390,7 @@
               </a:rPr>
               <a:t>Моя ценность - быстро соединить стратегию, экономику продукта, операционную модель и delivery в измеримый результат без потери клиентского опыта.</a:t>
             </a:r>
-            <a:endParaRPr lang="ru-RU" sz="720"/>
+            <a:endParaRPr lang="ru-RU" sz="670"/>
           </a:p>
         </p:txBody>
       </p:sp>
@@ -402,8 +402,8 @@
         </p:nvSpPr>
         <p:spPr>
           <a:xfrm>
-            <a:off x="396000" y="3132000"/>
-            <a:ext cx="4464000" cy="216000"/>
+            <a:off x="396000" y="2880000"/>
+            <a:ext cx="4500000" cy="216000"/>
           </a:xfrm>
           <a:prstGeom prst="rect">
             <a:avLst/>
@@ -421,7 +421,7 @@
               <a:buNone/>
             </a:pPr>
             <a:r>
-              <a:rPr lang="ru-RU" sz="820" b="1">
+              <a:rPr lang="ru-RU" sz="800" b="1">
                 <a:solidFill>
                   <a:srgbClr val="0F2742"/>
                 </a:solidFill>
@@ -430,7 +430,7 @@
               </a:rPr>
               <a:t>УПРАВЛЕНЧЕСКИЙ ФОКУС</a:t>
             </a:r>
-            <a:endParaRPr lang="ru-RU" sz="820"/>
+            <a:endParaRPr lang="ru-RU" sz="800"/>
           </a:p>
         </p:txBody>
       </p:sp>
@@ -442,8 +442,8 @@
         </p:nvSpPr>
         <p:spPr>
           <a:xfrm>
-            <a:off x="396000" y="3384000"/>
-            <a:ext cx="4464000" cy="9000"/>
+            <a:off x="396000" y="3132000"/>
+            <a:ext cx="4500000" cy="9000"/>
           </a:xfrm>
           <a:prstGeom prst="rect">
             <a:avLst/>
@@ -464,8 +464,8 @@
         </p:nvSpPr>
         <p:spPr>
           <a:xfrm>
-            <a:off x="396000" y="3528000"/>
-            <a:ext cx="4464000" cy="1764000"/>
+            <a:off x="396000" y="3240000"/>
+            <a:ext cx="4500000" cy="1980000"/>
           </a:xfrm>
           <a:prstGeom prst="roundRect">
             <a:avLst/>
@@ -480,14 +480,14 @@
           </a:ln>
         </p:spPr>
         <p:txBody>
-          <a:bodyPr wrap="square" lIns="18500" tIns="18500" rIns="18500" bIns="18500"/>
-          <a:lstStyle/>
-          <a:p>
-            <a:pPr>
-              <a:buNone/>
-            </a:pPr>
-            <a:r>
-              <a:rPr lang="ru-RU" sz="740" b="1">
+          <a:bodyPr wrap="square" lIns="16000" tIns="16000" rIns="16000" bIns="16000"/>
+          <a:lstStyle/>
+          <a:p>
+            <a:pPr>
+              <a:buNone/>
+            </a:pPr>
+            <a:r>
+              <a:rPr lang="ru-RU" sz="690" b="1">
                 <a:solidFill>
                   <a:srgbClr val="173A5E"/>
                 </a:solidFill>
@@ -496,14 +496,14 @@
               </a:rPr>
               <a:t>BUILD - запуск самостоятельных бизнес-направлений</a:t>
             </a:r>
-            <a:endParaRPr lang="ru-RU" sz="740"/>
-          </a:p>
-          <a:p>
-            <a:pPr marL="155000" indent="-80000">
+            <a:endParaRPr lang="ru-RU" sz="690"/>
+          </a:p>
+          <a:p>
+            <a:pPr marL="135000" indent="-70000">
               <a:buChar char="•"/>
             </a:pPr>
             <a:r>
-              <a:rPr lang="ru-RU" sz="590">
+              <a:rPr lang="ru-RU" sz="520">
                 <a:solidFill>
                   <a:srgbClr val="1F2933"/>
                 </a:solidFill>
@@ -512,14 +512,14 @@
               </a:rPr>
               <a:t>Определяю рынок, сегменты, бизнес-модель, стратегию, инвестиционную логику и окупаемость.</a:t>
             </a:r>
-            <a:endParaRPr lang="ru-RU" sz="590"/>
-          </a:p>
-          <a:p>
-            <a:pPr marL="155000" indent="-80000">
+            <a:endParaRPr lang="ru-RU" sz="520"/>
+          </a:p>
+          <a:p>
+            <a:pPr marL="135000" indent="-70000">
               <a:buChar char="•"/>
             </a:pPr>
             <a:r>
-              <a:rPr lang="ru-RU" sz="590">
+              <a:rPr lang="ru-RU" sz="520">
                 <a:solidFill>
                   <a:srgbClr val="1F2933"/>
                 </a:solidFill>
@@ -528,36 +528,20 @@
               </a:rPr>
               <a:t>Формирую продуктовый ряд и клиентское предложение; развиваю каналы продаж, партнерства и дистрибуцию.</a:t>
             </a:r>
-            <a:endParaRPr lang="ru-RU" sz="590"/>
-          </a:p>
-          <a:p>
-            <a:pPr marL="155000" indent="-80000">
-              <a:buChar char="•"/>
-            </a:pPr>
-            <a:r>
-              <a:rPr lang="ru-RU" sz="590">
-                <a:solidFill>
-                  <a:srgbClr val="1F2933"/>
-                </a:solidFill>
-                <a:latin typeface="Arial"/>
-                <a:cs typeface="Arial"/>
-              </a:rPr>
-              <a:t>Собираю кросс-функциональную реализацию с бизнесом, продажами, маркетингом, продуктом, операциями и IT.</a:t>
-            </a:r>
-            <a:endParaRPr lang="ru-RU" sz="590"/>
-          </a:p>
-        </p:txBody>
-      </p:sp>
-      <p:sp>
-        <p:nvSpPr>
-          <p:cNvPr id="200" name="tag"/>
-          <p:cNvSpPr txBox="1"/>
-          <p:nvPr/>
-        </p:nvSpPr>
-        <p:spPr>
-          <a:xfrm>
-            <a:off x="504000" y="4752000"/>
-            <a:ext cx="936000" cy="205200"/>
+            <a:endParaRPr lang="ru-RU" sz="520"/>
+          </a:p>
+        </p:txBody>
+      </p:sp>
+      <p:sp>
+        <p:nvSpPr>
+          <p:cNvPr id="200" name="proof"/>
+          <p:cNvSpPr txBox="1"/>
+          <p:nvPr/>
+        </p:nvSpPr>
+        <p:spPr>
+          <a:xfrm>
+            <a:off x="504000" y="3924000"/>
+            <a:ext cx="2106000" cy="576000"/>
           </a:xfrm>
           <a:prstGeom prst="roundRect">
             <a:avLst/>
@@ -567,41 +551,57 @@
           </a:solidFill>
           <a:ln w="6350">
             <a:solidFill>
-              <a:srgbClr val="E8F1FB"/>
+              <a:srgbClr val="D5E6F7"/>
             </a:solidFill>
           </a:ln>
         </p:spPr>
         <p:txBody>
-          <a:bodyPr wrap="square" lIns="14000" tIns="14000" rIns="14000" bIns="14000"/>
-          <a:lstStyle/>
-          <a:p>
-            <a:pPr>
-              <a:buNone/>
-            </a:pPr>
-            <a:r>
-              <a:rPr lang="ru-RU" sz="560" b="1">
+          <a:bodyPr wrap="square" lIns="12000" tIns="12000" rIns="12000" bIns="12000"/>
+          <a:lstStyle/>
+          <a:p>
+            <a:pPr>
+              <a:buNone/>
+            </a:pPr>
+            <a:r>
+              <a:rPr lang="ru-RU" sz="930" b="1">
                 <a:solidFill>
                   <a:srgbClr val="0F4778"/>
                 </a:solidFill>
                 <a:latin typeface="Arial"/>
                 <a:cs typeface="Arial"/>
               </a:rPr>
-              <a:t>АКБ +11% до 2,1 млн</a:t>
-            </a:r>
-            <a:endParaRPr lang="ru-RU" sz="560"/>
-          </a:p>
-        </p:txBody>
-      </p:sp>
-      <p:sp>
-        <p:nvSpPr>
-          <p:cNvPr id="201" name="tag"/>
-          <p:cNvSpPr txBox="1"/>
-          <p:nvPr/>
-        </p:nvSpPr>
-        <p:spPr>
-          <a:xfrm>
-            <a:off x="1512000" y="4752000"/>
-            <a:ext cx="720000" cy="205200"/>
+              <a:t>2,1 млн</a:t>
+            </a:r>
+            <a:endParaRPr lang="ru-RU" sz="930"/>
+          </a:p>
+          <a:p>
+            <a:pPr>
+              <a:buNone/>
+            </a:pPr>
+            <a:r>
+              <a:rPr lang="ru-RU" sz="465">
+                <a:solidFill>
+                  <a:srgbClr val="173A5E"/>
+                </a:solidFill>
+                <a:latin typeface="Arial"/>
+                <a:cs typeface="Arial"/>
+              </a:rPr>
+              <a:t>АКБ в Открытии после запуска пассивного и расчетного бизнеса; +11% при переходе к доходной модели</a:t>
+            </a:r>
+            <a:endParaRPr lang="ru-RU" sz="465"/>
+          </a:p>
+        </p:txBody>
+      </p:sp>
+      <p:sp>
+        <p:nvSpPr>
+          <p:cNvPr id="201" name="proof"/>
+          <p:cNvSpPr txBox="1"/>
+          <p:nvPr/>
+        </p:nvSpPr>
+        <p:spPr>
+          <a:xfrm>
+            <a:off x="2664000" y="3924000"/>
+            <a:ext cx="2106000" cy="576000"/>
           </a:xfrm>
           <a:prstGeom prst="roundRect">
             <a:avLst/>
@@ -611,19 +611,19 @@
           </a:solidFill>
           <a:ln w="6350">
             <a:solidFill>
-              <a:srgbClr val="E8F1FB"/>
+              <a:srgbClr val="D5E6F7"/>
             </a:solidFill>
           </a:ln>
         </p:spPr>
         <p:txBody>
-          <a:bodyPr wrap="square" lIns="14000" tIns="14000" rIns="14000" bIns="14000"/>
-          <a:lstStyle/>
-          <a:p>
-            <a:pPr>
-              <a:buNone/>
-            </a:pPr>
-            <a:r>
-              <a:rPr lang="ru-RU" sz="560" b="1">
+          <a:bodyPr wrap="square" lIns="12000" tIns="12000" rIns="12000" bIns="12000"/>
+          <a:lstStyle/>
+          <a:p>
+            <a:pPr>
+              <a:buNone/>
+            </a:pPr>
+            <a:r>
+              <a:rPr lang="ru-RU" sz="930" b="1">
                 <a:solidFill>
                   <a:srgbClr val="0F4778"/>
                 </a:solidFill>
@@ -632,20 +632,36 @@
               </a:rPr>
               <a:t>AUM +35%</a:t>
             </a:r>
-            <a:endParaRPr lang="ru-RU" sz="560"/>
-          </a:p>
-        </p:txBody>
-      </p:sp>
-      <p:sp>
-        <p:nvSpPr>
-          <p:cNvPr id="202" name="tag"/>
-          <p:cNvSpPr txBox="1"/>
-          <p:nvPr/>
-        </p:nvSpPr>
-        <p:spPr>
-          <a:xfrm>
-            <a:off x="2304000" y="4752000"/>
-            <a:ext cx="792000" cy="205200"/>
+            <a:endParaRPr lang="ru-RU" sz="930"/>
+          </a:p>
+          <a:p>
+            <a:pPr>
+              <a:buNone/>
+            </a:pPr>
+            <a:r>
+              <a:rPr lang="ru-RU" sz="465">
+                <a:solidFill>
+                  <a:srgbClr val="173A5E"/>
+                </a:solidFill>
+                <a:latin typeface="Arial"/>
+                <a:cs typeface="Arial"/>
+              </a:rPr>
+              <a:t>улучшение качества клиентского сегмента; транзакционный отток снижен в 3 раза</a:t>
+            </a:r>
+            <a:endParaRPr lang="ru-RU" sz="465"/>
+          </a:p>
+        </p:txBody>
+      </p:sp>
+      <p:sp>
+        <p:nvSpPr>
+          <p:cNvPr id="202" name="proof"/>
+          <p:cNvSpPr txBox="1"/>
+          <p:nvPr/>
+        </p:nvSpPr>
+        <p:spPr>
+          <a:xfrm>
+            <a:off x="504000" y="4554000"/>
+            <a:ext cx="2106000" cy="576000"/>
           </a:xfrm>
           <a:prstGeom prst="roundRect">
             <a:avLst/>
@@ -655,41 +671,57 @@
           </a:solidFill>
           <a:ln w="6350">
             <a:solidFill>
-              <a:srgbClr val="E8F1FB"/>
+              <a:srgbClr val="D5E6F7"/>
             </a:solidFill>
           </a:ln>
         </p:spPr>
         <p:txBody>
-          <a:bodyPr wrap="square" lIns="14000" tIns="14000" rIns="14000" bIns="14000"/>
-          <a:lstStyle/>
-          <a:p>
-            <a:pPr>
-              <a:buNone/>
-            </a:pPr>
-            <a:r>
-              <a:rPr lang="ru-RU" sz="560" b="1">
+          <a:bodyPr wrap="square" lIns="12000" tIns="12000" rIns="12000" bIns="12000"/>
+          <a:lstStyle/>
+          <a:p>
+            <a:pPr>
+              <a:buNone/>
+            </a:pPr>
+            <a:r>
+              <a:rPr lang="ru-RU" sz="930" b="1">
                 <a:solidFill>
                   <a:srgbClr val="0F4778"/>
                 </a:solidFill>
                 <a:latin typeface="Arial"/>
                 <a:cs typeface="Arial"/>
               </a:rPr>
-              <a:t>отток - в 3 раза</a:t>
-            </a:r>
-            <a:endParaRPr lang="ru-RU" sz="560"/>
-          </a:p>
-        </p:txBody>
-      </p:sp>
-      <p:sp>
-        <p:nvSpPr>
-          <p:cNvPr id="203" name="tag"/>
-          <p:cNvSpPr txBox="1"/>
-          <p:nvPr/>
-        </p:nvSpPr>
-        <p:spPr>
-          <a:xfrm>
-            <a:off x="3168000" y="4752000"/>
-            <a:ext cx="612000" cy="205200"/>
+              <a:t>N1 / 88% NTB</a:t>
+            </a:r>
+            <a:endParaRPr lang="ru-RU" sz="930"/>
+          </a:p>
+          <a:p>
+            <a:pPr>
+              <a:buNone/>
+            </a:pPr>
+            <a:r>
+              <a:rPr lang="ru-RU" sz="465">
+                <a:solidFill>
+                  <a:srgbClr val="173A5E"/>
+                </a:solidFill>
+                <a:latin typeface="Arial"/>
+                <a:cs typeface="Arial"/>
+              </a:rPr>
+              <a:t>автокредитование ВТБ24: stand-alone модель, 25% притока клиентов розницы</a:t>
+            </a:r>
+            <a:endParaRPr lang="ru-RU" sz="465"/>
+          </a:p>
+        </p:txBody>
+      </p:sp>
+      <p:sp>
+        <p:nvSpPr>
+          <p:cNvPr id="203" name="proof"/>
+          <p:cNvSpPr txBox="1"/>
+          <p:nvPr/>
+        </p:nvSpPr>
+        <p:spPr>
+          <a:xfrm>
+            <a:off x="2664000" y="4554000"/>
+            <a:ext cx="2106000" cy="576000"/>
           </a:xfrm>
           <a:prstGeom prst="roundRect">
             <a:avLst/>
@@ -699,129 +731,57 @@
           </a:solidFill>
           <a:ln w="6350">
             <a:solidFill>
-              <a:srgbClr val="E8F1FB"/>
+              <a:srgbClr val="D5E6F7"/>
             </a:solidFill>
           </a:ln>
         </p:spPr>
         <p:txBody>
-          <a:bodyPr wrap="square" lIns="14000" tIns="14000" rIns="14000" bIns="14000"/>
-          <a:lstStyle/>
-          <a:p>
-            <a:pPr>
-              <a:buNone/>
-            </a:pPr>
-            <a:r>
-              <a:rPr lang="ru-RU" sz="560" b="1">
+          <a:bodyPr wrap="square" lIns="12000" tIns="12000" rIns="12000" bIns="12000"/>
+          <a:lstStyle/>
+          <a:p>
+            <a:pPr>
+              <a:buNone/>
+            </a:pPr>
+            <a:r>
+              <a:rPr lang="ru-RU" sz="930" b="1">
                 <a:solidFill>
                   <a:srgbClr val="0F4778"/>
                 </a:solidFill>
                 <a:latin typeface="Arial"/>
                 <a:cs typeface="Arial"/>
               </a:rPr>
-              <a:t>N5 +3 п.п.</a:t>
-            </a:r>
-            <a:endParaRPr lang="ru-RU" sz="560"/>
-          </a:p>
-        </p:txBody>
-      </p:sp>
-      <p:sp>
-        <p:nvSpPr>
-          <p:cNvPr id="204" name="tag"/>
-          <p:cNvSpPr txBox="1"/>
-          <p:nvPr/>
-        </p:nvSpPr>
-        <p:spPr>
-          <a:xfrm>
-            <a:off x="504000" y="4982400"/>
-            <a:ext cx="936000" cy="205200"/>
-          </a:xfrm>
-          <a:prstGeom prst="roundRect">
-            <a:avLst/>
-          </a:prstGeom>
-          <a:solidFill>
-            <a:srgbClr val="E8F1FB"/>
-          </a:solidFill>
-          <a:ln w="6350">
-            <a:solidFill>
-              <a:srgbClr val="E8F1FB"/>
-            </a:solidFill>
-          </a:ln>
-        </p:spPr>
-        <p:txBody>
-          <a:bodyPr wrap="square" lIns="14000" tIns="14000" rIns="14000" bIns="14000"/>
-          <a:lstStyle/>
-          <a:p>
-            <a:pPr>
-              <a:buNone/>
-            </a:pPr>
-            <a:r>
-              <a:rPr lang="ru-RU" sz="560" b="1">
-                <a:solidFill>
-                  <a:srgbClr val="0F4778"/>
-                </a:solidFill>
-                <a:latin typeface="Arial"/>
-                <a:cs typeface="Arial"/>
-              </a:rPr>
-              <a:t>N1 автокредиты</a:t>
-            </a:r>
-            <a:endParaRPr lang="ru-RU" sz="560"/>
-          </a:p>
-        </p:txBody>
-      </p:sp>
-      <p:sp>
-        <p:nvSpPr>
-          <p:cNvPr id="205" name="tag"/>
-          <p:cNvSpPr txBox="1"/>
-          <p:nvPr/>
-        </p:nvSpPr>
-        <p:spPr>
-          <a:xfrm>
-            <a:off x="1512000" y="4982400"/>
-            <a:ext cx="540000" cy="205200"/>
-          </a:xfrm>
-          <a:prstGeom prst="roundRect">
-            <a:avLst/>
-          </a:prstGeom>
-          <a:solidFill>
-            <a:srgbClr val="E8F1FB"/>
-          </a:solidFill>
-          <a:ln w="6350">
-            <a:solidFill>
-              <a:srgbClr val="E8F1FB"/>
-            </a:solidFill>
-          </a:ln>
-        </p:spPr>
-        <p:txBody>
-          <a:bodyPr wrap="square" lIns="14000" tIns="14000" rIns="14000" bIns="14000"/>
-          <a:lstStyle/>
-          <a:p>
-            <a:pPr>
-              <a:buNone/>
-            </a:pPr>
-            <a:r>
-              <a:rPr lang="ru-RU" sz="560" b="1">
-                <a:solidFill>
-                  <a:srgbClr val="0F4778"/>
-                </a:solidFill>
-                <a:latin typeface="Arial"/>
-                <a:cs typeface="Arial"/>
-              </a:rPr>
-              <a:t>88% NTB</a:t>
-            </a:r>
-            <a:endParaRPr lang="ru-RU" sz="560"/>
-          </a:p>
-        </p:txBody>
-      </p:sp>
-      <p:sp>
-        <p:nvSpPr>
-          <p:cNvPr id="51" name="TRANSFORM - корректировка модели"/>
-          <p:cNvSpPr txBox="1"/>
-          <p:nvPr/>
-        </p:nvSpPr>
-        <p:spPr>
-          <a:xfrm>
-            <a:off x="396000" y="5472000"/>
-            <a:ext cx="4464000" cy="1764000"/>
+              <a:t>36-й месяц</a:t>
+            </a:r>
+            <a:endParaRPr lang="ru-RU" sz="930"/>
+          </a:p>
+          <a:p>
+            <a:pPr>
+              <a:buNone/>
+            </a:pPr>
+            <a:r>
+              <a:rPr lang="ru-RU" sz="465">
+                <a:solidFill>
+                  <a:srgbClr val="173A5E"/>
+                </a:solidFill>
+                <a:latin typeface="Arial"/>
+                <a:cs typeface="Arial"/>
+              </a:rPr>
+              <a:t>выход автокредитного бизнеса на прибыль с момента запуска</a:t>
+            </a:r>
+            <a:endParaRPr lang="ru-RU" sz="465"/>
+          </a:p>
+        </p:txBody>
+      </p:sp>
+      <p:sp>
+        <p:nvSpPr>
+          <p:cNvPr id="51" name="TRANSFORM - корректировка существующей модели"/>
+          <p:cNvSpPr txBox="1"/>
+          <p:nvPr/>
+        </p:nvSpPr>
+        <p:spPr>
+          <a:xfrm>
+            <a:off x="396000" y="5364000"/>
+            <a:ext cx="4500000" cy="1980000"/>
           </a:xfrm>
           <a:prstGeom prst="roundRect">
             <a:avLst/>
@@ -836,30 +796,30 @@
           </a:ln>
         </p:spPr>
         <p:txBody>
-          <a:bodyPr wrap="square" lIns="18500" tIns="18500" rIns="18500" bIns="18500"/>
-          <a:lstStyle/>
-          <a:p>
-            <a:pPr>
-              <a:buNone/>
-            </a:pPr>
-            <a:r>
-              <a:rPr lang="ru-RU" sz="740" b="1">
+          <a:bodyPr wrap="square" lIns="16000" tIns="16000" rIns="16000" bIns="16000"/>
+          <a:lstStyle/>
+          <a:p>
+            <a:pPr>
+              <a:buNone/>
+            </a:pPr>
+            <a:r>
+              <a:rPr lang="ru-RU" sz="690" b="1">
                 <a:solidFill>
                   <a:srgbClr val="173A5E"/>
                 </a:solidFill>
                 <a:latin typeface="Arial"/>
                 <a:cs typeface="Arial"/>
               </a:rPr>
-              <a:t>TRANSFORM - корректировка модели</a:t>
-            </a:r>
-            <a:endParaRPr lang="ru-RU" sz="740"/>
-          </a:p>
-          <a:p>
-            <a:pPr marL="155000" indent="-80000">
+              <a:t>TRANSFORM - корректировка существующей модели</a:t>
+            </a:r>
+            <a:endParaRPr lang="ru-RU" sz="690"/>
+          </a:p>
+          <a:p>
+            <a:pPr marL="135000" indent="-70000">
               <a:buChar char="•"/>
             </a:pPr>
             <a:r>
-              <a:rPr lang="ru-RU" sz="590">
+              <a:rPr lang="ru-RU" sz="520">
                 <a:solidFill>
                   <a:srgbClr val="1F2933"/>
                 </a:solidFill>
@@ -868,14 +828,14 @@
               </a:rPr>
               <a:t>Диагностирую модель бизнеса и определяю изменения под новые цели роста и доходности.</a:t>
             </a:r>
-            <a:endParaRPr lang="ru-RU" sz="590"/>
-          </a:p>
-          <a:p>
-            <a:pPr marL="155000" indent="-80000">
+            <a:endParaRPr lang="ru-RU" sz="520"/>
+          </a:p>
+          <a:p>
+            <a:pPr marL="135000" indent="-70000">
               <a:buChar char="•"/>
             </a:pPr>
             <a:r>
-              <a:rPr lang="ru-RU" sz="590">
+              <a:rPr lang="ru-RU" sz="520">
                 <a:solidFill>
                   <a:srgbClr val="1F2933"/>
                 </a:solidFill>
@@ -884,36 +844,20 @@
               </a:rPr>
               <a:t>Пересобираю стратегию, экономику привлечения, источники финансирования, продуктовые приоритеты и операционную модель.</a:t>
             </a:r>
-            <a:endParaRPr lang="ru-RU" sz="590"/>
-          </a:p>
-          <a:p>
-            <a:pPr marL="155000" indent="-80000">
-              <a:buChar char="•"/>
-            </a:pPr>
-            <a:r>
-              <a:rPr lang="ru-RU" sz="590">
-                <a:solidFill>
-                  <a:srgbClr val="1F2933"/>
-                </a:solidFill>
-                <a:latin typeface="Arial"/>
-                <a:cs typeface="Arial"/>
-              </a:rPr>
-              <a:t>Провожу изменения в работающем контуре банка: продукт, процессы, технологии, оргструктура и клиентский опыт.</a:t>
-            </a:r>
-            <a:endParaRPr lang="ru-RU" sz="590"/>
-          </a:p>
-        </p:txBody>
-      </p:sp>
-      <p:sp>
-        <p:nvSpPr>
-          <p:cNvPr id="206" name="tag"/>
-          <p:cNvSpPr txBox="1"/>
-          <p:nvPr/>
-        </p:nvSpPr>
-        <p:spPr>
-          <a:xfrm>
-            <a:off x="504000" y="6696000"/>
-            <a:ext cx="828000" cy="205200"/>
+            <a:endParaRPr lang="ru-RU" sz="520"/>
+          </a:p>
+        </p:txBody>
+      </p:sp>
+      <p:sp>
+        <p:nvSpPr>
+          <p:cNvPr id="204" name="proof"/>
+          <p:cNvSpPr txBox="1"/>
+          <p:nvPr/>
+        </p:nvSpPr>
+        <p:spPr>
+          <a:xfrm>
+            <a:off x="504000" y="6048000"/>
+            <a:ext cx="2106000" cy="576000"/>
           </a:xfrm>
           <a:prstGeom prst="roundRect">
             <a:avLst/>
@@ -923,41 +867,57 @@
           </a:solidFill>
           <a:ln w="6350">
             <a:solidFill>
-              <a:srgbClr val="E8F1FB"/>
+              <a:srgbClr val="D5E6F7"/>
             </a:solidFill>
           </a:ln>
         </p:spPr>
         <p:txBody>
-          <a:bodyPr wrap="square" lIns="14000" tIns="14000" rIns="14000" bIns="14000"/>
-          <a:lstStyle/>
-          <a:p>
-            <a:pPr>
-              <a:buNone/>
-            </a:pPr>
-            <a:r>
-              <a:rPr lang="ru-RU" sz="560" b="1">
+          <a:bodyPr wrap="square" lIns="12000" tIns="12000" rIns="12000" bIns="12000"/>
+          <a:lstStyle/>
+          <a:p>
+            <a:pPr>
+              <a:buNone/>
+            </a:pPr>
+            <a:r>
+              <a:rPr lang="ru-RU" sz="930" b="1">
                 <a:solidFill>
                   <a:srgbClr val="0F4778"/>
                 </a:solidFill>
                 <a:latin typeface="Arial"/>
                 <a:cs typeface="Arial"/>
               </a:rPr>
-              <a:t>25 млн клиентов</a:t>
-            </a:r>
-            <a:endParaRPr lang="ru-RU" sz="560"/>
-          </a:p>
-        </p:txBody>
-      </p:sp>
-      <p:sp>
-        <p:nvSpPr>
-          <p:cNvPr id="207" name="tag"/>
-          <p:cNvSpPr txBox="1"/>
-          <p:nvPr/>
-        </p:nvSpPr>
-        <p:spPr>
-          <a:xfrm>
-            <a:off x="1404000" y="6696000"/>
-            <a:ext cx="756000" cy="205200"/>
+              <a:t>25 млн</a:t>
+            </a:r>
+            <a:endParaRPr lang="ru-RU" sz="930"/>
+          </a:p>
+          <a:p>
+            <a:pPr>
+              <a:buNone/>
+            </a:pPr>
+            <a:r>
+              <a:rPr lang="ru-RU" sz="465">
+                <a:solidFill>
+                  <a:srgbClr val="173A5E"/>
+                </a:solidFill>
+                <a:latin typeface="Arial"/>
+                <a:cs typeface="Arial"/>
+              </a:rPr>
+              <a:t>клиентов в дебетовых картах и расчетных продуктах ВТБ после корректировки стратегии</a:t>
+            </a:r>
+            <a:endParaRPr lang="ru-RU" sz="465"/>
+          </a:p>
+        </p:txBody>
+      </p:sp>
+      <p:sp>
+        <p:nvSpPr>
+          <p:cNvPr id="205" name="proof"/>
+          <p:cNvSpPr txBox="1"/>
+          <p:nvPr/>
+        </p:nvSpPr>
+        <p:spPr>
+          <a:xfrm>
+            <a:off x="2664000" y="6048000"/>
+            <a:ext cx="2106000" cy="576000"/>
           </a:xfrm>
           <a:prstGeom prst="roundRect">
             <a:avLst/>
@@ -967,19 +927,19 @@
           </a:solidFill>
           <a:ln w="6350">
             <a:solidFill>
-              <a:srgbClr val="E8F1FB"/>
+              <a:srgbClr val="D5E6F7"/>
             </a:solidFill>
           </a:ln>
         </p:spPr>
         <p:txBody>
-          <a:bodyPr wrap="square" lIns="14000" tIns="14000" rIns="14000" bIns="14000"/>
-          <a:lstStyle/>
-          <a:p>
-            <a:pPr>
-              <a:buNone/>
-            </a:pPr>
-            <a:r>
-              <a:rPr lang="ru-RU" sz="560" b="1">
+          <a:bodyPr wrap="square" lIns="12000" tIns="12000" rIns="12000" bIns="12000"/>
+          <a:lstStyle/>
+          <a:p>
+            <a:pPr>
+              <a:buNone/>
+            </a:pPr>
+            <a:r>
+              <a:rPr lang="ru-RU" sz="930" b="1">
                 <a:solidFill>
                   <a:srgbClr val="0F4778"/>
                 </a:solidFill>
@@ -988,20 +948,36 @@
               </a:rPr>
               <a:t>+25% YoY</a:t>
             </a:r>
-            <a:endParaRPr lang="ru-RU" sz="560"/>
-          </a:p>
-        </p:txBody>
-      </p:sp>
-      <p:sp>
-        <p:nvSpPr>
-          <p:cNvPr id="208" name="tag"/>
-          <p:cNvSpPr txBox="1"/>
-          <p:nvPr/>
-        </p:nvSpPr>
-        <p:spPr>
-          <a:xfrm>
-            <a:off x="2232000" y="6696000"/>
-            <a:ext cx="612000" cy="205200"/>
+            <a:endParaRPr lang="ru-RU" sz="930"/>
+          </a:p>
+          <a:p>
+            <a:pPr>
+              <a:buNone/>
+            </a:pPr>
+            <a:r>
+              <a:rPr lang="ru-RU" sz="465">
+                <a:solidFill>
+                  <a:srgbClr val="173A5E"/>
+                </a:solidFill>
+                <a:latin typeface="Arial"/>
+                <a:cs typeface="Arial"/>
+              </a:rPr>
+              <a:t>рост активной клиентской базы за счет продуктовых, маркетинговых и дистрибуционных изменений</a:t>
+            </a:r>
+            <a:endParaRPr lang="ru-RU" sz="465"/>
+          </a:p>
+        </p:txBody>
+      </p:sp>
+      <p:sp>
+        <p:nvSpPr>
+          <p:cNvPr id="206" name="proof"/>
+          <p:cNvSpPr txBox="1"/>
+          <p:nvPr/>
+        </p:nvSpPr>
+        <p:spPr>
+          <a:xfrm>
+            <a:off x="504000" y="6678000"/>
+            <a:ext cx="2106000" cy="576000"/>
           </a:xfrm>
           <a:prstGeom prst="roundRect">
             <a:avLst/>
@@ -1011,19 +987,19 @@
           </a:solidFill>
           <a:ln w="6350">
             <a:solidFill>
-              <a:srgbClr val="E8F1FB"/>
+              <a:srgbClr val="D5E6F7"/>
             </a:solidFill>
           </a:ln>
         </p:spPr>
         <p:txBody>
-          <a:bodyPr wrap="square" lIns="14000" tIns="14000" rIns="14000" bIns="14000"/>
-          <a:lstStyle/>
-          <a:p>
-            <a:pPr>
-              <a:buNone/>
-            </a:pPr>
-            <a:r>
-              <a:rPr lang="ru-RU" sz="560" b="1">
+          <a:bodyPr wrap="square" lIns="12000" tIns="12000" rIns="12000" bIns="12000"/>
+          <a:lstStyle/>
+          <a:p>
+            <a:pPr>
+              <a:buNone/>
+            </a:pPr>
+            <a:r>
+              <a:rPr lang="ru-RU" sz="930" b="1">
                 <a:solidFill>
                   <a:srgbClr val="0F4778"/>
                 </a:solidFill>
@@ -1032,20 +1008,36 @@
               </a:rPr>
               <a:t>N2 по АКБ</a:t>
             </a:r>
-            <a:endParaRPr lang="ru-RU" sz="560"/>
-          </a:p>
-        </p:txBody>
-      </p:sp>
-      <p:sp>
-        <p:nvSpPr>
-          <p:cNvPr id="209" name="tag"/>
-          <p:cNvSpPr txBox="1"/>
-          <p:nvPr/>
-        </p:nvSpPr>
-        <p:spPr>
-          <a:xfrm>
-            <a:off x="2916000" y="6696000"/>
-            <a:ext cx="1224000" cy="205200"/>
+            <a:endParaRPr lang="ru-RU" sz="930"/>
+          </a:p>
+          <a:p>
+            <a:pPr>
+              <a:buNone/>
+            </a:pPr>
+            <a:r>
+              <a:rPr lang="ru-RU" sz="465">
+                <a:solidFill>
+                  <a:srgbClr val="173A5E"/>
+                </a:solidFill>
+                <a:latin typeface="Arial"/>
+                <a:cs typeface="Arial"/>
+              </a:rPr>
+              <a:t>итоговая рыночная позиция направления после трансформации модели работы</a:t>
+            </a:r>
+            <a:endParaRPr lang="ru-RU" sz="465"/>
+          </a:p>
+        </p:txBody>
+      </p:sp>
+      <p:sp>
+        <p:nvSpPr>
+          <p:cNvPr id="207" name="proof"/>
+          <p:cNvSpPr txBox="1"/>
+          <p:nvPr/>
+        </p:nvSpPr>
+        <p:spPr>
+          <a:xfrm>
+            <a:off x="2664000" y="6678000"/>
+            <a:ext cx="2106000" cy="576000"/>
           </a:xfrm>
           <a:prstGeom prst="roundRect">
             <a:avLst/>
@@ -1055,85 +1047,57 @@
           </a:solidFill>
           <a:ln w="6350">
             <a:solidFill>
-              <a:srgbClr val="E8F1FB"/>
+              <a:srgbClr val="D5E6F7"/>
             </a:solidFill>
           </a:ln>
         </p:spPr>
         <p:txBody>
-          <a:bodyPr wrap="square" lIns="14000" tIns="14000" rIns="14000" bIns="14000"/>
-          <a:lstStyle/>
-          <a:p>
-            <a:pPr>
-              <a:buNone/>
-            </a:pPr>
-            <a:r>
-              <a:rPr lang="ru-RU" sz="560" b="1">
+          <a:bodyPr wrap="square" lIns="12000" tIns="12000" rIns="12000" bIns="12000"/>
+          <a:lstStyle/>
+          <a:p>
+            <a:pPr>
+              <a:buNone/>
+            </a:pPr>
+            <a:r>
+              <a:rPr lang="ru-RU" sz="930" b="1">
                 <a:solidFill>
                   <a:srgbClr val="0F4778"/>
                 </a:solidFill>
                 <a:latin typeface="Arial"/>
                 <a:cs typeface="Arial"/>
               </a:rPr>
-              <a:t>масштабная IT-трансформация</a:t>
-            </a:r>
-            <a:endParaRPr lang="ru-RU" sz="560"/>
-          </a:p>
-        </p:txBody>
-      </p:sp>
-      <p:sp>
-        <p:nvSpPr>
-          <p:cNvPr id="210" name="tag"/>
-          <p:cNvSpPr txBox="1"/>
-          <p:nvPr/>
-        </p:nvSpPr>
-        <p:spPr>
-          <a:xfrm>
-            <a:off x="504000" y="6926400"/>
-            <a:ext cx="1008000" cy="205200"/>
-          </a:xfrm>
-          <a:prstGeom prst="roundRect">
-            <a:avLst/>
-          </a:prstGeom>
-          <a:solidFill>
-            <a:srgbClr val="E8F1FB"/>
-          </a:solidFill>
-          <a:ln w="6350">
-            <a:solidFill>
-              <a:srgbClr val="E8F1FB"/>
-            </a:solidFill>
-          </a:ln>
-        </p:spPr>
-        <p:txBody>
-          <a:bodyPr wrap="square" lIns="14000" tIns="14000" rIns="14000" bIns="14000"/>
-          <a:lstStyle/>
-          <a:p>
-            <a:pPr>
-              <a:buNone/>
-            </a:pPr>
-            <a:r>
-              <a:rPr lang="ru-RU" sz="560" b="1">
-                <a:solidFill>
-                  <a:srgbClr val="0F4778"/>
-                </a:solidFill>
-                <a:latin typeface="Arial"/>
-                <a:cs typeface="Arial"/>
-              </a:rPr>
-              <a:t>P&amp;L / CIR / pNPS</a:t>
-            </a:r>
-            <a:endParaRPr lang="ru-RU" sz="560"/>
-          </a:p>
-        </p:txBody>
-      </p:sp>
-      <p:sp>
-        <p:nvSpPr>
-          <p:cNvPr id="52" name="LEAD - сложные программы"/>
-          <p:cNvSpPr txBox="1"/>
-          <p:nvPr/>
-        </p:nvSpPr>
-        <p:spPr>
-          <a:xfrm>
-            <a:off x="396000" y="7416000"/>
-            <a:ext cx="4464000" cy="1764000"/>
+              <a:t>IT-трансформация</a:t>
+            </a:r>
+            <a:endParaRPr lang="ru-RU" sz="930"/>
+          </a:p>
+          <a:p>
+            <a:pPr>
+              <a:buNone/>
+            </a:pPr>
+            <a:r>
+              <a:rPr lang="ru-RU" sz="465">
+                <a:solidFill>
+                  <a:srgbClr val="173A5E"/>
+                </a:solidFill>
+                <a:latin typeface="Arial"/>
+                <a:cs typeface="Arial"/>
+              </a:rPr>
+              <a:t>продукт, маркетинг и каналы изменены параллельно с технологической программой</a:t>
+            </a:r>
+            <a:endParaRPr lang="ru-RU" sz="465"/>
+          </a:p>
+        </p:txBody>
+      </p:sp>
+      <p:sp>
+        <p:nvSpPr>
+          <p:cNvPr id="52" name="LEAD - сложные программы с большим количеством участников"/>
+          <p:cNvSpPr txBox="1"/>
+          <p:nvPr/>
+        </p:nvSpPr>
+        <p:spPr>
+          <a:xfrm>
+            <a:off x="396000" y="7488000"/>
+            <a:ext cx="4500000" cy="1980000"/>
           </a:xfrm>
           <a:prstGeom prst="roundRect">
             <a:avLst/>
@@ -1148,30 +1112,30 @@
           </a:ln>
         </p:spPr>
         <p:txBody>
-          <a:bodyPr wrap="square" lIns="18500" tIns="18500" rIns="18500" bIns="18500"/>
-          <a:lstStyle/>
-          <a:p>
-            <a:pPr>
-              <a:buNone/>
-            </a:pPr>
-            <a:r>
-              <a:rPr lang="ru-RU" sz="740" b="1">
+          <a:bodyPr wrap="square" lIns="16000" tIns="16000" rIns="16000" bIns="16000"/>
+          <a:lstStyle/>
+          <a:p>
+            <a:pPr>
+              <a:buNone/>
+            </a:pPr>
+            <a:r>
+              <a:rPr lang="ru-RU" sz="690" b="1">
                 <a:solidFill>
                   <a:srgbClr val="173A5E"/>
                 </a:solidFill>
                 <a:latin typeface="Arial"/>
                 <a:cs typeface="Arial"/>
               </a:rPr>
-              <a:t>LEAD - сложные программы</a:t>
-            </a:r>
-            <a:endParaRPr lang="ru-RU" sz="740"/>
-          </a:p>
-          <a:p>
-            <a:pPr marL="155000" indent="-80000">
+              <a:t>LEAD - сложные программы с большим количеством участников</a:t>
+            </a:r>
+            <a:endParaRPr lang="ru-RU" sz="690"/>
+          </a:p>
+          <a:p>
+            <a:pPr marL="135000" indent="-70000">
               <a:buChar char="•"/>
             </a:pPr>
             <a:r>
-              <a:rPr lang="ru-RU" sz="590">
+              <a:rPr lang="ru-RU" sz="520">
                 <a:solidFill>
                   <a:srgbClr val="1F2933"/>
                 </a:solidFill>
@@ -1180,52 +1144,36 @@
               </a:rPr>
               <a:t>Формирую концепт, систему принятия решений и общие цели для бизнеса, IT, операций, продаж, маркетинга, регулятора и партнеров.</a:t>
             </a:r>
-            <a:endParaRPr lang="ru-RU" sz="590"/>
-          </a:p>
-          <a:p>
-            <a:pPr marL="155000" indent="-80000">
+            <a:endParaRPr lang="ru-RU" sz="520"/>
+          </a:p>
+          <a:p>
+            <a:pPr marL="135000" indent="-70000">
               <a:buChar char="•"/>
             </a:pPr>
             <a:r>
-              <a:rPr lang="ru-RU" sz="590">
+              <a:rPr lang="ru-RU" sz="520">
                 <a:solidFill>
                   <a:srgbClr val="1F2933"/>
                 </a:solidFill>
                 <a:latin typeface="Arial"/>
                 <a:cs typeface="Arial"/>
               </a:rPr>
-              <a:t>Организую Agile-команды и крупные delivery-программы; удерживаю результат в условиях высокой сложности.</a:t>
-            </a:r>
-            <a:endParaRPr lang="ru-RU" sz="590"/>
-          </a:p>
-          <a:p>
-            <a:pPr marL="155000" indent="-80000">
-              <a:buChar char="•"/>
-            </a:pPr>
-            <a:r>
-              <a:rPr lang="ru-RU" sz="590">
-                <a:solidFill>
-                  <a:srgbClr val="1F2933"/>
-                </a:solidFill>
-                <a:latin typeface="Arial"/>
-                <a:cs typeface="Arial"/>
-              </a:rPr>
-              <a:t>Обеспечиваю бесшовность критичных изменений для клиентов и операционного контура.</a:t>
-            </a:r>
-            <a:endParaRPr lang="ru-RU" sz="590"/>
-          </a:p>
-        </p:txBody>
-      </p:sp>
-      <p:sp>
-        <p:nvSpPr>
-          <p:cNvPr id="211" name="tag"/>
-          <p:cNvSpPr txBox="1"/>
-          <p:nvPr/>
-        </p:nvSpPr>
-        <p:spPr>
-          <a:xfrm>
-            <a:off x="504000" y="8640000"/>
-            <a:ext cx="1296000" cy="205200"/>
+              <a:t>Организую Agile-команды и крупные delivery-программы; обеспечиваю бесшовность критичных изменений для клиентов.</a:t>
+            </a:r>
+            <a:endParaRPr lang="ru-RU" sz="520"/>
+          </a:p>
+        </p:txBody>
+      </p:sp>
+      <p:sp>
+        <p:nvSpPr>
+          <p:cNvPr id="208" name="proof"/>
+          <p:cNvSpPr txBox="1"/>
+          <p:nvPr/>
+        </p:nvSpPr>
+        <p:spPr>
+          <a:xfrm>
+            <a:off x="504000" y="8172000"/>
+            <a:ext cx="2106000" cy="576000"/>
           </a:xfrm>
           <a:prstGeom prst="roundRect">
             <a:avLst/>
@@ -1235,41 +1183,57 @@
           </a:solidFill>
           <a:ln w="6350">
             <a:solidFill>
-              <a:srgbClr val="E8F1FB"/>
+              <a:srgbClr val="D5E6F7"/>
             </a:solidFill>
           </a:ln>
         </p:spPr>
         <p:txBody>
-          <a:bodyPr wrap="square" lIns="14000" tIns="14000" rIns="14000" bIns="14000"/>
-          <a:lstStyle/>
-          <a:p>
-            <a:pPr>
-              <a:buNone/>
-            </a:pPr>
-            <a:r>
-              <a:rPr lang="ru-RU" sz="560" b="1">
+          <a:bodyPr wrap="square" lIns="12000" tIns="12000" rIns="12000" bIns="12000"/>
+          <a:lstStyle/>
+          <a:p>
+            <a:pPr>
+              <a:buNone/>
+            </a:pPr>
+            <a:r>
+              <a:rPr lang="ru-RU" sz="930" b="1">
                 <a:solidFill>
                   <a:srgbClr val="0F4778"/>
                 </a:solidFill>
                 <a:latin typeface="Arial"/>
                 <a:cs typeface="Arial"/>
               </a:rPr>
-              <a:t>1,5 млн / 8 процессингов</a:t>
-            </a:r>
-            <a:endParaRPr lang="ru-RU" sz="560"/>
-          </a:p>
-        </p:txBody>
-      </p:sp>
-      <p:sp>
-        <p:nvSpPr>
-          <p:cNvPr id="212" name="tag"/>
-          <p:cNvSpPr txBox="1"/>
-          <p:nvPr/>
-        </p:nvSpPr>
-        <p:spPr>
-          <a:xfrm>
-            <a:off x="1872000" y="8640000"/>
-            <a:ext cx="900000" cy="205200"/>
+              <a:t>20 млн</a:t>
+            </a:r>
+            <a:endParaRPr lang="ru-RU" sz="930"/>
+          </a:p>
+          <a:p>
+            <a:pPr>
+              <a:buNone/>
+            </a:pPr>
+            <a:r>
+              <a:rPr lang="ru-RU" sz="465">
+                <a:solidFill>
+                  <a:srgbClr val="173A5E"/>
+                </a:solidFill>
+                <a:latin typeface="Arial"/>
+                <a:cs typeface="Arial"/>
+              </a:rPr>
+              <a:t>действующих клиентов ВТБ переведены на новый процессинг без простоя в операциях</a:t>
+            </a:r>
+            <a:endParaRPr lang="ru-RU" sz="465"/>
+          </a:p>
+        </p:txBody>
+      </p:sp>
+      <p:sp>
+        <p:nvSpPr>
+          <p:cNvPr id="209" name="proof"/>
+          <p:cNvSpPr txBox="1"/>
+          <p:nvPr/>
+        </p:nvSpPr>
+        <p:spPr>
+          <a:xfrm>
+            <a:off x="2664000" y="8172000"/>
+            <a:ext cx="2106000" cy="576000"/>
           </a:xfrm>
           <a:prstGeom prst="roundRect">
             <a:avLst/>
@@ -1279,41 +1243,57 @@
           </a:solidFill>
           <a:ln w="6350">
             <a:solidFill>
-              <a:srgbClr val="E8F1FB"/>
+              <a:srgbClr val="D5E6F7"/>
             </a:solidFill>
           </a:ln>
         </p:spPr>
         <p:txBody>
-          <a:bodyPr wrap="square" lIns="14000" tIns="14000" rIns="14000" bIns="14000"/>
-          <a:lstStyle/>
-          <a:p>
-            <a:pPr>
-              <a:buNone/>
-            </a:pPr>
-            <a:r>
-              <a:rPr lang="ru-RU" sz="560" b="1">
+          <a:bodyPr wrap="square" lIns="12000" tIns="12000" rIns="12000" bIns="12000"/>
+          <a:lstStyle/>
+          <a:p>
+            <a:pPr>
+              <a:buNone/>
+            </a:pPr>
+            <a:r>
+              <a:rPr lang="ru-RU" sz="930" b="1">
                 <a:solidFill>
                   <a:srgbClr val="0F4778"/>
                 </a:solidFill>
                 <a:latin typeface="Arial"/>
                 <a:cs typeface="Arial"/>
               </a:rPr>
-              <a:t>20 млн без простоя</a:t>
-            </a:r>
-            <a:endParaRPr lang="ru-RU" sz="560"/>
-          </a:p>
-        </p:txBody>
-      </p:sp>
-      <p:sp>
-        <p:nvSpPr>
-          <p:cNvPr id="213" name="tag"/>
-          <p:cNvSpPr txBox="1"/>
-          <p:nvPr/>
-        </p:nvSpPr>
-        <p:spPr>
-          <a:xfrm>
-            <a:off x="2844000" y="8640000"/>
-            <a:ext cx="1044000" cy="205200"/>
+              <a:t>2 млн / 8 мес.</a:t>
+            </a:r>
+            <a:endParaRPr lang="ru-RU" sz="930"/>
+          </a:p>
+          <a:p>
+            <a:pPr>
+              <a:buNone/>
+            </a:pPr>
+            <a:r>
+              <a:rPr lang="ru-RU" sz="465">
+                <a:solidFill>
+                  <a:srgbClr val="173A5E"/>
+                </a:solidFill>
+                <a:latin typeface="Arial"/>
+                <a:cs typeface="Arial"/>
+              </a:rPr>
+              <a:t>детей с Пушкинскими картами мигрированы в федеральном проекте</a:t>
+            </a:r>
+            <a:endParaRPr lang="ru-RU" sz="465"/>
+          </a:p>
+        </p:txBody>
+      </p:sp>
+      <p:sp>
+        <p:nvSpPr>
+          <p:cNvPr id="210" name="proof"/>
+          <p:cNvSpPr txBox="1"/>
+          <p:nvPr/>
+        </p:nvSpPr>
+        <p:spPr>
+          <a:xfrm>
+            <a:off x="504000" y="8802000"/>
+            <a:ext cx="2106000" cy="576000"/>
           </a:xfrm>
           <a:prstGeom prst="roundRect">
             <a:avLst/>
@@ -1323,41 +1303,57 @@
           </a:solidFill>
           <a:ln w="6350">
             <a:solidFill>
-              <a:srgbClr val="E8F1FB"/>
+              <a:srgbClr val="D5E6F7"/>
             </a:solidFill>
           </a:ln>
         </p:spPr>
         <p:txBody>
-          <a:bodyPr wrap="square" lIns="14000" tIns="14000" rIns="14000" bIns="14000"/>
-          <a:lstStyle/>
-          <a:p>
-            <a:pPr>
-              <a:buNone/>
-            </a:pPr>
-            <a:r>
-              <a:rPr lang="ru-RU" sz="560" b="1">
+          <a:bodyPr wrap="square" lIns="12000" tIns="12000" rIns="12000" bIns="12000"/>
+          <a:lstStyle/>
+          <a:p>
+            <a:pPr>
+              <a:buNone/>
+            </a:pPr>
+            <a:r>
+              <a:rPr lang="ru-RU" sz="930" b="1">
                 <a:solidFill>
                   <a:srgbClr val="0F4778"/>
                 </a:solidFill>
                 <a:latin typeface="Arial"/>
                 <a:cs typeface="Arial"/>
               </a:rPr>
-              <a:t>2 млн детей / 8 мес.</a:t>
-            </a:r>
-            <a:endParaRPr lang="ru-RU" sz="560"/>
-          </a:p>
-        </p:txBody>
-      </p:sp>
-      <p:sp>
-        <p:nvSpPr>
-          <p:cNvPr id="214" name="tag"/>
-          <p:cNvSpPr txBox="1"/>
-          <p:nvPr/>
-        </p:nvSpPr>
-        <p:spPr>
-          <a:xfrm>
-            <a:off x="504000" y="8870400"/>
-            <a:ext cx="1008000" cy="205200"/>
+              <a:t>1,5 млн / 8</a:t>
+            </a:r>
+            <a:endParaRPr lang="ru-RU" sz="930"/>
+          </a:p>
+          <a:p>
+            <a:pPr>
+              <a:buNone/>
+            </a:pPr>
+            <a:r>
+              <a:rPr lang="ru-RU" sz="465">
+                <a:solidFill>
+                  <a:srgbClr val="173A5E"/>
+                </a:solidFill>
+                <a:latin typeface="Arial"/>
+                <a:cs typeface="Arial"/>
+              </a:rPr>
+              <a:t>клиентов Открытия мигрированы на разных продуктовых линейках и 8 процессингах</a:t>
+            </a:r>
+            <a:endParaRPr lang="ru-RU" sz="465"/>
+          </a:p>
+        </p:txBody>
+      </p:sp>
+      <p:sp>
+        <p:nvSpPr>
+          <p:cNvPr id="211" name="proof"/>
+          <p:cNvSpPr txBox="1"/>
+          <p:nvPr/>
+        </p:nvSpPr>
+        <p:spPr>
+          <a:xfrm>
+            <a:off x="2664000" y="8802000"/>
+            <a:ext cx="2106000" cy="576000"/>
           </a:xfrm>
           <a:prstGeom prst="roundRect">
             <a:avLst/>
@@ -1367,72 +1363,44 @@
           </a:solidFill>
           <a:ln w="6350">
             <a:solidFill>
-              <a:srgbClr val="E8F1FB"/>
+              <a:srgbClr val="D5E6F7"/>
             </a:solidFill>
           </a:ln>
         </p:spPr>
         <p:txBody>
-          <a:bodyPr wrap="square" lIns="14000" tIns="14000" rIns="14000" bIns="14000"/>
-          <a:lstStyle/>
-          <a:p>
-            <a:pPr>
-              <a:buNone/>
-            </a:pPr>
-            <a:r>
-              <a:rPr lang="ru-RU" sz="560" b="1">
+          <a:bodyPr wrap="square" lIns="12000" tIns="12000" rIns="12000" bIns="12000"/>
+          <a:lstStyle/>
+          <a:p>
+            <a:pPr>
+              <a:buNone/>
+            </a:pPr>
+            <a:r>
+              <a:rPr lang="ru-RU" sz="930" b="1">
                 <a:solidFill>
                   <a:srgbClr val="0F4778"/>
                 </a:solidFill>
                 <a:latin typeface="Arial"/>
                 <a:cs typeface="Arial"/>
               </a:rPr>
-              <a:t>170 чел. / 12 команд</a:t>
-            </a:r>
-            <a:endParaRPr lang="ru-RU" sz="560"/>
-          </a:p>
-        </p:txBody>
-      </p:sp>
-      <p:sp>
-        <p:nvSpPr>
-          <p:cNvPr id="215" name="tag"/>
-          <p:cNvSpPr txBox="1"/>
-          <p:nvPr/>
-        </p:nvSpPr>
-        <p:spPr>
-          <a:xfrm>
-            <a:off x="1584000" y="8870400"/>
-            <a:ext cx="648000" cy="205200"/>
-          </a:xfrm>
-          <a:prstGeom prst="roundRect">
-            <a:avLst/>
-          </a:prstGeom>
-          <a:solidFill>
-            <a:srgbClr val="E8F1FB"/>
-          </a:solidFill>
-          <a:ln w="6350">
-            <a:solidFill>
-              <a:srgbClr val="E8F1FB"/>
-            </a:solidFill>
-          </a:ln>
-        </p:spPr>
-        <p:txBody>
-          <a:bodyPr wrap="square" lIns="14000" tIns="14000" rIns="14000" bIns="14000"/>
-          <a:lstStyle/>
-          <a:p>
-            <a:pPr>
-              <a:buNone/>
-            </a:pPr>
-            <a:r>
-              <a:rPr lang="ru-RU" sz="560" b="1">
-                <a:solidFill>
-                  <a:srgbClr val="0F4778"/>
-                </a:solidFill>
-                <a:latin typeface="Arial"/>
-                <a:cs typeface="Arial"/>
-              </a:rPr>
-              <a:t>SDN-контур</a:t>
-            </a:r>
-            <a:endParaRPr lang="ru-RU" sz="560"/>
+              <a:t>170 / 12</a:t>
+            </a:r>
+            <a:endParaRPr lang="ru-RU" sz="930"/>
+          </a:p>
+          <a:p>
+            <a:pPr>
+              <a:buNone/>
+            </a:pPr>
+            <a:r>
+              <a:rPr lang="ru-RU" sz="465">
+                <a:solidFill>
+                  <a:srgbClr val="173A5E"/>
+                </a:solidFill>
+                <a:latin typeface="Arial"/>
+                <a:cs typeface="Arial"/>
+              </a:rPr>
+              <a:t>масштаб delivery: 170 человек, продукт + IT, штат/аутсорс, 12 команд</a:t>
+            </a:r>
+            <a:endParaRPr lang="ru-RU" sz="465"/>
           </a:p>
         </p:txBody>
       </p:sp>
@@ -1444,7 +1412,7 @@
         </p:nvSpPr>
         <p:spPr>
           <a:xfrm>
-            <a:off x="5112000" y="3132000"/>
+            <a:off x="5112000" y="2880000"/>
             <a:ext cx="2052000" cy="216000"/>
           </a:xfrm>
           <a:prstGeom prst="rect">
@@ -1463,7 +1431,7 @@
               <a:buNone/>
             </a:pPr>
             <a:r>
-              <a:rPr lang="ru-RU" sz="820" b="1">
+              <a:rPr lang="ru-RU" sz="780" b="1">
                 <a:solidFill>
                   <a:srgbClr val="0F2742"/>
                 </a:solidFill>
@@ -1472,7 +1440,7 @@
               </a:rPr>
               <a:t>ЦЕЛЕВЫЕ РОЛИ</a:t>
             </a:r>
-            <a:endParaRPr lang="ru-RU" sz="820"/>
+            <a:endParaRPr lang="ru-RU" sz="780"/>
           </a:p>
         </p:txBody>
       </p:sp>
@@ -1484,7 +1452,7 @@
         </p:nvSpPr>
         <p:spPr>
           <a:xfrm>
-            <a:off x="5112000" y="3384000"/>
+            <a:off x="5112000" y="3132000"/>
             <a:ext cx="2052000" cy="9000"/>
           </a:xfrm>
           <a:prstGeom prst="rect">
@@ -1506,8 +1474,8 @@
         </p:nvSpPr>
         <p:spPr>
           <a:xfrm>
-            <a:off x="5112000" y="3528000"/>
-            <a:ext cx="2052000" cy="1440000"/>
+            <a:off x="5112000" y="3276000"/>
+            <a:ext cx="2052000" cy="1404000"/>
           </a:xfrm>
           <a:prstGeom prst="rect">
             <a:avLst/>
@@ -1525,7 +1493,7 @@
               <a:buNone/>
             </a:pPr>
             <a:r>
-              <a:rPr lang="ru-RU" sz="630">
+              <a:rPr lang="ru-RU" sz="600">
                 <a:solidFill>
                   <a:srgbClr val="1F2933"/>
                 </a:solidFill>
@@ -1534,7 +1502,7 @@
               </a:rPr>
               <a:t>Chief Business Officer / Chief Product Officer / Chief Operating Officer / Head of Retail Banking / Managing Director по розничному бизнесу, продуктам, платежам, клиентским платформам или трансформации финансового бизнеса.</a:t>
             </a:r>
-            <a:endParaRPr lang="ru-RU" sz="630"/>
+            <a:endParaRPr lang="ru-RU" sz="600"/>
           </a:p>
         </p:txBody>
       </p:sp>
@@ -1546,7 +1514,7 @@
         </p:nvSpPr>
         <p:spPr>
           <a:xfrm>
-            <a:off x="5112000" y="5148000"/>
+            <a:off x="5112000" y="4932000"/>
             <a:ext cx="2052000" cy="216000"/>
           </a:xfrm>
           <a:prstGeom prst="rect">
@@ -1565,7 +1533,7 @@
               <a:buNone/>
             </a:pPr>
             <a:r>
-              <a:rPr lang="ru-RU" sz="820" b="1">
+              <a:rPr lang="ru-RU" sz="780" b="1">
                 <a:solidFill>
                   <a:srgbClr val="0F2742"/>
                 </a:solidFill>
@@ -1574,7 +1542,7 @@
               </a:rPr>
               <a:t>ЗОНЫ ЭКСПЕРТИЗЫ</a:t>
             </a:r>
-            <a:endParaRPr lang="ru-RU" sz="820"/>
+            <a:endParaRPr lang="ru-RU" sz="780"/>
           </a:p>
         </p:txBody>
       </p:sp>
@@ -1586,7 +1554,7 @@
         </p:nvSpPr>
         <p:spPr>
           <a:xfrm>
-            <a:off x="5112000" y="5400000"/>
+            <a:off x="5112000" y="5184000"/>
             <a:ext cx="2052000" cy="9000"/>
           </a:xfrm>
           <a:prstGeom prst="rect">
@@ -1608,7 +1576,7 @@
         </p:nvSpPr>
         <p:spPr>
           <a:xfrm>
-            <a:off x="5112000" y="5508000"/>
+            <a:off x="5112000" y="5292000"/>
             <a:ext cx="2052000" cy="504000"/>
           </a:xfrm>
           <a:prstGeom prst="rect">
@@ -1627,7 +1595,7 @@
               <a:buNone/>
             </a:pPr>
             <a:r>
-              <a:rPr lang="ru-RU" sz="580">
+              <a:rPr lang="ru-RU" sz="560">
                 <a:solidFill>
                   <a:srgbClr val="667085"/>
                 </a:solidFill>
@@ -1636,7 +1604,7 @@
               </a:rPr>
               <a:t>Уровень вовлеченности в областях с hands-on управленческим опытом.</a:t>
             </a:r>
-            <a:endParaRPr lang="ru-RU" sz="580"/>
+            <a:endParaRPr lang="ru-RU" sz="560"/>
           </a:p>
         </p:txBody>
       </p:sp>
@@ -1648,7 +1616,7 @@
         </p:nvSpPr>
         <p:spPr>
           <a:xfrm>
-            <a:off x="5112000" y="6048000"/>
+            <a:off x="5112000" y="5832000"/>
             <a:ext cx="2052000" cy="180000"/>
           </a:xfrm>
           <a:prstGeom prst="rect">
@@ -1667,7 +1635,7 @@
               <a:buNone/>
             </a:pPr>
             <a:r>
-              <a:rPr lang="ru-RU" sz="610" b="1">
+              <a:rPr lang="ru-RU" sz="590" b="1">
                 <a:solidFill>
                   <a:srgbClr val="173A5E"/>
                 </a:solidFill>
@@ -1677,7 +1645,7 @@
               <a:t>Retail business and P&amp;L</a:t>
             </a:r>
             <a:r>
-              <a:rPr lang="ru-RU" sz="610" b="1">
+              <a:rPr lang="ru-RU" sz="590" b="1">
                 <a:solidFill>
                   <a:srgbClr val="173A5E"/>
                 </a:solidFill>
@@ -1686,7 +1654,7 @@
               </a:rPr>
               <a:t> 100%</a:t>
             </a:r>
-            <a:endParaRPr lang="ru-RU" sz="610"/>
+            <a:endParaRPr lang="ru-RU" sz="590"/>
           </a:p>
         </p:txBody>
       </p:sp>
@@ -1698,8 +1666,8 @@
         </p:nvSpPr>
         <p:spPr>
           <a:xfrm>
-            <a:off x="5112000" y="6238800"/>
-            <a:ext cx="2052000" cy="97200"/>
+            <a:off x="5112000" y="6012000"/>
+            <a:ext cx="2052000" cy="90000"/>
           </a:xfrm>
           <a:prstGeom prst="rect">
             <a:avLst/>
@@ -1720,8 +1688,8 @@
         </p:nvSpPr>
         <p:spPr>
           <a:xfrm>
-            <a:off x="5112000" y="6238800"/>
-            <a:ext cx="2052000" cy="97200"/>
+            <a:off x="5112000" y="6012000"/>
+            <a:ext cx="2052000" cy="90000"/>
           </a:xfrm>
           <a:prstGeom prst="rect">
             <a:avLst/>
@@ -1742,7 +1710,7 @@
         </p:nvSpPr>
         <p:spPr>
           <a:xfrm>
-            <a:off x="5112000" y="6588000"/>
+            <a:off x="5112000" y="6372000"/>
             <a:ext cx="2052000" cy="180000"/>
           </a:xfrm>
           <a:prstGeom prst="rect">
@@ -1761,7 +1729,7 @@
               <a:buNone/>
             </a:pPr>
             <a:r>
-              <a:rPr lang="ru-RU" sz="610" b="1">
+              <a:rPr lang="ru-RU" sz="590" b="1">
                 <a:solidFill>
                   <a:srgbClr val="173A5E"/>
                 </a:solidFill>
@@ -1771,7 +1739,7 @@
               <a:t>Products and growth</a:t>
             </a:r>
             <a:r>
-              <a:rPr lang="ru-RU" sz="610" b="1">
+              <a:rPr lang="ru-RU" sz="590" b="1">
                 <a:solidFill>
                   <a:srgbClr val="173A5E"/>
                 </a:solidFill>
@@ -1780,7 +1748,7 @@
               </a:rPr>
               <a:t> 100%</a:t>
             </a:r>
-            <a:endParaRPr lang="ru-RU" sz="610"/>
+            <a:endParaRPr lang="ru-RU" sz="590"/>
           </a:p>
         </p:txBody>
       </p:sp>
@@ -1792,8 +1760,8 @@
         </p:nvSpPr>
         <p:spPr>
           <a:xfrm>
-            <a:off x="5112000" y="6778800"/>
-            <a:ext cx="2052000" cy="97200"/>
+            <a:off x="5112000" y="6552000"/>
+            <a:ext cx="2052000" cy="90000"/>
           </a:xfrm>
           <a:prstGeom prst="rect">
             <a:avLst/>
@@ -1814,8 +1782,8 @@
         </p:nvSpPr>
         <p:spPr>
           <a:xfrm>
-            <a:off x="5112000" y="6778800"/>
-            <a:ext cx="2052000" cy="97200"/>
+            <a:off x="5112000" y="6552000"/>
+            <a:ext cx="2052000" cy="90000"/>
           </a:xfrm>
           <a:prstGeom prst="rect">
             <a:avLst/>
@@ -1836,7 +1804,7 @@
         </p:nvSpPr>
         <p:spPr>
           <a:xfrm>
-            <a:off x="5112000" y="7128000"/>
+            <a:off x="5112000" y="6912000"/>
             <a:ext cx="2052000" cy="180000"/>
           </a:xfrm>
           <a:prstGeom prst="rect">
@@ -1855,7 +1823,7 @@
               <a:buNone/>
             </a:pPr>
             <a:r>
-              <a:rPr lang="ru-RU" sz="610" b="1">
+              <a:rPr lang="ru-RU" sz="590" b="1">
                 <a:solidFill>
                   <a:srgbClr val="173A5E"/>
                 </a:solidFill>
@@ -1865,7 +1833,7 @@
               <a:t>Channels and partnerships</a:t>
             </a:r>
             <a:r>
-              <a:rPr lang="ru-RU" sz="610" b="1">
+              <a:rPr lang="ru-RU" sz="590" b="1">
                 <a:solidFill>
                   <a:srgbClr val="173A5E"/>
                 </a:solidFill>
@@ -1874,7 +1842,7 @@
               </a:rPr>
               <a:t> 100%</a:t>
             </a:r>
-            <a:endParaRPr lang="ru-RU" sz="610"/>
+            <a:endParaRPr lang="ru-RU" sz="590"/>
           </a:p>
         </p:txBody>
       </p:sp>
@@ -1886,8 +1854,8 @@
         </p:nvSpPr>
         <p:spPr>
           <a:xfrm>
-            <a:off x="5112000" y="7318800"/>
-            <a:ext cx="2052000" cy="97200"/>
+            <a:off x="5112000" y="7092000"/>
+            <a:ext cx="2052000" cy="90000"/>
           </a:xfrm>
           <a:prstGeom prst="rect">
             <a:avLst/>
@@ -1908,8 +1876,8 @@
         </p:nvSpPr>
         <p:spPr>
           <a:xfrm>
-            <a:off x="5112000" y="7318800"/>
-            <a:ext cx="2052000" cy="97200"/>
+            <a:off x="5112000" y="7092000"/>
+            <a:ext cx="2052000" cy="90000"/>
           </a:xfrm>
           <a:prstGeom prst="rect">
             <a:avLst/>
@@ -1930,7 +1898,7 @@
         </p:nvSpPr>
         <p:spPr>
           <a:xfrm>
-            <a:off x="5112000" y="7668000"/>
+            <a:off x="5112000" y="7452000"/>
             <a:ext cx="2052000" cy="180000"/>
           </a:xfrm>
           <a:prstGeom prst="rect">
@@ -1949,7 +1917,7 @@
               <a:buNone/>
             </a:pPr>
             <a:r>
-              <a:rPr lang="ru-RU" sz="610" b="1">
+              <a:rPr lang="ru-RU" sz="590" b="1">
                 <a:solidFill>
                   <a:srgbClr val="173A5E"/>
                 </a:solidFill>
@@ -1959,7 +1927,7 @@
               <a:t>Technology and delivery</a:t>
             </a:r>
             <a:r>
-              <a:rPr lang="ru-RU" sz="610" b="1">
+              <a:rPr lang="ru-RU" sz="590" b="1">
                 <a:solidFill>
                   <a:srgbClr val="173A5E"/>
                 </a:solidFill>
@@ -1968,7 +1936,7 @@
               </a:rPr>
               <a:t> 80%</a:t>
             </a:r>
-            <a:endParaRPr lang="ru-RU" sz="610"/>
+            <a:endParaRPr lang="ru-RU" sz="590"/>
           </a:p>
         </p:txBody>
       </p:sp>
@@ -1980,8 +1948,8 @@
         </p:nvSpPr>
         <p:spPr>
           <a:xfrm>
-            <a:off x="5112000" y="7858800"/>
-            <a:ext cx="2052000" cy="97200"/>
+            <a:off x="5112000" y="7632000"/>
+            <a:ext cx="2052000" cy="90000"/>
           </a:xfrm>
           <a:prstGeom prst="rect">
             <a:avLst/>
@@ -2002,8 +1970,8 @@
         </p:nvSpPr>
         <p:spPr>
           <a:xfrm>
-            <a:off x="5112000" y="7858800"/>
-            <a:ext cx="1641600" cy="97200"/>
+            <a:off x="5112000" y="7632000"/>
+            <a:ext cx="1641600" cy="90000"/>
           </a:xfrm>
           <a:prstGeom prst="rect">
             <a:avLst/>
@@ -2024,7 +1992,7 @@
         </p:nvSpPr>
         <p:spPr>
           <a:xfrm>
-            <a:off x="5112000" y="8208000"/>
+            <a:off x="5112000" y="7992000"/>
             <a:ext cx="2052000" cy="180000"/>
           </a:xfrm>
           <a:prstGeom prst="rect">
@@ -2043,7 +2011,7 @@
               <a:buNone/>
             </a:pPr>
             <a:r>
-              <a:rPr lang="ru-RU" sz="610" b="1">
+              <a:rPr lang="ru-RU" sz="590" b="1">
                 <a:solidFill>
                   <a:srgbClr val="173A5E"/>
                 </a:solidFill>
@@ -2053,7 +2021,7 @@
               <a:t>Regulatory</a:t>
             </a:r>
             <a:r>
-              <a:rPr lang="ru-RU" sz="610" b="1">
+              <a:rPr lang="ru-RU" sz="590" b="1">
                 <a:solidFill>
                   <a:srgbClr val="173A5E"/>
                 </a:solidFill>
@@ -2062,7 +2030,7 @@
               </a:rPr>
               <a:t> 70%</a:t>
             </a:r>
-            <a:endParaRPr lang="ru-RU" sz="610"/>
+            <a:endParaRPr lang="ru-RU" sz="590"/>
           </a:p>
         </p:txBody>
       </p:sp>
@@ -2074,8 +2042,8 @@
         </p:nvSpPr>
         <p:spPr>
           <a:xfrm>
-            <a:off x="5112000" y="8398800"/>
-            <a:ext cx="2052000" cy="97200"/>
+            <a:off x="5112000" y="8172000"/>
+            <a:ext cx="2052000" cy="90000"/>
           </a:xfrm>
           <a:prstGeom prst="rect">
             <a:avLst/>
@@ -2096,8 +2064,8 @@
         </p:nvSpPr>
         <p:spPr>
           <a:xfrm>
-            <a:off x="5112000" y="8398800"/>
-            <a:ext cx="1436400" cy="97200"/>
+            <a:off x="5112000" y="8172000"/>
+            <a:ext cx="1436400" cy="90000"/>
           </a:xfrm>
           <a:prstGeom prst="rect">
             <a:avLst/>
@@ -2118,8 +2086,8 @@
         </p:nvSpPr>
         <p:spPr>
           <a:xfrm>
-            <a:off x="5112000" y="8892000"/>
-            <a:ext cx="2052000" cy="972000"/>
+            <a:off x="5112000" y="8676000"/>
+            <a:ext cx="2052000" cy="1152000"/>
           </a:xfrm>
           <a:prstGeom prst="rect">
             <a:avLst/>
@@ -2137,7 +2105,7 @@
               <a:buNone/>
             </a:pPr>
             <a:r>
-              <a:rPr lang="ru-RU" sz="780" b="1">
+              <a:rPr lang="ru-RU" sz="760" b="1">
                 <a:solidFill>
                   <a:srgbClr val="0F2742"/>
                 </a:solidFill>
@@ -2146,14 +2114,14 @@
               </a:rPr>
               <a:t>ОБРАЗОВАНИЕ И ЯЗЫКИ</a:t>
             </a:r>
-            <a:endParaRPr lang="ru-RU" sz="780"/>
-          </a:p>
-          <a:p>
-            <a:pPr>
-              <a:buNone/>
-            </a:pPr>
-            <a:r>
-              <a:rPr lang="ru-RU" sz="600">
+            <a:endParaRPr lang="ru-RU" sz="760"/>
+          </a:p>
+          <a:p>
+            <a:pPr>
+              <a:buNone/>
+            </a:pPr>
+            <a:r>
+              <a:rPr lang="ru-RU" sz="590">
                 <a:solidFill>
                   <a:srgbClr val="1F2933"/>
                 </a:solidFill>
@@ -2165,7 +2133,7 @@
 Русский - родной · Английский - C2
 Испанский - базовый</a:t>
             </a:r>
-            <a:endParaRPr lang="ru-RU" sz="600"/>
+            <a:endParaRPr lang="ru-RU" sz="590"/>
           </a:p>
         </p:txBody>
       </p:sp>
@@ -2319,7 +2287,7 @@
             <a:endParaRPr lang="ru-RU" sz="640"/>
           </a:p>
           <a:p>
-            <a:pPr marL="155000" indent="-80000">
+            <a:pPr marL="135000" indent="-70000">
               <a:buChar char="•"/>
             </a:pPr>
             <a:r>
@@ -2335,7 +2303,7 @@
             <a:endParaRPr lang="ru-RU" sz="590"/>
           </a:p>
           <a:p>
-            <a:pPr marL="155000" indent="-80000">
+            <a:pPr marL="135000" indent="-70000">
               <a:buChar char="•"/>
             </a:pPr>
             <a:r>
@@ -2351,7 +2319,7 @@
             <a:endParaRPr lang="ru-RU" sz="590"/>
           </a:p>
           <a:p>
-            <a:pPr marL="155000" indent="-80000">
+            <a:pPr marL="135000" indent="-70000">
               <a:buChar char="•"/>
             </a:pPr>
             <a:r>
@@ -2367,7 +2335,7 @@
             <a:endParaRPr lang="ru-RU" sz="590"/>
           </a:p>
           <a:p>
-            <a:pPr marL="155000" indent="-80000">
+            <a:pPr marL="135000" indent="-70000">
               <a:buChar char="•"/>
             </a:pPr>
             <a:r>
@@ -2383,7 +2351,7 @@
             <a:endParaRPr lang="ru-RU" sz="590"/>
           </a:p>
           <a:p>
-            <a:pPr marL="155000" indent="-80000">
+            <a:pPr marL="135000" indent="-70000">
               <a:buChar char="•"/>
             </a:pPr>
             <a:r>
@@ -2455,7 +2423,7 @@
             <a:endParaRPr lang="ru-RU" sz="640"/>
           </a:p>
           <a:p>
-            <a:pPr marL="155000" indent="-80000">
+            <a:pPr marL="135000" indent="-70000">
               <a:buChar char="•"/>
             </a:pPr>
             <a:r>
@@ -2471,7 +2439,7 @@
             <a:endParaRPr lang="ru-RU" sz="590"/>
           </a:p>
           <a:p>
-            <a:pPr marL="155000" indent="-80000">
+            <a:pPr marL="135000" indent="-70000">
               <a:buChar char="•"/>
             </a:pPr>
             <a:r>
@@ -2487,7 +2455,7 @@
             <a:endParaRPr lang="ru-RU" sz="590"/>
           </a:p>
           <a:p>
-            <a:pPr marL="155000" indent="-80000">
+            <a:pPr marL="135000" indent="-70000">
               <a:buChar char="•"/>
             </a:pPr>
             <a:r>
@@ -2503,7 +2471,7 @@
             <a:endParaRPr lang="ru-RU" sz="590"/>
           </a:p>
           <a:p>
-            <a:pPr marL="155000" indent="-80000">
+            <a:pPr marL="135000" indent="-70000">
               <a:buChar char="•"/>
             </a:pPr>
             <a:r>
@@ -2519,7 +2487,7 @@
             <a:endParaRPr lang="ru-RU" sz="590"/>
           </a:p>
           <a:p>
-            <a:pPr marL="155000" indent="-80000">
+            <a:pPr marL="135000" indent="-70000">
               <a:buChar char="•"/>
             </a:pPr>
             <a:r>
@@ -2535,7 +2503,7 @@
             <a:endParaRPr lang="ru-RU" sz="590"/>
           </a:p>
           <a:p>
-            <a:pPr marL="155000" indent="-80000">
+            <a:pPr marL="135000" indent="-70000">
               <a:buChar char="•"/>
             </a:pPr>
             <a:r>
@@ -2607,7 +2575,7 @@
             <a:endParaRPr lang="ru-RU" sz="640"/>
           </a:p>
           <a:p>
-            <a:pPr marL="155000" indent="-80000">
+            <a:pPr marL="135000" indent="-70000">
               <a:buChar char="•"/>
             </a:pPr>
             <a:r>
@@ -2623,7 +2591,7 @@
             <a:endParaRPr lang="ru-RU" sz="590"/>
           </a:p>
           <a:p>
-            <a:pPr marL="155000" indent="-80000">
+            <a:pPr marL="135000" indent="-70000">
               <a:buChar char="•"/>
             </a:pPr>
             <a:r>
@@ -2639,7 +2607,7 @@
             <a:endParaRPr lang="ru-RU" sz="590"/>
           </a:p>
           <a:p>
-            <a:pPr marL="155000" indent="-80000">
+            <a:pPr marL="135000" indent="-70000">
               <a:buChar char="•"/>
             </a:pPr>
             <a:r>
@@ -2655,7 +2623,7 @@
             <a:endParaRPr lang="ru-RU" sz="590"/>
           </a:p>
           <a:p>
-            <a:pPr marL="155000" indent="-80000">
+            <a:pPr marL="135000" indent="-70000">
               <a:buChar char="•"/>
             </a:pPr>
             <a:r>
@@ -2671,7 +2639,7 @@
             <a:endParaRPr lang="ru-RU" sz="590"/>
           </a:p>
           <a:p>
-            <a:pPr marL="155000" indent="-80000">
+            <a:pPr marL="135000" indent="-70000">
               <a:buChar char="•"/>
             </a:pPr>
             <a:r>

</xml_diff>

<commit_message>
Use original examples in focus sections
Co-authored-by: yanatimofeeva2511 <yanatimofeeva2511@users.noreply.github.com>
</commit_message>
<xml_diff>
--- a/resume_clevel_fintech_ru_editable.pptx
+++ b/resume_clevel_fintech_ru_editable.pptx
@@ -129,7 +129,7 @@
               <a:buNone/>
             </a:pPr>
             <a:r>
-              <a:rPr lang="ru-RU" sz="2000" b="1">
+              <a:rPr lang="ru-RU" sz="2050" b="1">
                 <a:solidFill>
                   <a:srgbClr val="0F2742"/>
                 </a:solidFill>
@@ -138,7 +138,7 @@
               </a:rPr>
               <a:t>Яна Тимофеева</a:t>
             </a:r>
-            <a:endParaRPr lang="ru-RU" sz="2000"/>
+            <a:endParaRPr lang="ru-RU" sz="2050"/>
           </a:p>
         </p:txBody>
       </p:sp>
@@ -347,7 +347,7 @@
         <p:spPr>
           <a:xfrm>
             <a:off x="396000" y="1872000"/>
-            <a:ext cx="6768000" cy="900000"/>
+            <a:ext cx="6768000" cy="792000"/>
           </a:xfrm>
           <a:prstGeom prst="rect">
             <a:avLst/>
@@ -365,7 +365,7 @@
               <a:buNone/>
             </a:pPr>
             <a:r>
-              <a:rPr lang="ru-RU" sz="670">
+              <a:rPr lang="ru-RU" sz="660">
                 <a:solidFill>
                   <a:srgbClr val="1F2933"/>
                 </a:solidFill>
@@ -374,23 +374,23 @@
               </a:rPr>
               <a:t>Бизнес-лидер с 20+ годами опыта в крупнейших финансовых организациях России. Отвечаю за розничные направления, запуск новых продуктов, клиентский рост, партнерскую дистрибуцию, технологические миграции и федеральные проекты на стыке бизнеса, IT, операций, маркетинга, продаж и регуляторного контура.</a:t>
             </a:r>
-            <a:endParaRPr lang="ru-RU" sz="670"/>
-          </a:p>
-          <a:p>
-            <a:pPr>
-              <a:buNone/>
-            </a:pPr>
-            <a:r>
-              <a:rPr lang="ru-RU" sz="670">
+            <a:endParaRPr lang="ru-RU" sz="660"/>
+          </a:p>
+          <a:p>
+            <a:pPr>
+              <a:buNone/>
+            </a:pPr>
+            <a:r>
+              <a:rPr lang="ru-RU" sz="660">
                 <a:solidFill>
                   <a:srgbClr val="1F2933"/>
                 </a:solidFill>
                 <a:latin typeface="Arial"/>
                 <a:cs typeface="Arial"/>
               </a:rPr>
-              <a:t>Моя ценность - быстро соединить стратегию, экономику продукта, операционную модель и delivery в измеримый результат без потери клиентского опыта.</a:t>
-            </a:r>
-            <a:endParaRPr lang="ru-RU" sz="670"/>
+              <a:t>Моя ценность - быстро соединить стратегию, экономику продукта, операционную модель и delivery в измеримый результат.</a:t>
+            </a:r>
+            <a:endParaRPr lang="ru-RU" sz="660"/>
           </a:p>
         </p:txBody>
       </p:sp>
@@ -402,8 +402,8 @@
         </p:nvSpPr>
         <p:spPr>
           <a:xfrm>
-            <a:off x="396000" y="2880000"/>
-            <a:ext cx="4500000" cy="216000"/>
+            <a:off x="396000" y="2808000"/>
+            <a:ext cx="4464000" cy="216000"/>
           </a:xfrm>
           <a:prstGeom prst="rect">
             <a:avLst/>
@@ -421,16 +421,16 @@
               <a:buNone/>
             </a:pPr>
             <a:r>
-              <a:rPr lang="ru-RU" sz="800" b="1">
+              <a:rPr lang="ru-RU" sz="790" b="1">
                 <a:solidFill>
                   <a:srgbClr val="0F2742"/>
                 </a:solidFill>
                 <a:latin typeface="Arial"/>
                 <a:cs typeface="Arial"/>
               </a:rPr>
-              <a:t>УПРАВЛЕНЧЕСКИЙ ФОКУС</a:t>
-            </a:r>
-            <a:endParaRPr lang="ru-RU" sz="800"/>
+              <a:t>УПРАВЛЕНЧЕСКИЙ ФОКУС И ПРИМЕРЫ</a:t>
+            </a:r>
+            <a:endParaRPr lang="ru-RU" sz="790"/>
           </a:p>
         </p:txBody>
       </p:sp>
@@ -442,8 +442,8 @@
         </p:nvSpPr>
         <p:spPr>
           <a:xfrm>
-            <a:off x="396000" y="3132000"/>
-            <a:ext cx="4500000" cy="9000"/>
+            <a:off x="396000" y="3060000"/>
+            <a:ext cx="4464000" cy="9000"/>
           </a:xfrm>
           <a:prstGeom prst="rect">
             <a:avLst/>
@@ -464,8 +464,8 @@
         </p:nvSpPr>
         <p:spPr>
           <a:xfrm>
-            <a:off x="396000" y="3240000"/>
-            <a:ext cx="4500000" cy="1980000"/>
+            <a:off x="396000" y="3204000"/>
+            <a:ext cx="4464000" cy="2052000"/>
           </a:xfrm>
           <a:prstGeom prst="roundRect">
             <a:avLst/>
@@ -480,14 +480,14 @@
           </a:ln>
         </p:spPr>
         <p:txBody>
-          <a:bodyPr wrap="square" lIns="16000" tIns="16000" rIns="16000" bIns="16000"/>
-          <a:lstStyle/>
-          <a:p>
-            <a:pPr>
-              <a:buNone/>
-            </a:pPr>
-            <a:r>
-              <a:rPr lang="ru-RU" sz="690" b="1">
+          <a:bodyPr wrap="square" lIns="14500" tIns="14500" rIns="14500" bIns="14500"/>
+          <a:lstStyle/>
+          <a:p>
+            <a:pPr>
+              <a:buNone/>
+            </a:pPr>
+            <a:r>
+              <a:rPr lang="ru-RU" sz="660" b="1">
                 <a:solidFill>
                   <a:srgbClr val="173A5E"/>
                 </a:solidFill>
@@ -496,52 +496,36 @@
               </a:rPr>
               <a:t>BUILD - запуск самостоятельных бизнес-направлений</a:t>
             </a:r>
-            <a:endParaRPr lang="ru-RU" sz="690"/>
-          </a:p>
-          <a:p>
-            <a:pPr marL="135000" indent="-70000">
-              <a:buChar char="•"/>
-            </a:pPr>
-            <a:r>
-              <a:rPr lang="ru-RU" sz="520">
-                <a:solidFill>
-                  <a:srgbClr val="1F2933"/>
-                </a:solidFill>
-                <a:latin typeface="Arial"/>
-                <a:cs typeface="Arial"/>
-              </a:rPr>
-              <a:t>Определяю рынок, сегменты, бизнес-модель, стратегию, инвестиционную логику и окупаемость.</a:t>
-            </a:r>
-            <a:endParaRPr lang="ru-RU" sz="520"/>
-          </a:p>
-          <a:p>
-            <a:pPr marL="135000" indent="-70000">
-              <a:buChar char="•"/>
-            </a:pPr>
-            <a:r>
-              <a:rPr lang="ru-RU" sz="520">
-                <a:solidFill>
-                  <a:srgbClr val="1F2933"/>
-                </a:solidFill>
-                <a:latin typeface="Arial"/>
-                <a:cs typeface="Arial"/>
-              </a:rPr>
-              <a:t>Формирую продуктовый ряд и клиентское предложение; развиваю каналы продаж, партнерства и дистрибуцию.</a:t>
-            </a:r>
-            <a:endParaRPr lang="ru-RU" sz="520"/>
-          </a:p>
-        </p:txBody>
-      </p:sp>
-      <p:sp>
-        <p:nvSpPr>
-          <p:cNvPr id="200" name="proof"/>
-          <p:cNvSpPr txBox="1"/>
-          <p:nvPr/>
-        </p:nvSpPr>
-        <p:spPr>
-          <a:xfrm>
-            <a:off x="504000" y="3924000"/>
-            <a:ext cx="2106000" cy="576000"/>
+            <a:endParaRPr lang="ru-RU" sz="660"/>
+          </a:p>
+          <a:p>
+            <a:pPr>
+              <a:buNone/>
+            </a:pPr>
+            <a:r>
+              <a:rPr lang="ru-RU" sz="545">
+                <a:solidFill>
+                  <a:srgbClr val="344054"/>
+                </a:solidFill>
+                <a:latin typeface="Arial"/>
+                <a:cs typeface="Arial"/>
+              </a:rPr>
+              <a:t>Запуск направления с нуля: рынок, бизнес-модель, продуктовый ряд, каналы продаж, партнерства и экономика окупаемости.</a:t>
+            </a:r>
+            <a:endParaRPr lang="ru-RU" sz="545"/>
+          </a:p>
+        </p:txBody>
+      </p:sp>
+      <p:sp>
+        <p:nvSpPr>
+          <p:cNvPr id="200" name="metric"/>
+          <p:cNvSpPr txBox="1"/>
+          <p:nvPr/>
+        </p:nvSpPr>
+        <p:spPr>
+          <a:xfrm>
+            <a:off x="504000" y="3672000"/>
+            <a:ext cx="540000" cy="208800"/>
           </a:xfrm>
           <a:prstGeom prst="roundRect">
             <a:avLst/>
@@ -551,7 +535,7 @@
           </a:solidFill>
           <a:ln w="6350">
             <a:solidFill>
-              <a:srgbClr val="D5E6F7"/>
+              <a:srgbClr val="E8F1FB"/>
             </a:solidFill>
           </a:ln>
         </p:spPr>
@@ -563,45 +547,29 @@
               <a:buNone/>
             </a:pPr>
             <a:r>
-              <a:rPr lang="ru-RU" sz="930" b="1">
+              <a:rPr lang="ru-RU" sz="600" b="1">
                 <a:solidFill>
                   <a:srgbClr val="0F4778"/>
                 </a:solidFill>
                 <a:latin typeface="Arial"/>
                 <a:cs typeface="Arial"/>
               </a:rPr>
-              <a:t>2,1 млн</a:t>
-            </a:r>
-            <a:endParaRPr lang="ru-RU" sz="930"/>
-          </a:p>
-          <a:p>
-            <a:pPr>
-              <a:buNone/>
-            </a:pPr>
-            <a:r>
-              <a:rPr lang="ru-RU" sz="465">
-                <a:solidFill>
-                  <a:srgbClr val="173A5E"/>
-                </a:solidFill>
-                <a:latin typeface="Arial"/>
-                <a:cs typeface="Arial"/>
-              </a:rPr>
-              <a:t>АКБ в Открытии после запуска пассивного и расчетного бизнеса; +11% при переходе к доходной модели</a:t>
-            </a:r>
-            <a:endParaRPr lang="ru-RU" sz="465"/>
-          </a:p>
-        </p:txBody>
-      </p:sp>
-      <p:sp>
-        <p:nvSpPr>
-          <p:cNvPr id="201" name="proof"/>
-          <p:cNvSpPr txBox="1"/>
-          <p:nvPr/>
-        </p:nvSpPr>
-        <p:spPr>
-          <a:xfrm>
-            <a:off x="2664000" y="3924000"/>
-            <a:ext cx="2106000" cy="576000"/>
+              <a:t>АКБ +11%</a:t>
+            </a:r>
+            <a:endParaRPr lang="ru-RU" sz="600"/>
+          </a:p>
+        </p:txBody>
+      </p:sp>
+      <p:sp>
+        <p:nvSpPr>
+          <p:cNvPr id="201" name="metric"/>
+          <p:cNvSpPr txBox="1"/>
+          <p:nvPr/>
+        </p:nvSpPr>
+        <p:spPr>
+          <a:xfrm>
+            <a:off x="1116000" y="3672000"/>
+            <a:ext cx="540000" cy="208800"/>
           </a:xfrm>
           <a:prstGeom prst="roundRect">
             <a:avLst/>
@@ -611,7 +579,7 @@
           </a:solidFill>
           <a:ln w="6350">
             <a:solidFill>
-              <a:srgbClr val="D5E6F7"/>
+              <a:srgbClr val="E8F1FB"/>
             </a:solidFill>
           </a:ln>
         </p:spPr>
@@ -623,45 +591,29 @@
               <a:buNone/>
             </a:pPr>
             <a:r>
-              <a:rPr lang="ru-RU" sz="930" b="1">
+              <a:rPr lang="ru-RU" sz="600" b="1">
                 <a:solidFill>
                   <a:srgbClr val="0F4778"/>
                 </a:solidFill>
                 <a:latin typeface="Arial"/>
                 <a:cs typeface="Arial"/>
               </a:rPr>
-              <a:t>AUM +35%</a:t>
-            </a:r>
-            <a:endParaRPr lang="ru-RU" sz="930"/>
-          </a:p>
-          <a:p>
-            <a:pPr>
-              <a:buNone/>
-            </a:pPr>
-            <a:r>
-              <a:rPr lang="ru-RU" sz="465">
-                <a:solidFill>
-                  <a:srgbClr val="173A5E"/>
-                </a:solidFill>
-                <a:latin typeface="Arial"/>
-                <a:cs typeface="Arial"/>
-              </a:rPr>
-              <a:t>улучшение качества клиентского сегмента; транзакционный отток снижен в 3 раза</a:t>
-            </a:r>
-            <a:endParaRPr lang="ru-RU" sz="465"/>
-          </a:p>
-        </p:txBody>
-      </p:sp>
-      <p:sp>
-        <p:nvSpPr>
-          <p:cNvPr id="202" name="proof"/>
-          <p:cNvSpPr txBox="1"/>
-          <p:nvPr/>
-        </p:nvSpPr>
-        <p:spPr>
-          <a:xfrm>
-            <a:off x="504000" y="4554000"/>
-            <a:ext cx="2106000" cy="576000"/>
+              <a:t>2,1 млн</a:t>
+            </a:r>
+            <a:endParaRPr lang="ru-RU" sz="600"/>
+          </a:p>
+        </p:txBody>
+      </p:sp>
+      <p:sp>
+        <p:nvSpPr>
+          <p:cNvPr id="202" name="metric"/>
+          <p:cNvSpPr txBox="1"/>
+          <p:nvPr/>
+        </p:nvSpPr>
+        <p:spPr>
+          <a:xfrm>
+            <a:off x="1728000" y="3672000"/>
+            <a:ext cx="540000" cy="208800"/>
           </a:xfrm>
           <a:prstGeom prst="roundRect">
             <a:avLst/>
@@ -671,7 +623,7 @@
           </a:solidFill>
           <a:ln w="6350">
             <a:solidFill>
-              <a:srgbClr val="D5E6F7"/>
+              <a:srgbClr val="E8F1FB"/>
             </a:solidFill>
           </a:ln>
         </p:spPr>
@@ -683,45 +635,29 @@
               <a:buNone/>
             </a:pPr>
             <a:r>
-              <a:rPr lang="ru-RU" sz="930" b="1">
+              <a:rPr lang="ru-RU" sz="600" b="1">
                 <a:solidFill>
                   <a:srgbClr val="0F4778"/>
                 </a:solidFill>
                 <a:latin typeface="Arial"/>
                 <a:cs typeface="Arial"/>
               </a:rPr>
-              <a:t>N1 / 88% NTB</a:t>
-            </a:r>
-            <a:endParaRPr lang="ru-RU" sz="930"/>
-          </a:p>
-          <a:p>
-            <a:pPr>
-              <a:buNone/>
-            </a:pPr>
-            <a:r>
-              <a:rPr lang="ru-RU" sz="465">
-                <a:solidFill>
-                  <a:srgbClr val="173A5E"/>
-                </a:solidFill>
-                <a:latin typeface="Arial"/>
-                <a:cs typeface="Arial"/>
-              </a:rPr>
-              <a:t>автокредитование ВТБ24: stand-alone модель, 25% притока клиентов розницы</a:t>
-            </a:r>
-            <a:endParaRPr lang="ru-RU" sz="465"/>
-          </a:p>
-        </p:txBody>
-      </p:sp>
-      <p:sp>
-        <p:nvSpPr>
-          <p:cNvPr id="203" name="proof"/>
-          <p:cNvSpPr txBox="1"/>
-          <p:nvPr/>
-        </p:nvSpPr>
-        <p:spPr>
-          <a:xfrm>
-            <a:off x="2664000" y="4554000"/>
-            <a:ext cx="2106000" cy="576000"/>
+              <a:t>AUM +35%</a:t>
+            </a:r>
+            <a:endParaRPr lang="ru-RU" sz="600"/>
+          </a:p>
+        </p:txBody>
+      </p:sp>
+      <p:sp>
+        <p:nvSpPr>
+          <p:cNvPr id="203" name="metric"/>
+          <p:cNvSpPr txBox="1"/>
+          <p:nvPr/>
+        </p:nvSpPr>
+        <p:spPr>
+          <a:xfrm>
+            <a:off x="2340000" y="3672000"/>
+            <a:ext cx="705600" cy="208800"/>
           </a:xfrm>
           <a:prstGeom prst="roundRect">
             <a:avLst/>
@@ -731,7 +667,7 @@
           </a:solidFill>
           <a:ln w="6350">
             <a:solidFill>
-              <a:srgbClr val="D5E6F7"/>
+              <a:srgbClr val="E8F1FB"/>
             </a:solidFill>
           </a:ln>
         </p:spPr>
@@ -743,32 +679,168 @@
               <a:buNone/>
             </a:pPr>
             <a:r>
-              <a:rPr lang="ru-RU" sz="930" b="1">
+              <a:rPr lang="ru-RU" sz="600" b="1">
                 <a:solidFill>
                   <a:srgbClr val="0F4778"/>
                 </a:solidFill>
                 <a:latin typeface="Arial"/>
                 <a:cs typeface="Arial"/>
               </a:rPr>
-              <a:t>36-й месяц</a:t>
-            </a:r>
-            <a:endParaRPr lang="ru-RU" sz="930"/>
-          </a:p>
-          <a:p>
-            <a:pPr>
-              <a:buNone/>
-            </a:pPr>
-            <a:r>
-              <a:rPr lang="ru-RU" sz="465">
+              <a:t>№1 / 88% NTB</a:t>
+            </a:r>
+            <a:endParaRPr lang="ru-RU" sz="600"/>
+          </a:p>
+        </p:txBody>
+      </p:sp>
+      <p:sp>
+        <p:nvSpPr>
+          <p:cNvPr id="204" name="metric"/>
+          <p:cNvSpPr txBox="1"/>
+          <p:nvPr/>
+        </p:nvSpPr>
+        <p:spPr>
+          <a:xfrm>
+            <a:off x="3117600" y="3672000"/>
+            <a:ext cx="540000" cy="208800"/>
+          </a:xfrm>
+          <a:prstGeom prst="roundRect">
+            <a:avLst/>
+          </a:prstGeom>
+          <a:solidFill>
+            <a:srgbClr val="E8F1FB"/>
+          </a:solidFill>
+          <a:ln w="6350">
+            <a:solidFill>
+              <a:srgbClr val="E8F1FB"/>
+            </a:solidFill>
+          </a:ln>
+        </p:spPr>
+        <p:txBody>
+          <a:bodyPr wrap="square" lIns="12000" tIns="12000" rIns="12000" bIns="12000"/>
+          <a:lstStyle/>
+          <a:p>
+            <a:pPr>
+              <a:buNone/>
+            </a:pPr>
+            <a:r>
+              <a:rPr lang="ru-RU" sz="600" b="1">
+                <a:solidFill>
+                  <a:srgbClr val="0F4778"/>
+                </a:solidFill>
+                <a:latin typeface="Arial"/>
+                <a:cs typeface="Arial"/>
+              </a:rPr>
+              <a:t>36 месяц</a:t>
+            </a:r>
+            <a:endParaRPr lang="ru-RU" sz="600"/>
+          </a:p>
+        </p:txBody>
+      </p:sp>
+      <p:sp>
+        <p:nvSpPr>
+          <p:cNvPr id="205" name="ФК Банк ОТКРЫТИЕ"/>
+          <p:cNvSpPr txBox="1"/>
+          <p:nvPr/>
+        </p:nvSpPr>
+        <p:spPr>
+          <a:xfrm>
+            <a:off x="504000" y="3931200"/>
+            <a:ext cx="4248000" cy="450000"/>
+          </a:xfrm>
+          <a:prstGeom prst="roundRect">
+            <a:avLst/>
+          </a:prstGeom>
+          <a:solidFill>
+            <a:srgbClr val="EEF6FF"/>
+          </a:solidFill>
+          <a:ln w="6350">
+            <a:solidFill>
+              <a:srgbClr val="EEF6FF"/>
+            </a:solidFill>
+          </a:ln>
+        </p:spPr>
+        <p:txBody>
+          <a:bodyPr wrap="square" lIns="9000" tIns="9000" rIns="9000" bIns="9000"/>
+          <a:lstStyle/>
+          <a:p>
+            <a:pPr>
+              <a:buNone/>
+            </a:pPr>
+            <a:r>
+              <a:rPr lang="ru-RU" sz="435" b="1">
+                <a:solidFill>
+                  <a:srgbClr val="0F2742"/>
+                </a:solidFill>
+                <a:latin typeface="Arial"/>
+                <a:cs typeface="Arial"/>
+              </a:rPr>
+              <a:t>ФК Банк ОТКРЫТИЕ: </a:t>
+            </a:r>
+            <a:r>
+              <a:rPr lang="ru-RU" sz="435">
                 <a:solidFill>
                   <a:srgbClr val="173A5E"/>
                 </a:solidFill>
                 <a:latin typeface="Arial"/>
                 <a:cs typeface="Arial"/>
               </a:rPr>
-              <a:t>выход автокредитного бизнеса на прибыль с момента запуска</a:t>
-            </a:r>
-            <a:endParaRPr lang="ru-RU" sz="465"/>
+              <a:t>запуск пассивного и расчетного бизнеса. При смене бизнес-модели на доходный бизнес удалось нарастить АКБ на 11% до 2,1 млн. клиентов; AUM +35%, отток в 3 раза ниже, РКО на самоокупаемости. Итоговая позиция: №5 (+3пп) по портфелю пассивов и АКБ</a:t>
+            </a:r>
+            <a:endParaRPr lang="ru-RU" sz="435"/>
+          </a:p>
+        </p:txBody>
+      </p:sp>
+      <p:sp>
+        <p:nvSpPr>
+          <p:cNvPr id="206" name="ВТБ24"/>
+          <p:cNvSpPr txBox="1"/>
+          <p:nvPr/>
+        </p:nvSpPr>
+        <p:spPr>
+          <a:xfrm>
+            <a:off x="504000" y="4417200"/>
+            <a:ext cx="4248000" cy="450000"/>
+          </a:xfrm>
+          <a:prstGeom prst="roundRect">
+            <a:avLst/>
+          </a:prstGeom>
+          <a:solidFill>
+            <a:srgbClr val="EEF6FF"/>
+          </a:solidFill>
+          <a:ln w="6350">
+            <a:solidFill>
+              <a:srgbClr val="EEF6FF"/>
+            </a:solidFill>
+          </a:ln>
+        </p:spPr>
+        <p:txBody>
+          <a:bodyPr wrap="square" lIns="9000" tIns="9000" rIns="9000" bIns="9000"/>
+          <a:lstStyle/>
+          <a:p>
+            <a:pPr>
+              <a:buNone/>
+            </a:pPr>
+            <a:r>
+              <a:rPr lang="ru-RU" sz="435" b="1">
+                <a:solidFill>
+                  <a:srgbClr val="0F2742"/>
+                </a:solidFill>
+                <a:latin typeface="Arial"/>
+                <a:cs typeface="Arial"/>
+              </a:rPr>
+              <a:t>ВТБ24: </a:t>
+            </a:r>
+            <a:r>
+              <a:rPr lang="ru-RU" sz="435">
+                <a:solidFill>
+                  <a:srgbClr val="173A5E"/>
+                </a:solidFill>
+                <a:latin typeface="Arial"/>
+                <a:cs typeface="Arial"/>
+              </a:rPr>
+              <a:t>Запуск Автокредитования. Stand-alone бизнес-модель с собственной и партнерской сетью дистрибуции: 25% клиентов розничного бизнеса, 88% NTB, прибыль с 36 месяца, позиция №1 по кредитному портфелю</a:t>
+            </a:r>
+            <a:endParaRPr lang="ru-RU" sz="435"/>
           </a:p>
         </p:txBody>
       </p:sp>
@@ -780,8 +852,8 @@
         </p:nvSpPr>
         <p:spPr>
           <a:xfrm>
-            <a:off x="396000" y="5364000"/>
-            <a:ext cx="4500000" cy="1980000"/>
+            <a:off x="396000" y="5436000"/>
+            <a:ext cx="4464000" cy="1908000"/>
           </a:xfrm>
           <a:prstGeom prst="roundRect">
             <a:avLst/>
@@ -796,14 +868,14 @@
           </a:ln>
         </p:spPr>
         <p:txBody>
-          <a:bodyPr wrap="square" lIns="16000" tIns="16000" rIns="16000" bIns="16000"/>
-          <a:lstStyle/>
-          <a:p>
-            <a:pPr>
-              <a:buNone/>
-            </a:pPr>
-            <a:r>
-              <a:rPr lang="ru-RU" sz="690" b="1">
+          <a:bodyPr wrap="square" lIns="14500" tIns="14500" rIns="14500" bIns="14500"/>
+          <a:lstStyle/>
+          <a:p>
+            <a:pPr>
+              <a:buNone/>
+            </a:pPr>
+            <a:r>
+              <a:rPr lang="ru-RU" sz="660" b="1">
                 <a:solidFill>
                   <a:srgbClr val="173A5E"/>
                 </a:solidFill>
@@ -812,52 +884,36 @@
               </a:rPr>
               <a:t>TRANSFORM - корректировка существующей модели</a:t>
             </a:r>
-            <a:endParaRPr lang="ru-RU" sz="690"/>
-          </a:p>
-          <a:p>
-            <a:pPr marL="135000" indent="-70000">
-              <a:buChar char="•"/>
-            </a:pPr>
-            <a:r>
-              <a:rPr lang="ru-RU" sz="520">
-                <a:solidFill>
-                  <a:srgbClr val="1F2933"/>
-                </a:solidFill>
-                <a:latin typeface="Arial"/>
-                <a:cs typeface="Arial"/>
-              </a:rPr>
-              <a:t>Диагностирую модель бизнеса и определяю изменения под новые цели роста и доходности.</a:t>
-            </a:r>
-            <a:endParaRPr lang="ru-RU" sz="520"/>
-          </a:p>
-          <a:p>
-            <a:pPr marL="135000" indent="-70000">
-              <a:buChar char="•"/>
-            </a:pPr>
-            <a:r>
-              <a:rPr lang="ru-RU" sz="520">
-                <a:solidFill>
-                  <a:srgbClr val="1F2933"/>
-                </a:solidFill>
-                <a:latin typeface="Arial"/>
-                <a:cs typeface="Arial"/>
-              </a:rPr>
-              <a:t>Пересобираю стратегию, экономику привлечения, источники финансирования, продуктовые приоритеты и операционную модель.</a:t>
-            </a:r>
-            <a:endParaRPr lang="ru-RU" sz="520"/>
-          </a:p>
-        </p:txBody>
-      </p:sp>
-      <p:sp>
-        <p:nvSpPr>
-          <p:cNvPr id="204" name="proof"/>
-          <p:cNvSpPr txBox="1"/>
-          <p:nvPr/>
-        </p:nvSpPr>
-        <p:spPr>
-          <a:xfrm>
-            <a:off x="504000" y="6048000"/>
-            <a:ext cx="2106000" cy="576000"/>
+            <a:endParaRPr lang="ru-RU" sz="660"/>
+          </a:p>
+          <a:p>
+            <a:pPr>
+              <a:buNone/>
+            </a:pPr>
+            <a:r>
+              <a:rPr lang="ru-RU" sz="545">
+                <a:solidFill>
+                  <a:srgbClr val="344054"/>
+                </a:solidFill>
+                <a:latin typeface="Arial"/>
+                <a:cs typeface="Arial"/>
+              </a:rPr>
+              <a:t>Пересборка стратегии, экономики привлечения, продукта, дистрибуции, IT и операционной модели в работающем контуре банка.</a:t>
+            </a:r>
+            <a:endParaRPr lang="ru-RU" sz="545"/>
+          </a:p>
+        </p:txBody>
+      </p:sp>
+      <p:sp>
+        <p:nvSpPr>
+          <p:cNvPr id="207" name="metric"/>
+          <p:cNvSpPr txBox="1"/>
+          <p:nvPr/>
+        </p:nvSpPr>
+        <p:spPr>
+          <a:xfrm>
+            <a:off x="504000" y="5904000"/>
+            <a:ext cx="565200" cy="208800"/>
           </a:xfrm>
           <a:prstGeom prst="roundRect">
             <a:avLst/>
@@ -867,7 +923,7 @@
           </a:solidFill>
           <a:ln w="6350">
             <a:solidFill>
-              <a:srgbClr val="D5E6F7"/>
+              <a:srgbClr val="E8F1FB"/>
             </a:solidFill>
           </a:ln>
         </p:spPr>
@@ -879,45 +935,29 @@
               <a:buNone/>
             </a:pPr>
             <a:r>
-              <a:rPr lang="ru-RU" sz="930" b="1">
+              <a:rPr lang="ru-RU" sz="600" b="1">
                 <a:solidFill>
                   <a:srgbClr val="0F4778"/>
                 </a:solidFill>
                 <a:latin typeface="Arial"/>
                 <a:cs typeface="Arial"/>
               </a:rPr>
-              <a:t>25 млн</a:t>
-            </a:r>
-            <a:endParaRPr lang="ru-RU" sz="930"/>
-          </a:p>
-          <a:p>
-            <a:pPr>
-              <a:buNone/>
-            </a:pPr>
-            <a:r>
-              <a:rPr lang="ru-RU" sz="465">
-                <a:solidFill>
-                  <a:srgbClr val="173A5E"/>
-                </a:solidFill>
-                <a:latin typeface="Arial"/>
-                <a:cs typeface="Arial"/>
-              </a:rPr>
-              <a:t>клиентов в дебетовых картах и расчетных продуктах ВТБ после корректировки стратегии</a:t>
-            </a:r>
-            <a:endParaRPr lang="ru-RU" sz="465"/>
-          </a:p>
-        </p:txBody>
-      </p:sp>
-      <p:sp>
-        <p:nvSpPr>
-          <p:cNvPr id="205" name="proof"/>
-          <p:cNvSpPr txBox="1"/>
-          <p:nvPr/>
-        </p:nvSpPr>
-        <p:spPr>
-          <a:xfrm>
-            <a:off x="2664000" y="6048000"/>
-            <a:ext cx="2106000" cy="576000"/>
+              <a:t>№2 по АКБ</a:t>
+            </a:r>
+            <a:endParaRPr lang="ru-RU" sz="600"/>
+          </a:p>
+        </p:txBody>
+      </p:sp>
+      <p:sp>
+        <p:nvSpPr>
+          <p:cNvPr id="208" name="metric"/>
+          <p:cNvSpPr txBox="1"/>
+          <p:nvPr/>
+        </p:nvSpPr>
+        <p:spPr>
+          <a:xfrm>
+            <a:off x="1141200" y="5904000"/>
+            <a:ext cx="540000" cy="208800"/>
           </a:xfrm>
           <a:prstGeom prst="roundRect">
             <a:avLst/>
@@ -927,7 +967,7 @@
           </a:solidFill>
           <a:ln w="6350">
             <a:solidFill>
-              <a:srgbClr val="D5E6F7"/>
+              <a:srgbClr val="E8F1FB"/>
             </a:solidFill>
           </a:ln>
         </p:spPr>
@@ -939,45 +979,29 @@
               <a:buNone/>
             </a:pPr>
             <a:r>
-              <a:rPr lang="ru-RU" sz="930" b="1">
+              <a:rPr lang="ru-RU" sz="600" b="1">
                 <a:solidFill>
                   <a:srgbClr val="0F4778"/>
                 </a:solidFill>
                 <a:latin typeface="Arial"/>
                 <a:cs typeface="Arial"/>
               </a:rPr>
-              <a:t>+25% YoY</a:t>
-            </a:r>
-            <a:endParaRPr lang="ru-RU" sz="930"/>
-          </a:p>
-          <a:p>
-            <a:pPr>
-              <a:buNone/>
-            </a:pPr>
-            <a:r>
-              <a:rPr lang="ru-RU" sz="465">
-                <a:solidFill>
-                  <a:srgbClr val="173A5E"/>
-                </a:solidFill>
-                <a:latin typeface="Arial"/>
-                <a:cs typeface="Arial"/>
-              </a:rPr>
-              <a:t>рост активной клиентской базы за счет продуктовых, маркетинговых и дистрибуционных изменений</a:t>
-            </a:r>
-            <a:endParaRPr lang="ru-RU" sz="465"/>
-          </a:p>
-        </p:txBody>
-      </p:sp>
-      <p:sp>
-        <p:nvSpPr>
-          <p:cNvPr id="206" name="proof"/>
-          <p:cNvSpPr txBox="1"/>
-          <p:nvPr/>
-        </p:nvSpPr>
-        <p:spPr>
-          <a:xfrm>
-            <a:off x="504000" y="6678000"/>
-            <a:ext cx="2106000" cy="576000"/>
+              <a:t>25 млн</a:t>
+            </a:r>
+            <a:endParaRPr lang="ru-RU" sz="600"/>
+          </a:p>
+        </p:txBody>
+      </p:sp>
+      <p:sp>
+        <p:nvSpPr>
+          <p:cNvPr id="209" name="metric"/>
+          <p:cNvSpPr txBox="1"/>
+          <p:nvPr/>
+        </p:nvSpPr>
+        <p:spPr>
+          <a:xfrm>
+            <a:off x="1753200" y="5904000"/>
+            <a:ext cx="540000" cy="208800"/>
           </a:xfrm>
           <a:prstGeom prst="roundRect">
             <a:avLst/>
@@ -987,7 +1011,7 @@
           </a:solidFill>
           <a:ln w="6350">
             <a:solidFill>
-              <a:srgbClr val="D5E6F7"/>
+              <a:srgbClr val="E8F1FB"/>
             </a:solidFill>
           </a:ln>
         </p:spPr>
@@ -999,45 +1023,29 @@
               <a:buNone/>
             </a:pPr>
             <a:r>
-              <a:rPr lang="ru-RU" sz="930" b="1">
+              <a:rPr lang="ru-RU" sz="600" b="1">
                 <a:solidFill>
                   <a:srgbClr val="0F4778"/>
                 </a:solidFill>
                 <a:latin typeface="Arial"/>
                 <a:cs typeface="Arial"/>
               </a:rPr>
-              <a:t>N2 по АКБ</a:t>
-            </a:r>
-            <a:endParaRPr lang="ru-RU" sz="930"/>
-          </a:p>
-          <a:p>
-            <a:pPr>
-              <a:buNone/>
-            </a:pPr>
-            <a:r>
-              <a:rPr lang="ru-RU" sz="465">
-                <a:solidFill>
-                  <a:srgbClr val="173A5E"/>
-                </a:solidFill>
-                <a:latin typeface="Arial"/>
-                <a:cs typeface="Arial"/>
-              </a:rPr>
-              <a:t>итоговая рыночная позиция направления после трансформации модели работы</a:t>
-            </a:r>
-            <a:endParaRPr lang="ru-RU" sz="465"/>
-          </a:p>
-        </p:txBody>
-      </p:sp>
-      <p:sp>
-        <p:nvSpPr>
-          <p:cNvPr id="207" name="proof"/>
-          <p:cNvSpPr txBox="1"/>
-          <p:nvPr/>
-        </p:nvSpPr>
-        <p:spPr>
-          <a:xfrm>
-            <a:off x="2664000" y="6678000"/>
-            <a:ext cx="2106000" cy="576000"/>
+              <a:t>+25% YoY</a:t>
+            </a:r>
+            <a:endParaRPr lang="ru-RU" sz="600"/>
+          </a:p>
+        </p:txBody>
+      </p:sp>
+      <p:sp>
+        <p:nvSpPr>
+          <p:cNvPr id="210" name="metric"/>
+          <p:cNvSpPr txBox="1"/>
+          <p:nvPr/>
+        </p:nvSpPr>
+        <p:spPr>
+          <a:xfrm>
+            <a:off x="2365200" y="5904000"/>
+            <a:ext cx="892800" cy="208800"/>
           </a:xfrm>
           <a:prstGeom prst="roundRect">
             <a:avLst/>
@@ -1047,7 +1055,7 @@
           </a:solidFill>
           <a:ln w="6350">
             <a:solidFill>
-              <a:srgbClr val="D5E6F7"/>
+              <a:srgbClr val="E8F1FB"/>
             </a:solidFill>
           </a:ln>
         </p:spPr>
@@ -1059,7 +1067,7 @@
               <a:buNone/>
             </a:pPr>
             <a:r>
-              <a:rPr lang="ru-RU" sz="930" b="1">
+              <a:rPr lang="ru-RU" sz="600" b="1">
                 <a:solidFill>
                   <a:srgbClr val="0F4778"/>
                 </a:solidFill>
@@ -1068,23 +1076,61 @@
               </a:rPr>
               <a:t>IT-трансформация</a:t>
             </a:r>
-            <a:endParaRPr lang="ru-RU" sz="930"/>
-          </a:p>
-          <a:p>
-            <a:pPr>
-              <a:buNone/>
-            </a:pPr>
-            <a:r>
-              <a:rPr lang="ru-RU" sz="465">
+            <a:endParaRPr lang="ru-RU" sz="600"/>
+          </a:p>
+        </p:txBody>
+      </p:sp>
+      <p:sp>
+        <p:nvSpPr>
+          <p:cNvPr id="211" name="ВТБ Дебетовые карты и расчетные продукты"/>
+          <p:cNvSpPr txBox="1"/>
+          <p:nvPr/>
+        </p:nvSpPr>
+        <p:spPr>
+          <a:xfrm>
+            <a:off x="504000" y="6163200"/>
+            <a:ext cx="4248000" cy="450000"/>
+          </a:xfrm>
+          <a:prstGeom prst="roundRect">
+            <a:avLst/>
+          </a:prstGeom>
+          <a:solidFill>
+            <a:srgbClr val="EEF6FF"/>
+          </a:solidFill>
+          <a:ln w="6350">
+            <a:solidFill>
+              <a:srgbClr val="EEF6FF"/>
+            </a:solidFill>
+          </a:ln>
+        </p:spPr>
+        <p:txBody>
+          <a:bodyPr wrap="square" lIns="9000" tIns="9000" rIns="9000" bIns="9000"/>
+          <a:lstStyle/>
+          <a:p>
+            <a:pPr>
+              <a:buNone/>
+            </a:pPr>
+            <a:r>
+              <a:rPr lang="ru-RU" sz="435" b="1">
+                <a:solidFill>
+                  <a:srgbClr val="0F2742"/>
+                </a:solidFill>
+                <a:latin typeface="Arial"/>
+                <a:cs typeface="Arial"/>
+              </a:rPr>
+              <a:t>ВТБ Дебетовые карты и расчетные продукты: </a:t>
+            </a:r>
+            <a:r>
+              <a:rPr lang="ru-RU" sz="435">
                 <a:solidFill>
                   <a:srgbClr val="173A5E"/>
                 </a:solidFill>
                 <a:latin typeface="Arial"/>
                 <a:cs typeface="Arial"/>
               </a:rPr>
-              <a:t>продукт, маркетинг и каналы изменены параллельно с технологической программой</a:t>
-            </a:r>
-            <a:endParaRPr lang="ru-RU" sz="465"/>
+              <a:t>Скорректирована стратегия под наращивание клиентской базы, определены инструменты и стоимость привлечения, найдены источники финансирования. Внедрены продуктовые, маркетинговые, дистрибуционные изменения одновременно с масштабной ИТ-трансформацией. Итоговая позиция: №2 по АКБ, 25 млн. клиентов, рост +25% YoY</a:t>
+            </a:r>
+            <a:endParaRPr lang="ru-RU" sz="435"/>
           </a:p>
         </p:txBody>
       </p:sp>
@@ -1096,8 +1142,8 @@
         </p:nvSpPr>
         <p:spPr>
           <a:xfrm>
-            <a:off x="396000" y="7488000"/>
-            <a:ext cx="4500000" cy="1980000"/>
+            <a:off x="396000" y="7524000"/>
+            <a:ext cx="4464000" cy="2196000"/>
           </a:xfrm>
           <a:prstGeom prst="roundRect">
             <a:avLst/>
@@ -1112,14 +1158,14 @@
           </a:ln>
         </p:spPr>
         <p:txBody>
-          <a:bodyPr wrap="square" lIns="16000" tIns="16000" rIns="16000" bIns="16000"/>
-          <a:lstStyle/>
-          <a:p>
-            <a:pPr>
-              <a:buNone/>
-            </a:pPr>
-            <a:r>
-              <a:rPr lang="ru-RU" sz="690" b="1">
+          <a:bodyPr wrap="square" lIns="14500" tIns="14500" rIns="14500" bIns="14500"/>
+          <a:lstStyle/>
+          <a:p>
+            <a:pPr>
+              <a:buNone/>
+            </a:pPr>
+            <a:r>
+              <a:rPr lang="ru-RU" sz="660" b="1">
                 <a:solidFill>
                   <a:srgbClr val="173A5E"/>
                 </a:solidFill>
@@ -1128,52 +1174,36 @@
               </a:rPr>
               <a:t>LEAD - сложные программы с большим количеством участников</a:t>
             </a:r>
-            <a:endParaRPr lang="ru-RU" sz="690"/>
-          </a:p>
-          <a:p>
-            <a:pPr marL="135000" indent="-70000">
-              <a:buChar char="•"/>
-            </a:pPr>
-            <a:r>
-              <a:rPr lang="ru-RU" sz="520">
-                <a:solidFill>
-                  <a:srgbClr val="1F2933"/>
-                </a:solidFill>
-                <a:latin typeface="Arial"/>
-                <a:cs typeface="Arial"/>
-              </a:rPr>
-              <a:t>Формирую концепт, систему принятия решений и общие цели для бизнеса, IT, операций, продаж, маркетинга, регулятора и партнеров.</a:t>
-            </a:r>
-            <a:endParaRPr lang="ru-RU" sz="520"/>
-          </a:p>
-          <a:p>
-            <a:pPr marL="135000" indent="-70000">
-              <a:buChar char="•"/>
-            </a:pPr>
-            <a:r>
-              <a:rPr lang="ru-RU" sz="520">
-                <a:solidFill>
-                  <a:srgbClr val="1F2933"/>
-                </a:solidFill>
-                <a:latin typeface="Arial"/>
-                <a:cs typeface="Arial"/>
-              </a:rPr>
-              <a:t>Организую Agile-команды и крупные delivery-программы; обеспечиваю бесшовность критичных изменений для клиентов.</a:t>
-            </a:r>
-            <a:endParaRPr lang="ru-RU" sz="520"/>
-          </a:p>
-        </p:txBody>
-      </p:sp>
-      <p:sp>
-        <p:nvSpPr>
-          <p:cNvPr id="208" name="proof"/>
-          <p:cNvSpPr txBox="1"/>
-          <p:nvPr/>
-        </p:nvSpPr>
-        <p:spPr>
-          <a:xfrm>
-            <a:off x="504000" y="8172000"/>
-            <a:ext cx="2106000" cy="576000"/>
+            <a:endParaRPr lang="ru-RU" sz="660"/>
+          </a:p>
+          <a:p>
+            <a:pPr>
+              <a:buNone/>
+            </a:pPr>
+            <a:r>
+              <a:rPr lang="ru-RU" sz="545">
+                <a:solidFill>
+                  <a:srgbClr val="344054"/>
+                </a:solidFill>
+                <a:latin typeface="Arial"/>
+                <a:cs typeface="Arial"/>
+              </a:rPr>
+              <a:t>Синхронизация бизнеса, IT, операций, продаж, маркетинга, регулятора и внешних партнеров вокруг результата.</a:t>
+            </a:r>
+            <a:endParaRPr lang="ru-RU" sz="545"/>
+          </a:p>
+        </p:txBody>
+      </p:sp>
+      <p:sp>
+        <p:nvSpPr>
+          <p:cNvPr id="212" name="metric"/>
+          <p:cNvSpPr txBox="1"/>
+          <p:nvPr/>
+        </p:nvSpPr>
+        <p:spPr>
+          <a:xfrm>
+            <a:off x="504000" y="7992000"/>
+            <a:ext cx="658800" cy="208800"/>
           </a:xfrm>
           <a:prstGeom prst="roundRect">
             <a:avLst/>
@@ -1183,7 +1213,7 @@
           </a:solidFill>
           <a:ln w="6350">
             <a:solidFill>
-              <a:srgbClr val="D5E6F7"/>
+              <a:srgbClr val="E8F1FB"/>
             </a:solidFill>
           </a:ln>
         </p:spPr>
@@ -1195,45 +1225,29 @@
               <a:buNone/>
             </a:pPr>
             <a:r>
-              <a:rPr lang="ru-RU" sz="930" b="1">
+              <a:rPr lang="ru-RU" sz="600" b="1">
                 <a:solidFill>
                   <a:srgbClr val="0F4778"/>
                 </a:solidFill>
                 <a:latin typeface="Arial"/>
                 <a:cs typeface="Arial"/>
               </a:rPr>
-              <a:t>20 млн</a:t>
-            </a:r>
-            <a:endParaRPr lang="ru-RU" sz="930"/>
-          </a:p>
-          <a:p>
-            <a:pPr>
-              <a:buNone/>
-            </a:pPr>
-            <a:r>
-              <a:rPr lang="ru-RU" sz="465">
-                <a:solidFill>
-                  <a:srgbClr val="173A5E"/>
-                </a:solidFill>
-                <a:latin typeface="Arial"/>
-                <a:cs typeface="Arial"/>
-              </a:rPr>
-              <a:t>действующих клиентов ВТБ переведены на новый процессинг без простоя в операциях</a:t>
-            </a:r>
-            <a:endParaRPr lang="ru-RU" sz="465"/>
-          </a:p>
-        </p:txBody>
-      </p:sp>
-      <p:sp>
-        <p:nvSpPr>
-          <p:cNvPr id="209" name="proof"/>
-          <p:cNvSpPr txBox="1"/>
-          <p:nvPr/>
-        </p:nvSpPr>
-        <p:spPr>
-          <a:xfrm>
-            <a:off x="2664000" y="8172000"/>
-            <a:ext cx="2106000" cy="576000"/>
+              <a:t>1,5 млн / 8</a:t>
+            </a:r>
+            <a:endParaRPr lang="ru-RU" sz="600"/>
+          </a:p>
+        </p:txBody>
+      </p:sp>
+      <p:sp>
+        <p:nvSpPr>
+          <p:cNvPr id="213" name="metric"/>
+          <p:cNvSpPr txBox="1"/>
+          <p:nvPr/>
+        </p:nvSpPr>
+        <p:spPr>
+          <a:xfrm>
+            <a:off x="1234800" y="7992000"/>
+            <a:ext cx="540000" cy="208800"/>
           </a:xfrm>
           <a:prstGeom prst="roundRect">
             <a:avLst/>
@@ -1243,7 +1257,7 @@
           </a:solidFill>
           <a:ln w="6350">
             <a:solidFill>
-              <a:srgbClr val="D5E6F7"/>
+              <a:srgbClr val="E8F1FB"/>
             </a:solidFill>
           </a:ln>
         </p:spPr>
@@ -1255,45 +1269,29 @@
               <a:buNone/>
             </a:pPr>
             <a:r>
-              <a:rPr lang="ru-RU" sz="930" b="1">
+              <a:rPr lang="ru-RU" sz="600" b="1">
                 <a:solidFill>
                   <a:srgbClr val="0F4778"/>
                 </a:solidFill>
                 <a:latin typeface="Arial"/>
                 <a:cs typeface="Arial"/>
               </a:rPr>
-              <a:t>2 млн / 8 мес.</a:t>
-            </a:r>
-            <a:endParaRPr lang="ru-RU" sz="930"/>
-          </a:p>
-          <a:p>
-            <a:pPr>
-              <a:buNone/>
-            </a:pPr>
-            <a:r>
-              <a:rPr lang="ru-RU" sz="465">
-                <a:solidFill>
-                  <a:srgbClr val="173A5E"/>
-                </a:solidFill>
-                <a:latin typeface="Arial"/>
-                <a:cs typeface="Arial"/>
-              </a:rPr>
-              <a:t>детей с Пушкинскими картами мигрированы в федеральном проекте</a:t>
-            </a:r>
-            <a:endParaRPr lang="ru-RU" sz="465"/>
-          </a:p>
-        </p:txBody>
-      </p:sp>
-      <p:sp>
-        <p:nvSpPr>
-          <p:cNvPr id="210" name="proof"/>
-          <p:cNvSpPr txBox="1"/>
-          <p:nvPr/>
-        </p:nvSpPr>
-        <p:spPr>
-          <a:xfrm>
-            <a:off x="504000" y="8802000"/>
-            <a:ext cx="2106000" cy="576000"/>
+              <a:t>20 млн</a:t>
+            </a:r>
+            <a:endParaRPr lang="ru-RU" sz="600"/>
+          </a:p>
+        </p:txBody>
+      </p:sp>
+      <p:sp>
+        <p:nvSpPr>
+          <p:cNvPr id="214" name="metric"/>
+          <p:cNvSpPr txBox="1"/>
+          <p:nvPr/>
+        </p:nvSpPr>
+        <p:spPr>
+          <a:xfrm>
+            <a:off x="1846800" y="7992000"/>
+            <a:ext cx="799200" cy="208800"/>
           </a:xfrm>
           <a:prstGeom prst="roundRect">
             <a:avLst/>
@@ -1303,7 +1301,7 @@
           </a:solidFill>
           <a:ln w="6350">
             <a:solidFill>
-              <a:srgbClr val="D5E6F7"/>
+              <a:srgbClr val="E8F1FB"/>
             </a:solidFill>
           </a:ln>
         </p:spPr>
@@ -1315,45 +1313,29 @@
               <a:buNone/>
             </a:pPr>
             <a:r>
-              <a:rPr lang="ru-RU" sz="930" b="1">
+              <a:rPr lang="ru-RU" sz="600" b="1">
                 <a:solidFill>
                   <a:srgbClr val="0F4778"/>
                 </a:solidFill>
                 <a:latin typeface="Arial"/>
                 <a:cs typeface="Arial"/>
               </a:rPr>
-              <a:t>1,5 млн / 8</a:t>
-            </a:r>
-            <a:endParaRPr lang="ru-RU" sz="930"/>
-          </a:p>
-          <a:p>
-            <a:pPr>
-              <a:buNone/>
-            </a:pPr>
-            <a:r>
-              <a:rPr lang="ru-RU" sz="465">
-                <a:solidFill>
-                  <a:srgbClr val="173A5E"/>
-                </a:solidFill>
-                <a:latin typeface="Arial"/>
-                <a:cs typeface="Arial"/>
-              </a:rPr>
-              <a:t>клиентов Открытия мигрированы на разных продуктовых линейках и 8 процессингах</a:t>
-            </a:r>
-            <a:endParaRPr lang="ru-RU" sz="465"/>
-          </a:p>
-        </p:txBody>
-      </p:sp>
-      <p:sp>
-        <p:nvSpPr>
-          <p:cNvPr id="211" name="proof"/>
-          <p:cNvSpPr txBox="1"/>
-          <p:nvPr/>
-        </p:nvSpPr>
-        <p:spPr>
-          <a:xfrm>
-            <a:off x="2664000" y="8802000"/>
-            <a:ext cx="2106000" cy="576000"/>
+              <a:t>2 млн / 8 мес.</a:t>
+            </a:r>
+            <a:endParaRPr lang="ru-RU" sz="600"/>
+          </a:p>
+        </p:txBody>
+      </p:sp>
+      <p:sp>
+        <p:nvSpPr>
+          <p:cNvPr id="215" name="metric"/>
+          <p:cNvSpPr txBox="1"/>
+          <p:nvPr/>
+        </p:nvSpPr>
+        <p:spPr>
+          <a:xfrm>
+            <a:off x="2718000" y="7992000"/>
+            <a:ext cx="540000" cy="208800"/>
           </a:xfrm>
           <a:prstGeom prst="roundRect">
             <a:avLst/>
@@ -1363,7 +1345,7 @@
           </a:solidFill>
           <a:ln w="6350">
             <a:solidFill>
-              <a:srgbClr val="D5E6F7"/>
+              <a:srgbClr val="E8F1FB"/>
             </a:solidFill>
           </a:ln>
         </p:spPr>
@@ -1375,32 +1357,168 @@
               <a:buNone/>
             </a:pPr>
             <a:r>
-              <a:rPr lang="ru-RU" sz="930" b="1">
+              <a:rPr lang="ru-RU" sz="600" b="1">
                 <a:solidFill>
                   <a:srgbClr val="0F4778"/>
                 </a:solidFill>
                 <a:latin typeface="Arial"/>
                 <a:cs typeface="Arial"/>
               </a:rPr>
-              <a:t>170 / 12</a:t>
-            </a:r>
-            <a:endParaRPr lang="ru-RU" sz="930"/>
-          </a:p>
-          <a:p>
-            <a:pPr>
-              <a:buNone/>
-            </a:pPr>
-            <a:r>
-              <a:rPr lang="ru-RU" sz="465">
+              <a:t>SDN</a:t>
+            </a:r>
+            <a:endParaRPr lang="ru-RU" sz="600"/>
+          </a:p>
+        </p:txBody>
+      </p:sp>
+      <p:sp>
+        <p:nvSpPr>
+          <p:cNvPr id="216" name="metric"/>
+          <p:cNvSpPr txBox="1"/>
+          <p:nvPr/>
+        </p:nvSpPr>
+        <p:spPr>
+          <a:xfrm>
+            <a:off x="3330000" y="7992000"/>
+            <a:ext cx="540000" cy="208800"/>
+          </a:xfrm>
+          <a:prstGeom prst="roundRect">
+            <a:avLst/>
+          </a:prstGeom>
+          <a:solidFill>
+            <a:srgbClr val="E8F1FB"/>
+          </a:solidFill>
+          <a:ln w="6350">
+            <a:solidFill>
+              <a:srgbClr val="E8F1FB"/>
+            </a:solidFill>
+          </a:ln>
+        </p:spPr>
+        <p:txBody>
+          <a:bodyPr wrap="square" lIns="12000" tIns="12000" rIns="12000" bIns="12000"/>
+          <a:lstStyle/>
+          <a:p>
+            <a:pPr>
+              <a:buNone/>
+            </a:pPr>
+            <a:r>
+              <a:rPr lang="ru-RU" sz="600" b="1">
+                <a:solidFill>
+                  <a:srgbClr val="0F4778"/>
+                </a:solidFill>
+                <a:latin typeface="Arial"/>
+                <a:cs typeface="Arial"/>
+              </a:rPr>
+              <a:t>Agile</a:t>
+            </a:r>
+            <a:endParaRPr lang="ru-RU" sz="600"/>
+          </a:p>
+        </p:txBody>
+      </p:sp>
+      <p:sp>
+        <p:nvSpPr>
+          <p:cNvPr id="217" name="ФК Банк Открытие"/>
+          <p:cNvSpPr txBox="1"/>
+          <p:nvPr/>
+        </p:nvSpPr>
+        <p:spPr>
+          <a:xfrm>
+            <a:off x="504000" y="8251200"/>
+            <a:ext cx="4248000" cy="450000"/>
+          </a:xfrm>
+          <a:prstGeom prst="roundRect">
+            <a:avLst/>
+          </a:prstGeom>
+          <a:solidFill>
+            <a:srgbClr val="EEF6FF"/>
+          </a:solidFill>
+          <a:ln w="6350">
+            <a:solidFill>
+              <a:srgbClr val="EEF6FF"/>
+            </a:solidFill>
+          </a:ln>
+        </p:spPr>
+        <p:txBody>
+          <a:bodyPr wrap="square" lIns="9000" tIns="9000" rIns="9000" bIns="9000"/>
+          <a:lstStyle/>
+          <a:p>
+            <a:pPr>
+              <a:buNone/>
+            </a:pPr>
+            <a:r>
+              <a:rPr lang="ru-RU" sz="435" b="1">
+                <a:solidFill>
+                  <a:srgbClr val="0F2742"/>
+                </a:solidFill>
+                <a:latin typeface="Arial"/>
+                <a:cs typeface="Arial"/>
+              </a:rPr>
+              <a:t>ФК Банк Открытие: </a:t>
+            </a:r>
+            <a:r>
+              <a:rPr lang="ru-RU" sz="435">
                 <a:solidFill>
                   <a:srgbClr val="173A5E"/>
                 </a:solidFill>
                 <a:latin typeface="Arial"/>
                 <a:cs typeface="Arial"/>
               </a:rPr>
-              <a:t>масштаб delivery: 170 человек, продукт + IT, штат/аутсорс, 12 команд</a:t>
-            </a:r>
-            <a:endParaRPr lang="ru-RU" sz="465"/>
+              <a:t>Бизнес и технологическая миграция 1.5 млн. клиентов на различных продуктовых линейках на 8 процессингах без оттока; переход на Agile и создание Трайбов; управление первой волной SDN.</a:t>
+            </a:r>
+            <a:endParaRPr lang="ru-RU" sz="435"/>
+          </a:p>
+        </p:txBody>
+      </p:sp>
+      <p:sp>
+        <p:nvSpPr>
+          <p:cNvPr id="218" name="ВТБ"/>
+          <p:cNvSpPr txBox="1"/>
+          <p:nvPr/>
+        </p:nvSpPr>
+        <p:spPr>
+          <a:xfrm>
+            <a:off x="504000" y="8737200"/>
+            <a:ext cx="4248000" cy="450000"/>
+          </a:xfrm>
+          <a:prstGeom prst="roundRect">
+            <a:avLst/>
+          </a:prstGeom>
+          <a:solidFill>
+            <a:srgbClr val="EEF6FF"/>
+          </a:solidFill>
+          <a:ln w="6350">
+            <a:solidFill>
+              <a:srgbClr val="EEF6FF"/>
+            </a:solidFill>
+          </a:ln>
+        </p:spPr>
+        <p:txBody>
+          <a:bodyPr wrap="square" lIns="9000" tIns="9000" rIns="9000" bIns="9000"/>
+          <a:lstStyle/>
+          <a:p>
+            <a:pPr>
+              <a:buNone/>
+            </a:pPr>
+            <a:r>
+              <a:rPr lang="ru-RU" sz="435" b="1">
+                <a:solidFill>
+                  <a:srgbClr val="0F2742"/>
+                </a:solidFill>
+                <a:latin typeface="Arial"/>
+                <a:cs typeface="Arial"/>
+              </a:rPr>
+              <a:t>ВТБ: </a:t>
+            </a:r>
+            <a:r>
+              <a:rPr lang="ru-RU" sz="435">
+                <a:solidFill>
+                  <a:srgbClr val="173A5E"/>
+                </a:solidFill>
+                <a:latin typeface="Arial"/>
+                <a:cs typeface="Arial"/>
+              </a:rPr>
+              <a:t>Импортозамещение и бесшовная замена процессинга для 20 млн действующих клиентов без простоя; федеральный проект миграции 2 млн детей с Пушкинскими картами за 8 месяцев.</a:t>
+            </a:r>
+            <a:endParaRPr lang="ru-RU" sz="435"/>
           </a:p>
         </p:txBody>
       </p:sp>
@@ -1412,7 +1530,7 @@
         </p:nvSpPr>
         <p:spPr>
           <a:xfrm>
-            <a:off x="5112000" y="2880000"/>
+            <a:off x="5112000" y="2808000"/>
             <a:ext cx="2052000" cy="216000"/>
           </a:xfrm>
           <a:prstGeom prst="rect">
@@ -1431,7 +1549,7 @@
               <a:buNone/>
             </a:pPr>
             <a:r>
-              <a:rPr lang="ru-RU" sz="780" b="1">
+              <a:rPr lang="ru-RU" sz="770" b="1">
                 <a:solidFill>
                   <a:srgbClr val="0F2742"/>
                 </a:solidFill>
@@ -1440,7 +1558,7 @@
               </a:rPr>
               <a:t>ЦЕЛЕВЫЕ РОЛИ</a:t>
             </a:r>
-            <a:endParaRPr lang="ru-RU" sz="780"/>
+            <a:endParaRPr lang="ru-RU" sz="770"/>
           </a:p>
         </p:txBody>
       </p:sp>
@@ -1452,7 +1570,7 @@
         </p:nvSpPr>
         <p:spPr>
           <a:xfrm>
-            <a:off x="5112000" y="3132000"/>
+            <a:off x="5112000" y="3060000"/>
             <a:ext cx="2052000" cy="9000"/>
           </a:xfrm>
           <a:prstGeom prst="rect">
@@ -1474,8 +1592,8 @@
         </p:nvSpPr>
         <p:spPr>
           <a:xfrm>
-            <a:off x="5112000" y="3276000"/>
-            <a:ext cx="2052000" cy="1404000"/>
+            <a:off x="5112000" y="3204000"/>
+            <a:ext cx="2052000" cy="1440000"/>
           </a:xfrm>
           <a:prstGeom prst="rect">
             <a:avLst/>
@@ -1493,7 +1611,7 @@
               <a:buNone/>
             </a:pPr>
             <a:r>
-              <a:rPr lang="ru-RU" sz="600">
+              <a:rPr lang="ru-RU" sz="590">
                 <a:solidFill>
                   <a:srgbClr val="1F2933"/>
                 </a:solidFill>
@@ -1502,7 +1620,7 @@
               </a:rPr>
               <a:t>Chief Business Officer / Chief Product Officer / Chief Operating Officer / Head of Retail Banking / Managing Director по розничному бизнесу, продуктам, платежам, клиентским платформам или трансформации финансового бизнеса.</a:t>
             </a:r>
-            <a:endParaRPr lang="ru-RU" sz="600"/>
+            <a:endParaRPr lang="ru-RU" sz="590"/>
           </a:p>
         </p:txBody>
       </p:sp>
@@ -1514,7 +1632,7 @@
         </p:nvSpPr>
         <p:spPr>
           <a:xfrm>
-            <a:off x="5112000" y="4932000"/>
+            <a:off x="5112000" y="4896000"/>
             <a:ext cx="2052000" cy="216000"/>
           </a:xfrm>
           <a:prstGeom prst="rect">
@@ -1533,7 +1651,7 @@
               <a:buNone/>
             </a:pPr>
             <a:r>
-              <a:rPr lang="ru-RU" sz="780" b="1">
+              <a:rPr lang="ru-RU" sz="770" b="1">
                 <a:solidFill>
                   <a:srgbClr val="0F2742"/>
                 </a:solidFill>
@@ -1542,7 +1660,7 @@
               </a:rPr>
               <a:t>ЗОНЫ ЭКСПЕРТИЗЫ</a:t>
             </a:r>
-            <a:endParaRPr lang="ru-RU" sz="780"/>
+            <a:endParaRPr lang="ru-RU" sz="770"/>
           </a:p>
         </p:txBody>
       </p:sp>
@@ -1554,7 +1672,7 @@
         </p:nvSpPr>
         <p:spPr>
           <a:xfrm>
-            <a:off x="5112000" y="5184000"/>
+            <a:off x="5112000" y="5148000"/>
             <a:ext cx="2052000" cy="9000"/>
           </a:xfrm>
           <a:prstGeom prst="rect">
@@ -1576,8 +1694,8 @@
         </p:nvSpPr>
         <p:spPr>
           <a:xfrm>
-            <a:off x="5112000" y="5292000"/>
-            <a:ext cx="2052000" cy="504000"/>
+            <a:off x="5112000" y="5256000"/>
+            <a:ext cx="2052000" cy="468000"/>
           </a:xfrm>
           <a:prstGeom prst="rect">
             <a:avLst/>
@@ -1595,7 +1713,7 @@
               <a:buNone/>
             </a:pPr>
             <a:r>
-              <a:rPr lang="ru-RU" sz="560">
+              <a:rPr lang="ru-RU" sz="540">
                 <a:solidFill>
                   <a:srgbClr val="667085"/>
                 </a:solidFill>
@@ -1604,7 +1722,7 @@
               </a:rPr>
               <a:t>Уровень вовлеченности в областях с hands-on управленческим опытом.</a:t>
             </a:r>
-            <a:endParaRPr lang="ru-RU" sz="560"/>
+            <a:endParaRPr lang="ru-RU" sz="540"/>
           </a:p>
         </p:txBody>
       </p:sp>
@@ -1616,8 +1734,8 @@
         </p:nvSpPr>
         <p:spPr>
           <a:xfrm>
-            <a:off x="5112000" y="5832000"/>
-            <a:ext cx="2052000" cy="180000"/>
+            <a:off x="5112000" y="5760000"/>
+            <a:ext cx="2052000" cy="172800"/>
           </a:xfrm>
           <a:prstGeom prst="rect">
             <a:avLst/>
@@ -1635,7 +1753,7 @@
               <a:buNone/>
             </a:pPr>
             <a:r>
-              <a:rPr lang="ru-RU" sz="590" b="1">
+              <a:rPr lang="ru-RU" sz="570" b="1">
                 <a:solidFill>
                   <a:srgbClr val="173A5E"/>
                 </a:solidFill>
@@ -1645,7 +1763,7 @@
               <a:t>Retail business and P&amp;L</a:t>
             </a:r>
             <a:r>
-              <a:rPr lang="ru-RU" sz="590" b="1">
+              <a:rPr lang="ru-RU" sz="570" b="1">
                 <a:solidFill>
                   <a:srgbClr val="173A5E"/>
                 </a:solidFill>
@@ -1654,7 +1772,7 @@
               </a:rPr>
               <a:t> 100%</a:t>
             </a:r>
-            <a:endParaRPr lang="ru-RU" sz="590"/>
+            <a:endParaRPr lang="ru-RU" sz="570"/>
           </a:p>
         </p:txBody>
       </p:sp>
@@ -1666,8 +1784,8 @@
         </p:nvSpPr>
         <p:spPr>
           <a:xfrm>
-            <a:off x="5112000" y="6012000"/>
-            <a:ext cx="2052000" cy="90000"/>
+            <a:off x="5112000" y="5932800"/>
+            <a:ext cx="2052000" cy="86400"/>
           </a:xfrm>
           <a:prstGeom prst="rect">
             <a:avLst/>
@@ -1688,8 +1806,8 @@
         </p:nvSpPr>
         <p:spPr>
           <a:xfrm>
-            <a:off x="5112000" y="6012000"/>
-            <a:ext cx="2052000" cy="90000"/>
+            <a:off x="5112000" y="5932800"/>
+            <a:ext cx="2052000" cy="86400"/>
           </a:xfrm>
           <a:prstGeom prst="rect">
             <a:avLst/>
@@ -1710,8 +1828,8 @@
         </p:nvSpPr>
         <p:spPr>
           <a:xfrm>
-            <a:off x="5112000" y="6372000"/>
-            <a:ext cx="2052000" cy="180000"/>
+            <a:off x="5112000" y="6300000"/>
+            <a:ext cx="2052000" cy="172800"/>
           </a:xfrm>
           <a:prstGeom prst="rect">
             <a:avLst/>
@@ -1729,7 +1847,7 @@
               <a:buNone/>
             </a:pPr>
             <a:r>
-              <a:rPr lang="ru-RU" sz="590" b="1">
+              <a:rPr lang="ru-RU" sz="570" b="1">
                 <a:solidFill>
                   <a:srgbClr val="173A5E"/>
                 </a:solidFill>
@@ -1739,7 +1857,7 @@
               <a:t>Products and growth</a:t>
             </a:r>
             <a:r>
-              <a:rPr lang="ru-RU" sz="590" b="1">
+              <a:rPr lang="ru-RU" sz="570" b="1">
                 <a:solidFill>
                   <a:srgbClr val="173A5E"/>
                 </a:solidFill>
@@ -1748,7 +1866,7 @@
               </a:rPr>
               <a:t> 100%</a:t>
             </a:r>
-            <a:endParaRPr lang="ru-RU" sz="590"/>
+            <a:endParaRPr lang="ru-RU" sz="570"/>
           </a:p>
         </p:txBody>
       </p:sp>
@@ -1760,8 +1878,8 @@
         </p:nvSpPr>
         <p:spPr>
           <a:xfrm>
-            <a:off x="5112000" y="6552000"/>
-            <a:ext cx="2052000" cy="90000"/>
+            <a:off x="5112000" y="6472800"/>
+            <a:ext cx="2052000" cy="86400"/>
           </a:xfrm>
           <a:prstGeom prst="rect">
             <a:avLst/>
@@ -1782,8 +1900,8 @@
         </p:nvSpPr>
         <p:spPr>
           <a:xfrm>
-            <a:off x="5112000" y="6552000"/>
-            <a:ext cx="2052000" cy="90000"/>
+            <a:off x="5112000" y="6472800"/>
+            <a:ext cx="2052000" cy="86400"/>
           </a:xfrm>
           <a:prstGeom prst="rect">
             <a:avLst/>
@@ -1804,8 +1922,8 @@
         </p:nvSpPr>
         <p:spPr>
           <a:xfrm>
-            <a:off x="5112000" y="6912000"/>
-            <a:ext cx="2052000" cy="180000"/>
+            <a:off x="5112000" y="6840000"/>
+            <a:ext cx="2052000" cy="172800"/>
           </a:xfrm>
           <a:prstGeom prst="rect">
             <a:avLst/>
@@ -1823,7 +1941,7 @@
               <a:buNone/>
             </a:pPr>
             <a:r>
-              <a:rPr lang="ru-RU" sz="590" b="1">
+              <a:rPr lang="ru-RU" sz="570" b="1">
                 <a:solidFill>
                   <a:srgbClr val="173A5E"/>
                 </a:solidFill>
@@ -1833,7 +1951,7 @@
               <a:t>Channels and partnerships</a:t>
             </a:r>
             <a:r>
-              <a:rPr lang="ru-RU" sz="590" b="1">
+              <a:rPr lang="ru-RU" sz="570" b="1">
                 <a:solidFill>
                   <a:srgbClr val="173A5E"/>
                 </a:solidFill>
@@ -1842,7 +1960,7 @@
               </a:rPr>
               <a:t> 100%</a:t>
             </a:r>
-            <a:endParaRPr lang="ru-RU" sz="590"/>
+            <a:endParaRPr lang="ru-RU" sz="570"/>
           </a:p>
         </p:txBody>
       </p:sp>
@@ -1854,8 +1972,8 @@
         </p:nvSpPr>
         <p:spPr>
           <a:xfrm>
-            <a:off x="5112000" y="7092000"/>
-            <a:ext cx="2052000" cy="90000"/>
+            <a:off x="5112000" y="7012800"/>
+            <a:ext cx="2052000" cy="86400"/>
           </a:xfrm>
           <a:prstGeom prst="rect">
             <a:avLst/>
@@ -1876,8 +1994,8 @@
         </p:nvSpPr>
         <p:spPr>
           <a:xfrm>
-            <a:off x="5112000" y="7092000"/>
-            <a:ext cx="2052000" cy="90000"/>
+            <a:off x="5112000" y="7012800"/>
+            <a:ext cx="2052000" cy="86400"/>
           </a:xfrm>
           <a:prstGeom prst="rect">
             <a:avLst/>
@@ -1898,8 +2016,8 @@
         </p:nvSpPr>
         <p:spPr>
           <a:xfrm>
-            <a:off x="5112000" y="7452000"/>
-            <a:ext cx="2052000" cy="180000"/>
+            <a:off x="5112000" y="7380000"/>
+            <a:ext cx="2052000" cy="172800"/>
           </a:xfrm>
           <a:prstGeom prst="rect">
             <a:avLst/>
@@ -1917,7 +2035,7 @@
               <a:buNone/>
             </a:pPr>
             <a:r>
-              <a:rPr lang="ru-RU" sz="590" b="1">
+              <a:rPr lang="ru-RU" sz="570" b="1">
                 <a:solidFill>
                   <a:srgbClr val="173A5E"/>
                 </a:solidFill>
@@ -1927,7 +2045,7 @@
               <a:t>Technology and delivery</a:t>
             </a:r>
             <a:r>
-              <a:rPr lang="ru-RU" sz="590" b="1">
+              <a:rPr lang="ru-RU" sz="570" b="1">
                 <a:solidFill>
                   <a:srgbClr val="173A5E"/>
                 </a:solidFill>
@@ -1936,7 +2054,7 @@
               </a:rPr>
               <a:t> 80%</a:t>
             </a:r>
-            <a:endParaRPr lang="ru-RU" sz="590"/>
+            <a:endParaRPr lang="ru-RU" sz="570"/>
           </a:p>
         </p:txBody>
       </p:sp>
@@ -1948,8 +2066,8 @@
         </p:nvSpPr>
         <p:spPr>
           <a:xfrm>
-            <a:off x="5112000" y="7632000"/>
-            <a:ext cx="2052000" cy="90000"/>
+            <a:off x="5112000" y="7552800"/>
+            <a:ext cx="2052000" cy="86400"/>
           </a:xfrm>
           <a:prstGeom prst="rect">
             <a:avLst/>
@@ -1970,8 +2088,8 @@
         </p:nvSpPr>
         <p:spPr>
           <a:xfrm>
-            <a:off x="5112000" y="7632000"/>
-            <a:ext cx="1641600" cy="90000"/>
+            <a:off x="5112000" y="7552800"/>
+            <a:ext cx="1641600" cy="86400"/>
           </a:xfrm>
           <a:prstGeom prst="rect">
             <a:avLst/>
@@ -1992,8 +2110,8 @@
         </p:nvSpPr>
         <p:spPr>
           <a:xfrm>
-            <a:off x="5112000" y="7992000"/>
-            <a:ext cx="2052000" cy="180000"/>
+            <a:off x="5112000" y="7920000"/>
+            <a:ext cx="2052000" cy="172800"/>
           </a:xfrm>
           <a:prstGeom prst="rect">
             <a:avLst/>
@@ -2011,7 +2129,7 @@
               <a:buNone/>
             </a:pPr>
             <a:r>
-              <a:rPr lang="ru-RU" sz="590" b="1">
+              <a:rPr lang="ru-RU" sz="570" b="1">
                 <a:solidFill>
                   <a:srgbClr val="173A5E"/>
                 </a:solidFill>
@@ -2021,7 +2139,7 @@
               <a:t>Regulatory</a:t>
             </a:r>
             <a:r>
-              <a:rPr lang="ru-RU" sz="590" b="1">
+              <a:rPr lang="ru-RU" sz="570" b="1">
                 <a:solidFill>
                   <a:srgbClr val="173A5E"/>
                 </a:solidFill>
@@ -2030,7 +2148,7 @@
               </a:rPr>
               <a:t> 70%</a:t>
             </a:r>
-            <a:endParaRPr lang="ru-RU" sz="590"/>
+            <a:endParaRPr lang="ru-RU" sz="570"/>
           </a:p>
         </p:txBody>
       </p:sp>
@@ -2042,8 +2160,8 @@
         </p:nvSpPr>
         <p:spPr>
           <a:xfrm>
-            <a:off x="5112000" y="8172000"/>
-            <a:ext cx="2052000" cy="90000"/>
+            <a:off x="5112000" y="8092800"/>
+            <a:ext cx="2052000" cy="86400"/>
           </a:xfrm>
           <a:prstGeom prst="rect">
             <a:avLst/>
@@ -2064,8 +2182,8 @@
         </p:nvSpPr>
         <p:spPr>
           <a:xfrm>
-            <a:off x="5112000" y="8172000"/>
-            <a:ext cx="1436400" cy="90000"/>
+            <a:off x="5112000" y="8092800"/>
+            <a:ext cx="1436400" cy="86400"/>
           </a:xfrm>
           <a:prstGeom prst="rect">
             <a:avLst/>
@@ -2086,8 +2204,8 @@
         </p:nvSpPr>
         <p:spPr>
           <a:xfrm>
-            <a:off x="5112000" y="8676000"/>
-            <a:ext cx="2052000" cy="1152000"/>
+            <a:off x="5112000" y="8568000"/>
+            <a:ext cx="2052000" cy="1224000"/>
           </a:xfrm>
           <a:prstGeom prst="rect">
             <a:avLst/>
@@ -2287,7 +2405,7 @@
             <a:endParaRPr lang="ru-RU" sz="640"/>
           </a:p>
           <a:p>
-            <a:pPr marL="135000" indent="-70000">
+            <a:pPr marL="125000" indent="-65000">
               <a:buChar char="•"/>
             </a:pPr>
             <a:r>
@@ -2303,7 +2421,7 @@
             <a:endParaRPr lang="ru-RU" sz="590"/>
           </a:p>
           <a:p>
-            <a:pPr marL="135000" indent="-70000">
+            <a:pPr marL="125000" indent="-65000">
               <a:buChar char="•"/>
             </a:pPr>
             <a:r>
@@ -2319,7 +2437,7 @@
             <a:endParaRPr lang="ru-RU" sz="590"/>
           </a:p>
           <a:p>
-            <a:pPr marL="135000" indent="-70000">
+            <a:pPr marL="125000" indent="-65000">
               <a:buChar char="•"/>
             </a:pPr>
             <a:r>
@@ -2335,7 +2453,7 @@
             <a:endParaRPr lang="ru-RU" sz="590"/>
           </a:p>
           <a:p>
-            <a:pPr marL="135000" indent="-70000">
+            <a:pPr marL="125000" indent="-65000">
               <a:buChar char="•"/>
             </a:pPr>
             <a:r>
@@ -2351,7 +2469,7 @@
             <a:endParaRPr lang="ru-RU" sz="590"/>
           </a:p>
           <a:p>
-            <a:pPr marL="135000" indent="-70000">
+            <a:pPr marL="125000" indent="-65000">
               <a:buChar char="•"/>
             </a:pPr>
             <a:r>
@@ -2423,7 +2541,7 @@
             <a:endParaRPr lang="ru-RU" sz="640"/>
           </a:p>
           <a:p>
-            <a:pPr marL="135000" indent="-70000">
+            <a:pPr marL="125000" indent="-65000">
               <a:buChar char="•"/>
             </a:pPr>
             <a:r>
@@ -2439,7 +2557,7 @@
             <a:endParaRPr lang="ru-RU" sz="590"/>
           </a:p>
           <a:p>
-            <a:pPr marL="135000" indent="-70000">
+            <a:pPr marL="125000" indent="-65000">
               <a:buChar char="•"/>
             </a:pPr>
             <a:r>
@@ -2455,7 +2573,7 @@
             <a:endParaRPr lang="ru-RU" sz="590"/>
           </a:p>
           <a:p>
-            <a:pPr marL="135000" indent="-70000">
+            <a:pPr marL="125000" indent="-65000">
               <a:buChar char="•"/>
             </a:pPr>
             <a:r>
@@ -2471,7 +2589,7 @@
             <a:endParaRPr lang="ru-RU" sz="590"/>
           </a:p>
           <a:p>
-            <a:pPr marL="135000" indent="-70000">
+            <a:pPr marL="125000" indent="-65000">
               <a:buChar char="•"/>
             </a:pPr>
             <a:r>
@@ -2487,7 +2605,7 @@
             <a:endParaRPr lang="ru-RU" sz="590"/>
           </a:p>
           <a:p>
-            <a:pPr marL="135000" indent="-70000">
+            <a:pPr marL="125000" indent="-65000">
               <a:buChar char="•"/>
             </a:pPr>
             <a:r>
@@ -2503,7 +2621,7 @@
             <a:endParaRPr lang="ru-RU" sz="590"/>
           </a:p>
           <a:p>
-            <a:pPr marL="135000" indent="-70000">
+            <a:pPr marL="125000" indent="-65000">
               <a:buChar char="•"/>
             </a:pPr>
             <a:r>
@@ -2575,7 +2693,7 @@
             <a:endParaRPr lang="ru-RU" sz="640"/>
           </a:p>
           <a:p>
-            <a:pPr marL="135000" indent="-70000">
+            <a:pPr marL="125000" indent="-65000">
               <a:buChar char="•"/>
             </a:pPr>
             <a:r>
@@ -2591,7 +2709,7 @@
             <a:endParaRPr lang="ru-RU" sz="590"/>
           </a:p>
           <a:p>
-            <a:pPr marL="135000" indent="-70000">
+            <a:pPr marL="125000" indent="-65000">
               <a:buChar char="•"/>
             </a:pPr>
             <a:r>
@@ -2607,7 +2725,7 @@
             <a:endParaRPr lang="ru-RU" sz="590"/>
           </a:p>
           <a:p>
-            <a:pPr marL="135000" indent="-70000">
+            <a:pPr marL="125000" indent="-65000">
               <a:buChar char="•"/>
             </a:pPr>
             <a:r>
@@ -2623,7 +2741,7 @@
             <a:endParaRPr lang="ru-RU" sz="590"/>
           </a:p>
           <a:p>
-            <a:pPr marL="135000" indent="-70000">
+            <a:pPr marL="125000" indent="-65000">
               <a:buChar char="•"/>
             </a:pPr>
             <a:r>
@@ -2639,7 +2757,7 @@
             <a:endParaRPr lang="ru-RU" sz="590"/>
           </a:p>
           <a:p>
-            <a:pPr marL="135000" indent="-70000">
+            <a:pPr marL="125000" indent="-65000">
               <a:buChar char="•"/>
             </a:pPr>
             <a:r>

</xml_diff>

<commit_message>
Add strategic banking framing
Co-authored-by: yanatimofeeva2511 <yanatimofeeva2511@users.noreply.github.com>
</commit_message>
<xml_diff>
--- a/resume_clevel_fintech_ru_editable.pptx
+++ b/resume_clevel_fintech_ru_editable.pptx
@@ -254,7 +254,7 @@
                 <a:latin typeface="Arial"/>
                 <a:cs typeface="Arial"/>
               </a:rPr>
-              <a:t>C-level лидер | розничный банкинг, финтех и платежная инфраструктура</a:t>
+              <a:t>C-level лидер | розничный банкинг, финтех и трансформация клиентских платформ</a:t>
             </a:r>
             <a:endParaRPr lang="ru-RU" sz="980"/>
           </a:p>
@@ -270,7 +270,7 @@
                 <a:latin typeface="Arial"/>
                 <a:cs typeface="Arial"/>
               </a:rPr>
-              <a:t>BUILD / TRANSFORM / LEAD: запуск бизнес-направлений, трансформация продуктовых моделей, управление крупными программами изменений</a:t>
+              <a:t>Стратегия роста · operating model · продуктовый P&amp;L · regulated delivery · mission-critical banking infrastructure</a:t>
             </a:r>
             <a:endParaRPr lang="ru-RU" sz="720"/>
           </a:p>
@@ -372,7 +372,7 @@
                 <a:latin typeface="Arial"/>
                 <a:cs typeface="Arial"/>
               </a:rPr>
-              <a:t>Бизнес-лидер с 20+ годами опыта в крупнейших финансовых организациях России. Отвечаю за розничные направления, запуск новых продуктов, клиентский рост, партнерскую дистрибуцию, технологические миграции и федеральные проекты на стыке бизнеса, IT, операций, маркетинга, продаж и регуляторного контура.</a:t>
+              <a:t>Бизнес-лидер с 20+ годами опыта. Работаю не только с отдельными продуктами, а с банковскими бизнес-системами: клиентские платформы, P&amp;L, продуктовая архитектура, каналы, партнерская экосистема, платежная инфраструктура и регуляторный контур.</a:t>
             </a:r>
             <a:endParaRPr lang="ru-RU" sz="660"/>
           </a:p>
@@ -388,7 +388,7 @@
                 <a:latin typeface="Arial"/>
                 <a:cs typeface="Arial"/>
               </a:rPr>
-              <a:t>Моя ценность - быстро соединить стратегию, экономику продукта, операционную модель и delivery в измеримый результат.</a:t>
+              <a:t>Моя ценность - соединять стратегическое видение и банковский execution: бизнес-модель, operating model и измеримый результат без потери клиентского опыта.</a:t>
             </a:r>
             <a:endParaRPr lang="ru-RU" sz="660"/>
           </a:p>
@@ -510,7 +510,7 @@
                 <a:latin typeface="Arial"/>
                 <a:cs typeface="Arial"/>
               </a:rPr>
-              <a:t>Запуск направления с нуля: рынок, бизнес-модель, продуктовый ряд, каналы продаж, партнерства и экономика окупаемости.</a:t>
+              <a:t>Создаю самостоятельную бизнес-систему: рынок, сегменты, P&amp;L-логику, продуктовый портфель, каналы, партнерства и окупаемость.</a:t>
             </a:r>
             <a:endParaRPr lang="ru-RU" sz="545"/>
           </a:p>
@@ -898,7 +898,7 @@
                 <a:latin typeface="Arial"/>
                 <a:cs typeface="Arial"/>
               </a:rPr>
-              <a:t>Пересборка стратегии, экономики привлечения, продукта, дистрибуции, IT и операционной модели в работающем контуре банка.</a:t>
+              <a:t>Перевожу действующий банковский портфель в новую модель роста: стратегия, экономика привлечения, продуктовая архитектура, IT-roadmap и KPI.</a:t>
             </a:r>
             <a:endParaRPr lang="ru-RU" sz="545"/>
           </a:p>
@@ -1188,7 +1188,7 @@
                 <a:latin typeface="Arial"/>
                 <a:cs typeface="Arial"/>
               </a:rPr>
-              <a:t>Синхронизация бизнеса, IT, операций, продаж, маркетинга, регулятора и внешних партнеров вокруг результата.</a:t>
+              <a:t>Веду mission-critical программы в регулируемой среде: бизнес, IT, операции, регулятор и партнеры вокруг непрерывности клиентского опыта.</a:t>
             </a:r>
             <a:endParaRPr lang="ru-RU" sz="545"/>
           </a:p>

</xml_diff>